<commit_message>
Update Prosperity-Economics-And-Right-Use study and companion deck: reorder Section 3, expand canon & modern economic coverage, and develop multi-level AI agent infrastructure in Section 8
</commit_message>
<xml_diff>
--- a/Studies/Prosperity-Economics-And-Right-Use/Prosperity-Economics-And-Right-Use-Madhyasth-Darshan.pptx
+++ b/Studies/Prosperity-Economics-And-Right-Use/Prosperity-Economics-And-Right-Use-Madhyasth-Darshan.pptx
@@ -21,8 +21,8 @@
     <p:sldId id="269" r:id="rId21"/>
     <p:sldId id="270" r:id="rId22"/>
     <p:sldId id="271" r:id="rId23"/>
+    <p:sldId id="273" r:id="rId25"/>
     <p:sldId id="272" r:id="rId24"/>
-    <p:sldId id="273" r:id="rId25"/>
     <p:sldId id="274" r:id="rId26"/>
     <p:sldId id="275" r:id="rId27"/>
     <p:sldId id="276" r:id="rId28"/>
@@ -31,6 +31,8 @@
     <p:sldId id="279" r:id="rId31"/>
     <p:sldId id="280" r:id="rId32"/>
     <p:sldId id="281" r:id="rId33"/>
+    <p:sldId id="287" r:id="rId39"/>
+    <p:sldId id="288" r:id="rId40"/>
     <p:sldId id="282" r:id="rId34"/>
     <p:sldId id="283" r:id="rId35"/>
     <p:sldId id="284" r:id="rId36"/>
@@ -538,13 +540,13 @@
           <a:p/>
           <a:p>
             <a:r>
-              <a:t>The study's principal source is Avartansheel Arthshastra, Shri A. Nagraj's treatise on cyclical economics, read through the project's working English translation. It draws as well on Madhyasth Darshan, Jeevan Vidya, Samadhanatmak Bhautikvad, Karm Darshan, Janvad and Adhyatmvad, and it compares the darshan's account with economic theory, with Indian and Advaita teaching on desire, and with the sciences of satiation and natural limits.</a:t>
+              <a:t>The study's principal source is Avartansheel Arthshastra, Shri A. Nagraj's treatise on cyclical economics, read through the project's working English translation. It draws as well on Madhyasth Darshan, Jeevan Vidya, Samadhanatmak Bhautikvad, Karm Darshan, Janvad and Adhyatmvad, and it compares the darshan's account with classical, Marxian, marginalist, institutional, ecological and Gandhian economics, with Indian and Advaita teaching on desire, and with the sciences of satiation and natural limits.</a:t>
             </a:r>
           </a:p>
           <a:p/>
           <a:p>
             <a:r>
-              <a:t>The deck follows the study in five parts: balance in nature and in the body; the source of insatiability; cyclical economics; comparison; and what measurement and artificial intelligence can contribute, and what they must leave to people.</a:t>
+              <a:t>The deck follows the study in five parts: balance in nature and in the body; the source of insatiability and the genealogy of money and profit; cyclical economics; comparison with economic traditions and the sciences; and why intelligent systems and multi-level AI agents across the ten-tier order are needed to accelerate transition and keep the cycle in balance, while leaving normative judgement to people.</a:t>
             </a:r>
           </a:p>
         </p:txBody>
@@ -696,19 +698,19 @@
           <a:lstStyle/>
           <a:p>
             <a:r>
-              <a:t>Profit has always meant giving less and getting more, and prevailing economics has fixed no limit to how much less and how much more (AA p. 5). Madhyasth Darshan defines profit against labour: seeking more worth than the labour performed, obtaining a higher value in exchange for a lower one (MVD pp. 57, 66).</a:t>
+              <a:t>The treatise traces how exchange left usefulness behind. Early humans recognised natural resources, shared within the family, and bartered between communities. Seats of state and religion then imposed taxation to sustain non-producing rulers and retainers, and moved exchange from barter to metal coins and finally to paper currency. In that transition, neither unrestrained market economics nor state-regulated economics freed society from exploitation (AA pp. 1–8). Profit means giving less and getting more, and Madhyasth Darshan defines it against labour: seeking more worth than the labour performed (MVD pp. 57, 66).</a:t>
             </a:r>
           </a:p>
           <a:p/>
           <a:p>
             <a:r>
-              <a:t>Accumulation settles on money because money escapes the constraint that governs real goods. Metal became the symbol of objects and paper the symbol of metal, so that economics became the study of a symbol (AA pp. 5–6, 52). However much currency exists, it cannot replace grain for one person or quench one person's thirst (AA p. 6; JV pp. 151–152). The accumulation is only of money, which is symbolic value (MVD p. 182). Once objects are subject to currency, labour is subject to it too, and accumulated currency becomes the measure of a person's standing (AA p. 45). Changes in price over decades are changes in the symbol alone (AA pp. 52–53).</a:t>
+              <a:t>Accumulation settles on money because money escapes the decay that governs real goods. Metal became the symbol of objects and paper the symbol of metal (AA pp. 5–6, 52). Paper currency carries three allurements: it is easily carried from place to place, easily hidden, and easily received and paid (AA p. 45). Once currency becomes the measure of standing, trade expands into seven kinds: strength, learning, knowledge, position, beauty, objects, and deceptive speech are all bought and sold (AA pp. 45–46).</a:t>
             </a:r>
           </a:p>
           <a:p/>
           <a:p>
             <a:r>
-              <a:t>Two consequences follow. Artificial scarcity becomes a principal technique for gaining profit. And because accumulation has no satiation point, it cannot be accessible to all, since the earth is limited (AA p. 52). Those who produce are unable to accumulate, and the producer of objects has generally remained poor (AA pp. 7, 75).</a:t>
+              <a:t>Artificial scarcity becomes a principal technique for profit, and because accumulation has no satiation point on a limited earth, it cannot be accessible to all (AA p. 52). Those who produce cannot accumulate, and those who accumulate become slack in production (AA pp. 7, 75).</a:t>
             </a:r>
           </a:p>
         </p:txBody>
@@ -860,7 +862,7 @@
           <a:lstStyle/>
           <a:p>
             <a:r>
-              <a:t>Cyclical economics is the right use, security and prosperity of resources, artha, in the form of body, mind and wealth (AA p. 25). The means of a human being are only body, mind and wealth (MVD p. 243). When the mind works through the body by a realisation-based method, labour applied with skill and proficiency to natural abundance produces objects that carry usefulness value and aesthetic value. These objects are wealth, dhan. Wealth is only the produced object, not money (AA pp. 25, 105).</a:t>
+              <a:t>Cyclical economics is the right use, security and prosperity of resources, artha, in the form of body, mind and wealth (AA p. 25). The means of a human being are only body, mind and wealth (MVD p. 243). In doing so, the five powers of jeevan project into human living through bodily skill and proficiency, and reflect back in mutual evaluation across family and society (AA pp. 18–19, 48–50). Labour applied with skill and proficiency to natural abundance produces objects that carry usefulness value and aesthetic value. These objects are wealth, dhan. Wealth is only the produced object, not money (AA pp. 25, 105).</a:t>
             </a:r>
           </a:p>
           <a:p/>
@@ -1264,19 +1266,19 @@
           <a:lstStyle/>
           <a:p>
             <a:r>
-              <a:t>Use, right use and purposeful use name three levels at which resources serve human purposes. Use is the utilisation of body, mind and wealth in the nourishment and protection of the body and in the motion of society. Right use is their utilisation in orderliness and in the motion of undivided society. Purposeful use is their utilisation in evidencing, from generation to generation, knowledge of coexistence, of jeevan, and of humane conduct (AA pp. 72, 94; MVD p. 56). In terms of scale, production is used within the family, rightly used in society, and put to purpose in the universal order (KD p. 116). The treatise pairs use with justice, right use with resolution, and purposeful use with authenticity (AA p. 116).</a:t>
+              <a:t>Before objects can be valued in exchange, the treatise defines the three levels at which resources serve human purposes: use, right use and purposeful use. Use is the utilisation of body, mind and wealth in the nourishment and protection of the body and in the motion of society. Right use is their utilisation in orderliness and in the motion of undivided society. Purposeful use is their utilisation in evidencing, from generation to generation, knowledge of coexistence, of jeevan, and of humane conduct (AA pp. 72, 94; MVD p. 56). In scale, production is used within the family, rightly used in society, and put to purpose in the universal order (KD p. 116). The treatise pairs use with justice, right use with resolution, and purposeful use with authenticity (AA p. 116).</a:t>
             </a:r>
           </a:p>
           <a:p/>
           <a:p>
             <a:r>
-              <a:t>Values are ordered by what they serve. In offering and surrender, object values are dedicated to civic values, civic values to established values, established values to human values, and human values to jeevan values, happiness, peace, contentment and bliss (AA p. 92).</a:t>
+              <a:t>This places economics within the darshan's hierarchy of thirty values across five categories: two object values (usefulness and artistic value), nine civic values, nine established values, one human value (steadfastness, courage, generosity, kindness, grace and compassion), and four jeevan values (happiness, peace, contentment and bliss), alongside five obligatory allegiances (AA pp. 20–24, 92).</a:t>
             </a:r>
           </a:p>
           <a:p/>
           <a:p>
             <a:r>
-              <a:t>Karm Darshan ranks wealth by the same logic. Wealth placed in the service of liberation, dharma or the fulfilment of desire is ranked high; those purposes placed in the service of wealth are ranked low; wealth sought for its own sake falls in between (KD p. 4).</a:t>
+              <a:t>Karm Darshan ranks wealth by the same logic: wealth placed in the service of liberation, dharma or the fulfilment of desire ranks high; higher purposes made to serve wealth rank low (KD p. 4).</a:t>
             </a:r>
           </a:p>
         </p:txBody>
@@ -1346,19 +1348,19 @@
           <a:lstStyle/>
           <a:p>
             <a:r>
-              <a:t>The ethics of the economy are stated in terms of character. Humane character consists of righteous wealth, marital faithfulness, and kindness in work and behaviour (AA p. 54). Righteous wealth, svadhan, is wealth received as the remuneration of one's own labour, as a gift, or as an award for a special display of art, technique or scholarship (AA p. 140; AVD p. 170). Its opposite, ill-gotten wealth, is obtained through exploitation and hypocrisy, and the darshan counts it, with adultery and hurting others, as crime (MVD pp. 59, 263).</a:t>
+              <a:t>The ethics of the economy are stated in terms of character. Humane character consists of righteous wealth, marital faithfulness, and kindness in work and behaviour (AA p. 54). Righteous wealth, svadhan, is wealth received as the remuneration of one's own labour, as a gift, or as an award for a special display of art, technique or scholarship (AA p. 140; AVD p. 170). Its opposite, ill-gotten wealth obtained through exploitation and hypocrisy, is counted as crime (MVD pp. 59, 263), and moral accountability extends across doing, commissioning and consenting in body, speech and mind (KD pp. 1–2, 117; SB pp. 207, 258).</a:t>
             </a:r>
           </a:p>
           <a:p/>
           <a:p>
             <a:r>
-              <a:t>The darshan does not ask people to renounce wealth. The motives for progeny, wealth and reputation are humane propensities (MVD pp. 59, 137). What changes is their orientation: people, wealth and reputation are assets of the family and of the undivided society (MVD p. 221), and wealth finds its satisfaction through generosity, the happy offering of body, mind and wealth for the awakening, health and prosperity of others (MVD pp. 211, 339; AA p. 22).</a:t>
+              <a:t>The darshan distinguishes animal instincts from the three humane motives: progeny (putreshana), wealth (vitteshana), and public welfare or reputation (lokeshana), with public welfare highest (MVD pp. 318, 320). It also contrasts five kinds of human living: servile, voluptuary and glorious humans driven by sensory interest, the virtuous human on the path of awakening, and the capable human living by values (AA pp. 101–102).</a:t>
             </a:r>
           </a:p>
           <a:p/>
           <a:p>
             <a:r>
-              <a:t>Within the family goods are shared; between families they are exchanged (AA p. 1). Those who cannot produce are provided for through kindness, including help to the helpless, the distressed, the sick and those struck by calamity (AA pp. 23–24, 140). Once a family is resolved and prosperous, the propensity of benevolence answers where its surplus goes (KD p. 116).</a:t>
+              <a:t>Within the family goods are shared; between families they are exchanged (AA p. 1). Those who cannot produce are cared for through kindness, and surplus flows into generosity and benevolence (MVD p. 339; KD p. 116).</a:t>
             </a:r>
           </a:p>
         </p:txBody>
@@ -1510,19 +1512,19 @@
           <a:lstStyle/>
           <a:p>
             <a:r>
-              <a:t>The provision cycle is nested within the cycles of nature, and its production must keep them intact. Natural assets, minerals and vegetation, are to be used in proportion to their production; their production is not to be obstructed; and human beings are to become helpful in it. Without keeping nature prosperous, the human being cannot be prosperous (AA pp. 142, 146; KD p. 7).</a:t>
+              <a:t>The provision cycle is nested within the cycles of nature, and the treatise draws a sharp line between production (utpadan) and extraction (paddat-prapti). Production is inherently cyclical and leaves natural equilibrium undisturbed; drawing coal and mineral oil from the earth is mere extraction, not production (AA p. 78). Natural assets, minerals and vegetation, are to be used in proportion to their regeneration; their production is not to be obstructed; and human beings are to become helpful in it. Without keeping nature prosperous, the human being cannot be prosperous (AA pp. 142, 146; KD p. 7).</a:t>
             </a:r>
           </a:p>
           <a:p/>
           <a:p>
             <a:r>
-              <a:t>Madhyasth Darshan sets out the same rule as lawful and unlawful conduct. Spending minerals and forests in proportion to their regeneration, being complementary in the balance of natural abundance, and maintaining circularity are lawful; spending beyond regeneration, disproportionate extraction, and exploiting non-renewable materials are not (MVD p. 263). Its state policy names production security as maintained through the principle of maintaining nature's balance (MVD p. 264).</a:t>
+              <a:t>Madhyasth Darshan sets out the same rule as lawful and unlawful conduct: spending minerals and forests in proportion to regeneration and maintaining circularity are lawful; spending beyond regeneration and exploiting non-renewables are not (MVD p. 263).</a:t>
             </a:r>
           </a:p>
           <a:p/>
           <a:p>
             <a:r>
-              <a:t>The treatise is specific about energy. Mineral oil, coal and radioactive fuels are the most harmful; flowing and falling water, wind, solar heat and gas from dung and refuse are pollution-free. Vegetable oil from roadside trees forms a closed cycle: tree, seed, oil, smoke taken up by trees, and seed again (AA pp. 31–33, 106–107). Determining the land of a village also determines how many families it can support with prosperity (AA p. 92).</a:t>
+              <a:t>Flowing and falling water, wind, solar heat, biogas from dung and refuse, and vegetable oil from roadside trees provide cyclical, pollution-free energy (AA pp. 31–33, 106–107). Determining the land of a village also determines how many families it can support with prosperity (AA p. 92).</a:t>
             </a:r>
           </a:p>
         </p:txBody>
@@ -1592,19 +1594,19 @@
           <a:lstStyle/>
           <a:p>
             <a:r>
-              <a:t>Machine production is not contrary to economics (AA p. 47). Technique multiplies the speed of whatever humans do. Until people can live as members of society and of an orderly system, that multiplication increases the speed of problems and the number of crimes; only with such understanding do machines become available to every family as prosperity (SB p. 267).</a:t>
+              <a:t>In the cyclical economy, every villager is trained across multiple occupations, planned jointly by the education, production and exchange-reserve committees, so that no one suffers occupational fear (AA pp. 64–65, 131). Research and dissemination are inseparable: just as one grain multiplies into hundreds only when sown in the field, knowledge and skill reach fruition through dissemination, not through patent monopolies that sell research while concealing the method (AA pp. 56–58; JV pp. 88–89).</a:t>
             </a:r>
           </a:p>
           <a:p/>
           <a:p>
             <a:r>
-              <a:t>The treatise names two drives that kept technique from serving this purpose: the preoccupation with making all production automatic, and the centralisation of industry. Both rest on capital investment and on buying labour power. Automatic production reduced the number of people engaged in production, so that of two equally educated people one finds work and the other feels useless (AA p. 107). Janvad observes that a working mindset has given way to a managing mindset (JVD p. 35).</a:t>
+              <a:t>Machine production is not contrary to economics (AA p. 47), but technique multiplies the speed of whatever humans do, problems included (SB p. 267). Preoccupation with full automation and centralised industry, resting on capital and bought labour power, displaced producers and replaced a working mindset with a managing mindset (AA p. 107; JVD p. 35).</a:t>
             </a:r>
           </a:p>
           <a:p/>
           <a:p>
             <a:r>
-              <a:t>Against this, every person is to be engaged in production according to capacity, receptivity and ability (MVD p. 265). When every member of every family takes part in production, poverty, deprivation and the trap of accumulation and comfort are left behind together (JVD p. 216). Means rightly used increase from generation to generation while the time required decreases (AA p. 118). The criterion is twofold: raise the usefulness labour establishes and reduce its time, while keeping every person a producer.</a:t>
+              <a:t>Against this, every person is to be engaged in production according to capacity, receptivity and ability (MVD p. 265). Means rightly used increase the usefulness labour establishes and reduce the time production takes across generations, while keeping every member of every family a producer (AA p. 118; JVD p. 216).</a:t>
             </a:r>
           </a:p>
         </p:txBody>
@@ -1674,19 +1676,19 @@
           <a:lstStyle/>
           <a:p>
             <a:r>
-              <a:t>Economics in isolation has no definition or standing (AA p. 117). Cyclical economics is one part of self-governance, which means accessibility to justice, to production and to exchange, sustained by education-sanskar and health-restraint (AA p. 63). The five dimensions are drawn as a circle joined to a pentagon: education-sanskar to understanding, health-restraint to expression consistent with science and wisdom, justice-security to honesty, production to prosperity, and exchange-reserve to balance (AA p. 112).</a:t>
+              <a:t>Economics in isolation has no definition or standing (AA p. 117). Self-governance rests on authority (the strength of understanding), identity (evidencing it in living), and independence (unconstrained participation in family and universal orderliness; AA pp. 104–105). The five dimensions link education-sanskar to understanding, health-restraint to balanced expression, justice-security to honesty, production to prosperity, and exchange-reserve to balance (AA p. 112).</a:t>
             </a:r>
           </a:p>
           <a:p/>
           <a:p>
             <a:r>
-              <a:t>The village of about a hundred families is the first unit. Ten families form a family cluster, ten clusters a village council, and so on through ten tiers to a world family council, each with five committees (AA pp. 27–28). Production scale rises with the tier: cottage industry in the village, large industry at the region and world (AA pp. 29–30, 115).</a:t>
+              <a:t>Ten families form a family cluster, ten clusters a hundred-family village with nine branches of production (agriculture, go-shala, forestry, cottage crafts and related work; AA pp. 133–136), and ten tiers reach the world family council. Representatives are selected by mutual recognition with zero election expenditure and serve part-time while continuing production, keeping at least eighty percent of society prosperous in production and twenty percent in coordination (AA pp. 27–30, 110, 127; MVD p. 259).</a:t>
             </a:r>
           </a:p>
           <a:p/>
           <a:p>
             <a:r>
-              <a:t>The darshan names three policies: protection is state policy, right use is moral policy, and production beyond the family's needs is economic policy (KD p. 67). Its state policy sets out six securities, including exchange security through the evaluation of human labour, and exchange between nations too is to be free of profit and loss, based on object value and labour value (MVD pp. 264–268). Today, countries with large foreign exchange reserves are able to exploit others (JVD p. 32).</a:t>
+              <a:t>Moral policy is the right use of resources, economic policy is production beyond family need, and state policy is protection across the six securities, with moral policy primary (KD pp. 14, 67; MVD pp. 264–271).</a:t>
             </a:r>
           </a:p>
         </p:txBody>
@@ -1838,19 +1840,19 @@
           <a:lstStyle/>
           <a:p>
             <a:r>
-              <a:t>The traditions disagree most sharply on the source of insatiable want. Neoclassical theory takes non-satiation as given and does not ask its source. Aristotle distinguished household management, limited by need, from wealth-getting for its own sake, which has no limit; Marx contrasted selling in order to buy, which ends in use, with buying in order to sell for more, whose movement is limitless. Keynes distinguished absolute needs, which can be met, from relative needs, which may be insatiable; Veblen and Hirsch located insatiability in status and positional goods. Ecological economists explain continued growth through debt, competition and employment. Kumarappa contrasted an economy of transience with an economy of permanence. The Gita and Advaita trace desire to ignorance of the Self.</a:t>
+              <a:t>The traditions disagree most sharply on the source of insatiable want and how labour and need are valued. Since Jevons, Menger and Walras (1871), marginalist and neoclassical theory abandoned classical labour value for subjective marginal utility and took non-satiation and scarcity as given (Robbins 1932). Aristotle and Marx located limitlessness in money-making and the circuit of capital; in the Critique of the Gotha Programme (1875), Marx separated post-capitalist distribution into a first stage of labour-time certificates and a distant stage of need-based sharing, whereas the darshan pairs family need-sharing with inter-family labour-value exchange simultaneously (AA pp. 1, 119–120).</a:t>
             </a:r>
           </a:p>
           <a:p/>
           <a:p>
             <a:r>
-              <a:t>The darshan places the source in the joint form: a jeevan whose higher activities lack understanding, whose discontent is read as a shortage of objects, and whose capacity for selection and taste is left without regulation. On this account the other explanations describe real consequences of the same error.</a:t>
+              <a:t>Keynes, Veblen and Hirsch located insatiability in relative and positional goods; Polanyi (1944) showed how treating land, labour and money as fictitious commodities disembeds the economy from society; ecological economists point to debt and throughput limits; Kumarappa and Schumacher ground permanence in village production and moral restraint; and Advaita traces desire to ignorance of the Self.</a:t>
             </a:r>
           </a:p>
           <a:p/>
           <a:p>
             <a:r>
-              <a:t>On what closes the cycle, ecological economics closes material loops, and Daly's steady state addresses throughput. Only the darshan, Gandhian economics and in part Keynes make the definiteness of need a condition of the economy's structure.</a:t>
+              <a:t>The darshan places the root in the joint form: a jeevan whose unexpressed higher activities read their discontent as a shortage of objects. Only the darshan, Gandhian economics and in part Keynes make the definiteness of need a structural condition of the economy.</a:t>
             </a:r>
           </a:p>
         </p:txBody>
@@ -1920,19 +1922,13 @@
           <a:lstStyle/>
           <a:p>
             <a:r>
-              <a:t>The study does not treat economic theory as an adversary. Six lessons bear directly on cyclical economics.</a:t>
+              <a:t>Six lessons from economic theory bear directly on cyclical economics.</a:t>
             </a:r>
           </a:p>
           <a:p/>
           <a:p>
             <a:r>
-              <a:t>First, coordination beyond the village needs information. Hayek argued that prices communicate knowledge dispersed among many people, and the treatise's own transitional use of market rates shows that a labour-based system must obtain that knowledge in another form. Second, prosperity and production security can be evidenced only if they are measured; national accounting, input–output analysis, material-flow accounting and life-cycle assessment provide methods. Third, Elinor Ostrom showed that communities can govern shared resources, which bears on the village's jurisdiction over forests, water and minerals. Fourth, theories of human need, from Max-Neef, Doyal and Gough, can sharpen the family's assessment of need. Fifth, money today is mostly credit created by banks when they lend; the darshan's critique of symbolic value can address that system directly. Sixth, Leontief's input–output tables, and Cockshott and Cottrell's work on labour-time accounting, show how the labour embodied in complex goods can be computed.</a:t>
-            </a:r>
-          </a:p>
-          <a:p/>
-          <a:p>
-            <a:r>
-              <a:t>Neoclassical economics coordinates without a stopping point. Its tools can serve a cyclical economy once that economy supplies the criteria the discipline leaves out.</a:t>
+              <a:t>First, coordination beyond the village needs active information processing: Hayek showed that market prices compress dispersed knowledge, so a non-price system must supply that coordination in another way. Second, prosperity and production security must be measured through national accounts, input–output tables, material-flow accounting and life-cycle assessment. Third, Elinor Ostrom's polycentric commons governance and Karl Polanyi's analysis of embeddedness and fictitious commodities show how land, labour and credit are kept within social bounds. Fourth, the need and capability frameworks of Max-Neef, Doyal and Gough, and Amartya Sen sharpen the family's assessment of need against adaptive preference. Fifth, modern money is credit created by commercial banks at interest (BoE 2014), while mutual-credit clearing networks such as Switzerland's WIR (Stodder 2009) demonstrate interest-free ledger clearing of the kind used by the village exchange-reserve. Sixth, Leontief's input–output analysis, Cockshott and Cottrell's labour-time calculation, and Ricardo's theory of differential rent (1817) show how embodied labour, capital depreciation, and unequal soil or mineral fertility can be separated and computed.</a:t>
             </a:r>
           </a:p>
         </p:txBody>
@@ -2002,19 +1998,19 @@
           <a:lstStyle/>
           <a:p>
             <a:r>
-              <a:t>The darshan joins two kinds of order in one sequence. Knowledge is law, law is regulation, and regulation is balance; balanced living is justice in humans; living within universal orderliness with justice is dharma; and realisation in coexistence is dharma and truth (MVD p. 173). Law, regulation and balance are already evident in the orders other than the human, which are bound by their own laws (AA p. 117). Justice, dharma and truth are the evaluations by which humans establish their own orderliness, and the treatise describes them as still under review in human tradition (AA p. 18).</a:t>
+              <a:t>The darshan joins two kinds of order in one sequence. Knowledge is law, law is regulation, and regulation is balance; balanced living is justice in humans; living within universal orderliness with justice is dharma; and realisation in coexistence is dharma and truth (MVD p. 173). Law, regulation and balance are already evident in the orders other than the human (AA p. 117). Justice, dharma and truth are the evaluations by which humans establish their own orderliness, and the treatise describes them as still under review in human tradition (AA p. 18).</a:t>
             </a:r>
           </a:p>
           <a:p/>
           <a:p>
             <a:r>
-              <a:t>This suggests a division of labour. Where a relation can be stated as a quantity, a rate or a rule, it can be measured, recorded and in part handled by an instrument. Where a question concerns the fulfilment of a relationship, the purpose of a choice, or its accord with coexistence, it belongs to human evaluation. The treatise already prescribes surveys and committee evaluations, and expects computers in the exchange-reserve and a computer system linking committees from village to world (AA pp. 122–125, 132, 138).</a:t>
+              <a:t>This sets the division of labour for any instrument. Where a relation is governed by law, regulation or balance and can be stated as a quantity, rate, constraint or rule, it can be measured, modelled and partly handled by an instrument. Where a question concerns the fulfilment of a relationship, the purpose of a choice, or its accord with coexistence, it belongs to human evaluation.</a:t>
             </a:r>
           </a:p>
           <a:p/>
           <a:p>
             <a:r>
-              <a:t>Karm Darshan gives the rule for trusting instruments. Every instrument embodies the mentality of those who plan it and falls short of the purpose it was planned for; trust and use should stay below that purpose, and every signal must still be read by a human being (KD p. 139).</a:t>
+              <a:t>Every instrument is conceived, planned and produced by humans, embodies their mentality, and falls short of its purpose: trust and use must stay below that purpose, and every signal must be read by a human being (KD p. 139). Present AI systems belong to the material order as insentient instruments, yantra, that either amplify delusion or, directed by humane criteria, make the basis of decisions visible.</a:t>
             </a:r>
           </a:p>
         </p:txBody>
@@ -2084,19 +2080,19 @@
           <a:lstStyle/>
           <a:p>
             <a:r>
-              <a:t>Each condition of the cycle can fail in a recognisable way, and most failures leave traces in records long before they become crises. The study pairs each condition with what can be recorded, the early signal of failure, and the question the signal raises for people.</a:t>
+              <a:t>Each condition of the cycle can fail in a recognisable way, and most failures leave traces in records long before they become crises. Within the multi-level architecture of §8.3, the Family, Committee and Regional AI Agents watch these indicators continuously and route early warnings to the responsible human unit.</a:t>
             </a:r>
           </a:p>
           <a:p/>
           <a:p>
             <a:r>
-              <a:t>Need is definite: the signal is use rising faster than the family's assessed need, and the question is whether the assessment is true to the family's need and fair to each member. Labour receives its value: the signal is producers receiving less than the labour value of what they make, or a widening gap between producer and consumer, and the question is whether the fruit of this labour is being exploited. Exchange follows labour value: the signal is ratios drifting and margins appearing between villages. Everyone takes part in production: the signal is people displaced and skills left idle. Goods are used, not hoarded: the signal is stock ageing in store and balances accumulating. Natural assets are used in proportion to their production: the signal is drawdown, falling fertility, soils turning acidic or saline.</a:t>
+              <a:t>Need is definite: the Family Agent flags use rising faster than the family's assessed need, returning the question of whether the assessment is true and fair. Labour receives its value: the Production and Exchange-Reserve Agents flag producers receiving less than labour value or a widening producer–consumer gap. Exchange follows labour value: regional agents flag drifting ratios or unauthorised margins. Everyone takes part in production: committee agents flag displaced workers or idle skills and alert the Education-Sanskar Agent to plan training. Goods are used, not hoarded: agents flag ageing stock and idle balances. Natural assets are used in proportion to regeneration: agents flag drawdown or soil acidity and salinity.</a:t>
             </a:r>
           </a:p>
           <a:p/>
           <a:p>
             <a:r>
-              <a:t>The table in the study also covers cyclical energy, village autonomy, and education and health. In every row, the instrument's work ends at the question; the answer belongs to people.</a:t>
+              <a:t>In every row, the agent's work ends by presenting the causal trace and the question to the family, committee or council responsible; the decision belongs to people.</a:t>
             </a:r>
           </a:p>
         </p:txBody>
@@ -2166,19 +2162,19 @@
           <a:lstStyle/>
           <a:p>
             <a:r>
-              <a:t>The darshan's valuation of labour needs records: the pace of work in each activity, the time and means each product requires, the quantities producers achieve under different conditions, and the remuneration they actually receive (AA pp. 66, 119, 145). Within a village these can be kept by hand. Between villages and regions, and for products assembled from many inputs, they become a large accounting task, and this is where computing systems help most directly.</a:t>
+              <a:t>The darshan's valuation of labour needs records: the pace of work in each activity, the time and means each product requires, the quantities producers achieve under different conditions, and the remuneration they actually receive (AA pp. 66, 119, 145). Within a single village for wheat, these can be kept by hand. Across villages, districts and tiers, and for industrial goods assembled from many inputs, the connected Production and Exchange-Reserve Agents of §8.3 perform the computation.</a:t>
             </a:r>
           </a:p>
           <a:p/>
           <a:p>
             <a:r>
-              <a:t>A system can keep labour records for each kind of product and compute a common value of labour from the range of yields across many villages, as the treatise does for wheat within one village (AA p. 66). It can compute the labour embodied in complex goods by tracing inputs back through the chain of production, using input–output methods from economics. During the transition it can keep prices and labour values side by side, so the second and third stages have the figures they need (AA pp. 142–143). It can show each producer what their labour established and what they received, and help plan training for the work a village needs (AA p. 131).</a:t>
+              <a:t>The agents compute common labour values across villages, updating them as generational means reduce the labour required per unit (AA pp. 66, 118, 145). They trace embodied labour through multi-stage input–output tables (Leontief 1936), including tool and building depreciation without charging interest. Across regions with unequal soil fertility, rainfall or mineral access, they separate natural endowment (Ricardo 1817) from human effort so midpoint valuation does not penalise less fertile villages. During the transition they maintain currency prices and labour values side by side for Stages 2 and 3 (AA pp. 142–143).</a:t>
             </a:r>
           </a:p>
           <a:p/>
           <a:p>
             <a:r>
-              <a:t>The method of valuation remains a human decision: the village council decides how values are set, and the committees fix the quantity, quality and value of labour (AA pp. 67, 143). Inside the family, contributions are not weighed at all.</a:t>
+              <a:t>The method of valuation remains a human decision: the village council sets the consolidation method, and the production and exchange-reserve committees fix the quantity, quality and value of labour (AA pp. 67, 143). Inside the family, nothing is weighed.</a:t>
             </a:r>
           </a:p>
         </p:txBody>
@@ -2248,19 +2244,19 @@
           <a:lstStyle/>
           <a:p>
             <a:r>
-              <a:t>To keep the cycle in balance, a system can maintain the village survey as a living record, track stock and its age, compare extraction with regeneration for each natural asset, and estimate from the land and water how many families a village can support with prosperity (AA p. 92). Where a rule has been settled by the people concerned, such as the share of a forest that may be cut in a year, it can apply the rule and report what it did. Across tiers it can show a district the balance of production and need, plan which village supplies what another lacks, and keep exchange between regions at labour value (AA p. 72; MVD p. 268).</a:t>
+              <a:t>Across the ten tiers, the agent network keeps the cycle in balance and lowers the barrier to transition. When a new cluster of families or villages begins transitioning inside today's market economy, pre-configured agents immediately connect its exchange-reserve to regional labour-value benchmarks and mutual-credit clearing, routing surpluses to cover deficits without speculative middlemen or interest rates (AA pp. 72, 115, 118, 142–143; MVD p. 268).</a:t>
             </a:r>
           </a:p>
           <a:p/>
           <a:p>
             <a:r>
-              <a:t>The criterion for technique applies to AI with special force. AI can take over drudgery and reduce the time production takes, which is the generational gain the treatise expects from means rightly used (AA p. 118). It can also concentrate capital and displace producers, the very drives the treatise identifies as obstacles (AA p. 107; JVD p. 35). A cyclical economy would keep every person engaged in production (MVD p. 265). Its knowledge, models and records would be shared, since research and dissemination are inseparable (AA pp. 56–58, 132).</a:t>
+              <a:t>The darshan's criterion for technique governs deployment: AI must reduce drudgery and production time while keeping every person a participant in physical production (MVD p. 265; AA p. 107; JVD p. 35), and all models, weights and agricultural or craft records must remain an open commons rather than proprietary intellectual property (AA pp. 29, 56–58, 132).</a:t>
             </a:r>
           </a:p>
           <a:p/>
           <a:p>
             <a:r>
-              <a:t>Today's recommendation and advertising systems give the selection–taste cycle an instrument tuned to keep it running. Directed by use and right use, the same capacities can help a family keep to its assessed needs.</a:t>
+              <a:t>Four safeguards keep the agent network subordinate to people (§8.8): no optimisation for profit or attention capture; strict data subsidiarity (personal logs belong to the person, family records to the family, village records to the villagers; AA p. 128); inspectable rules that prevent technocratic rulership (AA p. 82); and counting AI's own energy and mineral footprint within regenerative limits.</a:t>
             </a:r>
           </a:p>
         </p:txBody>
@@ -2336,7 +2332,7 @@
           <a:p/>
           <a:p>
             <a:r>
-              <a:t>First, the body's needs are definite, so the body by itself could come to balance with the rest of nature like any other organism. Second, human want is not definite. The darshan explains why: jeevan, the conscious unit, seeks continuity of happiness, and in delusion it reads its own dissatisfaction as a shortage of objects. Third, cyclical economics closes the cycle at the points where it now runs open: need assessed in the family, labour applied to natural abundance, goods produced for use, exchange at the value of labour, and the remainder given to right use. Fourth, instruments, including artificial intelligence, can help keep that cycle in balance and give labour its value, while the judgements of justice, dharma and truth stay with people.</a:t>
+              <a:t>First, the body's needs are definite, so the body by itself could come to balance with the rest of nature like any other organism. Second, human want is not definite. The darshan explains why: jeevan, the conscious unit, seeks continuity of happiness, and in delusion it reads its own dissatisfaction as a shortage of objects. Third, cyclical economics closes the cycle at the points where it now runs open: need assessed in the family, labour applied to natural abundance, goods produced for use, right use and purposeful use, exchange at the value of labour, and production kept within nature's regeneration. Fourth, passive databases and networks alone cannot establish or run such an order; intelligent systems and AI agents paired with individuals, families, committees and councils across all ten tiers can accelerate transition and keep the cycle in balance, while the judgements of justice, dharma and truth stay with people.</a:t>
             </a:r>
           </a:p>
           <a:p/>
@@ -2412,25 +2408,19 @@
           <a:lstStyle/>
           <a:p>
             <a:r>
-              <a:t>The critical review weighs the darshan's account as the study weighs every tradition.</a:t>
+              <a:t>The critical review weighs the darshan's account alongside neoclassical, Marxian, ecological and Gandhian economics and Advaita.</a:t>
             </a:r>
           </a:p>
           <a:p/>
           <a:p>
             <a:r>
-              <a:t>Its strengths: it explains insatiability rather than postulating it, through the distinction between the body's definite needs and jeevan's need for continuing happiness. It unifies diagnoses other traditions hold separately: limitless money-making, relative needs, throughput, and desire. Its definition of wealth as produced objects and of capital as human labour power keeps economics tied to provision. Its cycle closes need, use and regeneration together. Its policy names the value of human labour explicitly, and it gives a staged path of transition and a clear rule for instruments.</a:t>
+              <a:t>Its strengths: it explains insatiability rather than postulating it; unifies diagnoses of limitless money-making, disembedded markets, positional goods, throughput and desire; defines wealth as produced objects and capital as human labour power; pairs need-based sharing inside the family with equal labour-value exchange between families and regions simultaneously; closes need, use and natural regeneration together; names the value of labour in policy; and gives a three-stage transition path and a clear boundary for instruments.</a:t>
             </a:r>
           </a:p>
           <a:p/>
           <a:p>
             <a:r>
-              <a:t>Its open problems: how family-level assessment of need aggregates across a district or a nation; how common values of labour are set when skills and conditions differ widely, and how far computed labour values for complex goods can be relied on; what replaces the information carried by prices in the third stage; how machines and AI can reduce drudgery without displacing people from production; and what observations in communities practising the darshan would show that needs become definite, that producers receive the value of their labour, and that material throughput falls.</a:t>
-            </a:r>
-          </a:p>
-          <a:p/>
-          <a:p>
-            <a:r>
-              <a:t>The darshan gives the most complete account of why economies do not reach balance; its practicability depends on understanding it has yet to evidence at scale.</a:t>
+              <a:t>Its open problems: how family need assessments aggregate at scale; how common labour values account for complex multi-stage inputs, capital depreciation without interest, and Ricardian differential fertility across regions; how a federated network of AI agents paired with committees across the ten tiers can replace price and interest signals without creating a technocratic bottleneck; how automation reduces drudgery without displacing producers; and how communities govern Personal, Family and Committee AI Agents without ceding to them the judgements of justice, dharma and truth.</a:t>
             </a:r>
           </a:p>
         </p:txBody>
@@ -2506,13 +2496,171 @@
           <a:p/>
           <a:p>
             <a:r>
-              <a:t>Cyclical economics answers by closing the cycle where it now runs open. Need is assessed and made definite within the family. Labour applied to natural abundance produces objects for use; the objects nourish and protect the body and sustain social life, which renews the capacity to produce. Labour is valued by the usefulness it establishes, and exchange follows that value, so that remuneration equals production. Production stays within the proportions of natural regeneration, and the remainder flows into right use.</a:t>
+              <a:t>Cyclical economics answers by closing the cycle where it now runs open: definite need assessed in the family, labour valued by the usefulness it establishes, exchange at labour value free of profit and loss, production within natural regeneration, and the remainder flowing into right use across the five dimensions and ten tiers of self-governance.</a:t>
             </a:r>
           </a:p>
           <a:p/>
           <a:p>
             <a:r>
-              <a:t>Instruments, including AI, can help bring the economy into balance and give labour its true value: they can measure, account, warn and apply settled rules, and show each producer what their labour established. They must return to people the questions of whether a need is real, an exchange just and a valuation fair, and they must keep every person a participant in production. The economy the darshan describes depends finally on understanding. Instruments can show quickly where understanding is missing; they cannot supply it.</a:t>
+              <a:t>Passive databases and network connectivity alone cannot establish or run this order while keeping governance part-time and every citizen a producer. Intelligent systems and AI agents paired with every human unit, from the Personal AI Assistant and the Family AI Agent to the Committee and Council Agents across all ten tiers, can lower the barrier to transition and keep the cycle legible and coordinated, while returning to people the judgements of justice, dharma and truth.</a:t>
+            </a:r>
+          </a:p>
+        </p:txBody>
+      </p:sp>
+      <p:sp>
+        <p:nvSpPr>
+          <p:cNvPr id="4" name="Slide Number Placeholder 3"/>
+          <p:cNvSpPr>
+            <a:spLocks noGrp="1"/>
+          </p:cNvSpPr>
+          <p:nvPr>
+            <p:ph type="sldNum" idx="5" sz="quarter"/>
+          </p:nvPr>
+        </p:nvSpPr>
+        <p:spPr/>
+      </p:sp>
+    </p:spTree>
+  </p:cSld>
+  <p:clrMapOvr>
+    <a:masterClrMapping/>
+  </p:clrMapOvr>
+</p:notes>
+</file>
+
+<file path=ppt/notesSlides/notesSlide32.xml><?xml version="1.0" encoding="utf-8"?>
+<p:notes xmlns:a="http://schemas.openxmlformats.org/drawingml/2006/main" xmlns:p="http://schemas.openxmlformats.org/presentationml/2006/main" xmlns:r="http://schemas.openxmlformats.org/officeDocument/2006/relationships">
+  <p:cSld>
+    <p:spTree>
+      <p:nvGrpSpPr>
+        <p:cNvPr id="1" name=""/>
+        <p:cNvGrpSpPr/>
+        <p:nvPr/>
+      </p:nvGrpSpPr>
+      <p:grpSpPr>
+        <a:xfrm>
+          <a:off x="0" y="0"/>
+          <a:ext cx="0" cy="0"/>
+          <a:chOff x="0" y="0"/>
+          <a:chExt cx="0" cy="0"/>
+        </a:xfrm>
+      </p:grpSpPr>
+      <p:sp>
+        <p:nvSpPr>
+          <p:cNvPr id="2" name="Slide Image Placeholder 1"/>
+          <p:cNvSpPr>
+            <a:spLocks noGrp="1"/>
+          </p:cNvSpPr>
+          <p:nvPr>
+            <p:ph type="sldImg" idx="2"/>
+          </p:nvPr>
+        </p:nvSpPr>
+        <p:spPr/>
+      </p:sp>
+      <p:sp>
+        <p:nvSpPr>
+          <p:cNvPr id="3" name="Notes Placeholder 2"/>
+          <p:cNvSpPr>
+            <a:spLocks noGrp="1"/>
+          </p:cNvSpPr>
+          <p:nvPr>
+            <p:ph type="body" idx="3" sz="quarter"/>
+          </p:nvPr>
+        </p:nvSpPr>
+        <p:spPr/>
+        <p:txBody>
+          <a:bodyPr/>
+          <a:lstStyle/>
+          <a:p>
+            <a:r>
+              <a:t>Writing in the 1990s, Shri A. Nagraj anticipated computers in the village exchange-reserve (AA p. 138) and a computer network linking committees from the village to the world (AA p. 132). Yet passive databases and network connectivity alone cannot establish the cyclical economy or enable a fast transition from the current market system, because of four structural bottlenecks.</a:t>
+            </a:r>
+          </a:p>
+          <a:p/>
+          <a:p>
+            <a:r>
+              <a:t>First, the staffing constraint: council and committee members are part-time representatives who continue their own physical production (AA p. 127), the village exchange-reserve has as few as three staff members (AA p. 138), and eighty percent of society remains in production (MVD p. 259). Manual database querying across ten tiers would either stall or create a full-time managerial bureaucracy (JVD p. 35). Second, non-price coordination: replacing scalar market prices across millions of goods, capital depreciation and Ricardian fertility differences requires continuous input–output propagation and option generation. Third, qualitative-to-quantitative translation: surveys, family need assessments and joint training plans involve natural language that static forms cannot interpret without turning producers into clerks. Fourth, the transition bottleneck: because the system must be built by people still moving toward awakening (anubhav-gami) inside a profit economy, active intelligent agents are needed to give reflective feedback before habits harden and to run the dual currency-and-labour ledgers of Stages 1 and 2 (AA pp. 142–143).</a:t>
+            </a:r>
+          </a:p>
+        </p:txBody>
+      </p:sp>
+      <p:sp>
+        <p:nvSpPr>
+          <p:cNvPr id="4" name="Slide Number Placeholder 3"/>
+          <p:cNvSpPr>
+            <a:spLocks noGrp="1"/>
+          </p:cNvSpPr>
+          <p:nvPr>
+            <p:ph type="sldNum" idx="5" sz="quarter"/>
+          </p:nvPr>
+        </p:nvSpPr>
+        <p:spPr/>
+      </p:sp>
+    </p:spTree>
+  </p:cSld>
+  <p:clrMapOvr>
+    <a:masterClrMapping/>
+  </p:clrMapOvr>
+</p:notes>
+</file>
+
+<file path=ppt/notesSlides/notesSlide33.xml><?xml version="1.0" encoding="utf-8"?>
+<p:notes xmlns:a="http://schemas.openxmlformats.org/drawingml/2006/main" xmlns:p="http://schemas.openxmlformats.org/presentationml/2006/main" xmlns:r="http://schemas.openxmlformats.org/officeDocument/2006/relationships">
+  <p:cSld>
+    <p:spTree>
+      <p:nvGrpSpPr>
+        <p:cNvPr id="1" name=""/>
+        <p:cNvGrpSpPr/>
+        <p:nvPr/>
+      </p:nvGrpSpPr>
+      <p:grpSpPr>
+        <a:xfrm>
+          <a:off x="0" y="0"/>
+          <a:ext cx="0" cy="0"/>
+          <a:chOff x="0" y="0"/>
+          <a:chExt cx="0" cy="0"/>
+        </a:xfrm>
+      </p:grpSpPr>
+      <p:sp>
+        <p:nvSpPr>
+          <p:cNvPr id="2" name="Slide Image Placeholder 1"/>
+          <p:cNvSpPr>
+            <a:spLocks noGrp="1"/>
+          </p:cNvSpPr>
+          <p:nvPr>
+            <p:ph type="sldImg" idx="2"/>
+          </p:nvPr>
+        </p:nvSpPr>
+        <p:spPr/>
+      </p:sp>
+      <p:sp>
+        <p:nvSpPr>
+          <p:cNvPr id="3" name="Notes Placeholder 2"/>
+          <p:cNvSpPr>
+            <a:spLocks noGrp="1"/>
+          </p:cNvSpPr>
+          <p:nvPr>
+            <p:ph type="body" idx="3" sz="quarter"/>
+          </p:nvPr>
+        </p:nvSpPr>
+        <p:spPr/>
+        <p:txBody>
+          <a:bodyPr/>
+          <a:lstStyle/>
+          <a:p>
+            <a:r>
+              <a:t>The companion technical note on a personal AI assistant showed how an AI agent designed under the darshan's criteria can help an individual in transition (anubhav-gami) overcome delusion by serving as a diagnostic mirror for priya-hita-labha impulses, an educational companion for coexistence study and multi-occupation skills, and a practical work log. Establishing and governing a cyclical economy requires extending that architecture to every unit in the ten-tier family-rooted self-governing order.</a:t>
+            </a:r>
+          </a:p>
+          <a:p/>
+          <a:p>
+            <a:r>
+              <a:t>At the family level (10–12 members; AA pp. 14, 26, 65), a Family AI Agent helps the household assess its common and special aspirations (AA p. 112), tracks actual use and stock age against hoarding or spoilage, coordinates restful family production without weighing individual labour shares (AA pp. 119–120), and publishes only aggregate need and surplus to the village. At Tiers 1 and 2, Cluster, Village Council, and five Committee Agents (production-work, exchange-reserve, education-sanskar, health-restraint, and justice-security) maintain the living village survey, link the five dimensions horizontally, and run the three-stage transition ledgers alongside the three-person exchange-reserve staff (AA pp. 125–145).</a:t>
+            </a:r>
+          </a:p>
+          <a:p/>
+          <a:p>
+            <a:r>
+              <a:t>Across Tiers 3 to 10, federated Council and Committee Agents match inter-village surpluses and deficits at labour value (AA p. 72), coordinate cottage, small, medium and large industry (AA p. 115), onboard newly transitioning villages, and monitor planetary regeneration boundaries (MVD p. 268). At every level, the human unit retains normative judgement.</a:t>
             </a:r>
           </a:p>
         </p:txBody>
@@ -6620,7 +6768,7 @@
                 </a:solidFill>
                 <a:latin typeface="Calibri"/>
               </a:rPr>
-              <a:t>AA · MVD · JV · SB · KD · JVD · AVD  ·  1 / 31</a:t>
+              <a:t>AA · MVD · JV · SB · KD · JVD · AVD  ·  1 / 33</a:t>
             </a:r>
           </a:p>
         </p:txBody>
@@ -7759,7 +7907,7 @@
                 </a:solidFill>
                 <a:latin typeface="Calibri"/>
               </a:rPr>
-              <a:t>KD p. 115  ·  SB p. 234  ·  Robbins 1932  ·  AnalyticMadhyasthDarshan.org  ·  10 / 31</a:t>
+              <a:t>KD p. 115  ·  SB p. 234  ·  Robbins 1932  ·  AnalyticMadhyasthDarshan.org  ·  10 / 33</a:t>
             </a:r>
           </a:p>
         </p:txBody>
@@ -8539,7 +8687,7 @@
                 </a:solidFill>
                 <a:latin typeface="Calibri"/>
               </a:rPr>
-              <a:t>Seeking more worth than the labour performed: a higher value in exchange for a lower one. It has no fixed limit.</a:t>
+              <a:t>Seeking more worth than the labour performed. Neither unrestrained nor state-regulated currency economies remove profit-obsession.</a:t>
             </a:r>
           </a:p>
         </p:txBody>
@@ -8624,7 +8772,7 @@
                 </a:solidFill>
                 <a:latin typeface="Cambria"/>
               </a:rPr>
-              <a:t>Artificial scarcity</a:t>
+              <a:t>Three allurements &amp; seven trades</a:t>
             </a:r>
           </a:p>
         </p:txBody>
@@ -8663,7 +8811,7 @@
                 </a:solidFill>
                 <a:latin typeface="Calibri"/>
               </a:rPr>
-              <a:t>Where currency is concentrated, objects are held back from the motion that makes them accessible to all.</a:t>
+              <a:t>Paper is easily carried, hidden and paid; objects, strength, learning, knowledge, position and beauty are all sold for currency.</a:t>
             </a:r>
           </a:p>
         </p:txBody>
@@ -8865,7 +9013,7 @@
                 </a:solidFill>
                 <a:latin typeface="Calibri"/>
               </a:rPr>
-              <a:t>AA pp. 5–7, 45, 52–53, 75  ·  MVD pp. 57, 66, 182  ·  JV pp. 151–152  ·  AnalyticMadhyasthDarshan.org  ·  11 / 31</a:t>
+              <a:t>AA pp. 1–8, 45–46, 52–53, 75  ·  MVD pp. 57, 66, 182  ·  JV pp. 151–152  ·  AnalyticMadhyasthDarshan.org  ·  11 / 33</a:t>
             </a:r>
           </a:p>
         </p:txBody>
@@ -9962,7 +10110,7 @@
                 </a:solidFill>
                 <a:latin typeface="Calibri"/>
               </a:rPr>
-              <a:t>AA pp. 30–31, 47, 70–71, 74, 82  ·  KD §3.7  ·  AnalyticMadhyasthDarshan.org  ·  12 / 31</a:t>
+              <a:t>AA pp. 30–31, 47, 70–71, 74, 82  ·  KD §3.7  ·  AnalyticMadhyasthDarshan.org  ·  12 / 33</a:t>
             </a:r>
           </a:p>
         </p:txBody>
@@ -10749,7 +10897,7 @@
                 </a:solidFill>
                 <a:latin typeface="Calibri"/>
               </a:rPr>
-              <a:t>AA pp. 25, 73, 105  ·  MVD pp. 56, 243  ·  SB p. 268  ·  JV p. 151  ·  JVD p. 215  ·  AnalyticMadhyasthDarshan.org  ·  13 / 31</a:t>
+              <a:t>AA pp. 18–19, 25, 48–50, 73, 105  ·  MVD pp. 56, 243  ·  SB p. 268  ·  JVD p. 215  ·  AnalyticMadhyasthDarshan.org  ·  13 / 33</a:t>
             </a:r>
           </a:p>
         </p:txBody>
@@ -11869,7 +12017,7 @@
                 </a:solidFill>
                 <a:latin typeface="Calibri"/>
               </a:rPr>
-              <a:t>AA pp. 15, 34–35, 42  ·  MVD p. 152  ·  AnalyticMadhyasthDarshan.org  ·  14 / 31</a:t>
+              <a:t>AA pp. 15, 34–35, 42  ·  MVD p. 152  ·  AnalyticMadhyasthDarshan.org  ·  14 / 33</a:t>
             </a:r>
           </a:p>
         </p:txBody>
@@ -13183,7 +13331,7 @@
                 </a:solidFill>
                 <a:latin typeface="Calibri"/>
               </a:rPr>
-              <a:t>AA pp. 26, 106, 118  ·  JV p. 154  ·  AnalyticMadhyasthDarshan.org  ·  15 / 31</a:t>
+              <a:t>AA pp. 26, 106, 118  ·  JV p. 154  ·  AnalyticMadhyasthDarshan.org  ·  15 / 33</a:t>
             </a:r>
           </a:p>
         </p:txBody>
@@ -13993,7 +14141,7 @@
                 </a:solidFill>
                 <a:latin typeface="Calibri"/>
               </a:rPr>
-              <a:t>AA pp. 14, 26, 62–63, 65, 76, 113–114  ·  MVD p. 71  ·  JV p. 153  ·  KD p. 115  ·  AnalyticMadhyasthDarshan.org  ·  16 / 31</a:t>
+              <a:t>AA pp. 14, 26, 62–63, 65, 76, 113–114  ·  MVD p. 71  ·  JV p. 153  ·  KD p. 115  ·  AnalyticMadhyasthDarshan.org  ·  16 / 33</a:t>
             </a:r>
           </a:p>
         </p:txBody>
@@ -14190,7 +14338,7 @@
                 </a:solidFill>
                 <a:latin typeface="Calibri"/>
               </a:rPr>
-              <a:t>III  ·  THE VALUE OF LABOUR  ·  §§3.5, 3.12</a:t>
+              <a:t>III  ·  THE VALUE OF LABOUR  ·  §§3.6, 3.12</a:t>
             </a:r>
           </a:p>
         </p:txBody>
@@ -15200,7 +15348,7 @@
                 </a:solidFill>
                 <a:latin typeface="Calibri"/>
               </a:rPr>
-              <a:t>AA pp. 49, 66, 112, 119–120, 145  ·  MVD pp. 265–268  ·  Axiology §§1.1, 1.5–1.6  ·  AnalyticMadhyasthDarshan.org  ·  17 / 31</a:t>
+              <a:t>AA pp. 49, 66, 112, 119–120, 145  ·  MVD pp. 265–268  ·  Axiology §§1.1, 1.5–1.6  ·  AnalyticMadhyasthDarshan.org  ·  18 / 33</a:t>
             </a:r>
           </a:p>
         </p:txBody>
@@ -15397,7 +15545,7 @@
                 </a:solidFill>
                 <a:latin typeface="Calibri"/>
               </a:rPr>
-              <a:t>III  ·  THREE LEVELS OF USE  ·  §3.6</a:t>
+              <a:t>III  ·  THREE LEVELS OF USE  ·  §3.5</a:t>
             </a:r>
           </a:p>
         </p:txBody>
@@ -17068,7 +17216,7 @@
                 </a:solidFill>
                 <a:latin typeface="Calibri"/>
               </a:rPr>
-              <a:t>AA pp. 68, 72, 92, 94, 116  ·  MVD p. 56  ·  KD pp. 4, 116  ·  AnalyticMadhyasthDarshan.org  ·  18 / 31</a:t>
+              <a:t>AA pp. 20–24, 68, 72, 92, 94, 116  ·  MVD p. 56  ·  KD pp. 4, 116  ·  AnalyticMadhyasthDarshan.org  ·  17 / 33</a:t>
             </a:r>
           </a:p>
         </p:txBody>
@@ -17265,7 +17413,7 @@
                 </a:solidFill>
                 <a:latin typeface="Calibri"/>
               </a:rPr>
-              <a:t>III  ·  CHARACTER  ·  §3.9</a:t>
+              <a:t>III  ·  CHARACTER  ·  §3.7</a:t>
             </a:r>
           </a:p>
         </p:txBody>
@@ -17513,7 +17661,7 @@
                 </a:solidFill>
                 <a:latin typeface="Cambria"/>
               </a:rPr>
-              <a:t>Wealth is not renounced</a:t>
+              <a:t>Three motives &amp; responsibility</a:t>
             </a:r>
           </a:p>
         </p:txBody>
@@ -17552,7 +17700,7 @@
                 </a:solidFill>
                 <a:latin typeface="Calibri"/>
               </a:rPr>
-              <a:t>The motives for progeny, wealth and reputation are humane; they become assets of the family and society.</a:t>
+              <a:t>Progeny, wealth and public welfare are humane motives, with public welfare highest; responsibility covers doing, commissioning and consenting.</a:t>
             </a:r>
           </a:p>
         </p:txBody>
@@ -17878,7 +18026,7 @@
                 </a:solidFill>
                 <a:latin typeface="Calibri"/>
               </a:rPr>
-              <a:t>AA pp. 1, 22–24, 54, 102, 140  ·  MVD pp. 59, 137, 211, 221, 263, 339  ·  AVD p. 170  ·  KD p. 116  ·  AnalyticMadhyasthDarshan.org  ·  19 / 31</a:t>
+              <a:t>AA pp. 1, 22–24, 54, 101–102, 140  ·  MVD pp. 59, 211, 263, 318–320, 339  ·  KD pp. 1–2, 116–117  ·  AnalyticMadhyasthDarshan.org  ·  19 / 33</a:t>
             </a:r>
           </a:p>
         </p:txBody>
@@ -18665,7 +18813,7 @@
                 </a:solidFill>
                 <a:latin typeface="Calibri"/>
               </a:rPr>
-              <a:t>Study, opening and §1  ·  AnalyticMadhyasthDarshan.org  ·  2 / 31</a:t>
+              <a:t>Study, opening and §1  ·  AnalyticMadhyasthDarshan.org  ·  2 / 33</a:t>
             </a:r>
           </a:p>
         </p:txBody>
@@ -18862,7 +19010,7 @@
                 </a:solidFill>
                 <a:latin typeface="Calibri"/>
               </a:rPr>
-              <a:t>III  ·  NATURE'S BALANCE  ·  §3.7</a:t>
+              <a:t>III  ·  NATURE'S BALANCE  ·  §3.8</a:t>
             </a:r>
           </a:p>
         </p:txBody>
@@ -19686,7 +19834,7 @@
                 </a:solidFill>
                 <a:latin typeface="Cambria"/>
               </a:rPr>
-              <a:t>Without a prosperous nature</a:t>
+              <a:t>Production vs. extraction</a:t>
             </a:r>
           </a:p>
         </p:txBody>
@@ -19725,7 +19873,7 @@
                 </a:solidFill>
                 <a:latin typeface="Calibri"/>
               </a:rPr>
-              <a:t>the human cannot be prosperous. Production security is maintained through nature's balance.</a:t>
+              <a:t>Production is cyclical and leaves earth's balance undisturbed; digging coal and oil is extraction, not production.</a:t>
             </a:r>
           </a:p>
         </p:txBody>
@@ -19764,7 +19912,7 @@
                 </a:solidFill>
                 <a:latin typeface="Calibri"/>
               </a:rPr>
-              <a:t>MVD pp. 263–264  ·  AA pp. 31–33, 92, 106–107, 114, 134–135, 142, 146  ·  KD p. 7  ·  AnalyticMadhyasthDarshan.org  ·  20 / 31</a:t>
+              <a:t>MVD pp. 263–264  ·  AA pp. 31–33, 78, 92, 106–107, 114, 142, 146  ·  KD p. 7  ·  AnalyticMadhyasthDarshan.org  ·  20 / 33</a:t>
             </a:r>
           </a:p>
         </p:txBody>
@@ -19961,7 +20109,7 @@
                 </a:solidFill>
                 <a:latin typeface="Calibri"/>
               </a:rPr>
-              <a:t>III  ·  TECHNIQUE  ·  §3.11</a:t>
+              <a:t>III  ·  SKILL AND TECHNIQUE  ·  §§3.9–3.10</a:t>
             </a:r>
           </a:p>
         </p:txBody>
@@ -20000,7 +20148,7 @@
                 </a:solidFill>
                 <a:latin typeface="Cambria"/>
               </a:rPr>
-              <a:t>Machines and Participation</a:t>
+              <a:t>Skills, Machines, and Participation</a:t>
             </a:r>
           </a:p>
         </p:txBody>
@@ -20085,7 +20233,7 @@
                 </a:solidFill>
                 <a:latin typeface="Cambria"/>
               </a:rPr>
-              <a:t>Technique multiplies speed</a:t>
+              <a:t>Open skills &amp; dissemination</a:t>
             </a:r>
           </a:p>
         </p:txBody>
@@ -20124,7 +20272,7 @@
                 </a:solidFill>
                 <a:latin typeface="Calibri"/>
               </a:rPr>
-              <a:t>Of whatever humans do: without social understanding, it multiplies problems too.</a:t>
+              <a:t>Research and dissemination are inseparable; multi-occupation skills are taught to all, never enclosed by patents.</a:t>
             </a:r>
           </a:p>
         </p:txBody>
@@ -20660,7 +20808,7 @@
                 </a:solidFill>
                 <a:latin typeface="Calibri"/>
               </a:rPr>
-              <a:t>SB p. 267  ·  AA pp. 47, 75–76, 107, 115, 118, 137  ·  JVD pp. 35, 216  ·  MVD p. 265  ·  AnalyticMadhyasthDarshan.org  ·  21 / 31</a:t>
+              <a:t>SB p. 267  ·  AA pp. 29, 47, 56–58, 107, 118, 131  ·  JV pp. 88–89  ·  JVD pp. 35, 216  ·  MVD p. 265  ·  21 / 33</a:t>
             </a:r>
           </a:p>
         </p:txBody>
@@ -20857,7 +21005,7 @@
                 </a:solidFill>
                 <a:latin typeface="Calibri"/>
               </a:rPr>
-              <a:t>III  ·  ORDERLINESS  ·  §§3.8, 3.12</a:t>
+              <a:t>III  ·  ORDERLINESS  ·  §§3.11–3.12</a:t>
             </a:r>
           </a:p>
         </p:txBody>
@@ -21525,7 +21673,7 @@
                 </a:solidFill>
                 <a:latin typeface="Calibri"/>
               </a:rPr>
-              <a:t>A village of about 100 families; ten tiers of councils, each with five committees. Small industry below, large industry at higher tiers.</a:t>
+              <a:t>A 100-family village with nine production branches; ten tiers of part-time councils (zero election cost); 80% in production, 20% in service.</a:t>
             </a:r>
           </a:p>
         </p:txBody>
@@ -21766,7 +21914,7 @@
                 </a:solidFill>
                 <a:latin typeface="Calibri"/>
               </a:rPr>
-              <a:t>AA pp. 27–30, 63, 110, 112, 115, 117  ·  MVD pp. 233, 264–271  ·  KD p. 67  ·  JVD p. 32  ·  AnalyticMadhyasthDarshan.org  ·  22 / 31</a:t>
+              <a:t>AA pp. 27–30, 63, 104–105, 110–117, 127, 133–136  ·  MVD pp. 233, 259, 264–271  ·  KD p. 67  ·  22 / 33</a:t>
             </a:r>
           </a:p>
         </p:txBody>
@@ -22741,7 +22889,7 @@
                 </a:solidFill>
                 <a:latin typeface="Calibri"/>
               </a:rPr>
-              <a:t>AA pp. 122–125, 136–138, 142–143  ·  JV pp. 153–154  ·  JVD pp. 217–218  ·  AVD p. 52  ·  AnalyticMadhyasthDarshan.org  ·  23 / 31</a:t>
+              <a:t>AA pp. 122–125, 136–138, 142–143  ·  JV pp. 153–154  ·  JVD pp. 217–218  ·  AVD p. 52  ·  AnalyticMadhyasthDarshan.org  ·  23 / 33</a:t>
             </a:r>
           </a:p>
         </p:txBody>
@@ -23511,7 +23659,7 @@
                 </a:solidFill>
                 <a:latin typeface="Calibri"/>
               </a:rPr>
-              <a:t>Neoclassical economics</a:t>
+              <a:t>Neoclassical &amp; marginalist</a:t>
             </a:r>
           </a:p>
         </p:txBody>
@@ -23550,7 +23698,7 @@
                 </a:solidFill>
                 <a:latin typeface="Calibri"/>
               </a:rPr>
-              <a:t>Taken as given: non-satiation and scarcity</a:t>
+              <a:t>Non-satiation; marginal utility (Jevons)</a:t>
             </a:r>
           </a:p>
         </p:txBody>
@@ -23794,7 +23942,7 @@
                 </a:solidFill>
                 <a:latin typeface="Calibri"/>
               </a:rPr>
-              <a:t>Use limits household acquisition</a:t>
+              <a:t>Use limits household; abolish capital</a:t>
             </a:r>
           </a:p>
         </p:txBody>
@@ -24565,7 +24713,7 @@
                 </a:solidFill>
                 <a:latin typeface="Calibri"/>
               </a:rPr>
-              <a:t>Study §§4–7  ·  Robbins 1932  ·  Keynes 1930  ·  Daly 1974  ·  Kumarappa 1945  ·  BG 3.37–39  ·  AnalyticMadhyasthDarshan.org  ·  24 / 31</a:t>
+              <a:t>Study §§4–7  ·  Jevons 1871  ·  Marx 1875  ·  Robbins 1932  ·  Polanyi 1944  ·  Daly 1974  ·  Kumarappa 1945  ·  24 / 33</a:t>
             </a:r>
           </a:p>
         </p:txBody>
@@ -25134,7 +25282,7 @@
                 </a:solidFill>
                 <a:latin typeface="Cambria"/>
               </a:rPr>
-              <a:t>Commons</a:t>
+              <a:t>Commons &amp; embeddedness</a:t>
             </a:r>
           </a:p>
         </p:txBody>
@@ -25173,7 +25321,7 @@
                 </a:solidFill>
                 <a:latin typeface="Calibri"/>
               </a:rPr>
-              <a:t>shared assets can be governed (Ostrom)</a:t>
+              <a:t>polycentric rules; non-commodities (Ostrom, Polanyi)</a:t>
             </a:r>
           </a:p>
         </p:txBody>
@@ -25258,7 +25406,7 @@
                 </a:solidFill>
                 <a:latin typeface="Cambria"/>
               </a:rPr>
-              <a:t>Needs theory</a:t>
+              <a:t>Needs &amp; capabilities</a:t>
             </a:r>
           </a:p>
         </p:txBody>
@@ -25297,7 +25445,7 @@
                 </a:solidFill>
                 <a:latin typeface="Calibri"/>
               </a:rPr>
-              <a:t>finite, classifiable needs (Max-Neef)</a:t>
+              <a:t>objective needs &amp; functionings (Max-Neef, Sen)</a:t>
             </a:r>
           </a:p>
         </p:txBody>
@@ -25382,7 +25530,7 @@
                 </a:solidFill>
                 <a:latin typeface="Cambria"/>
               </a:rPr>
-              <a:t>Money as credit</a:t>
+              <a:t>Credit &amp; mutual clearing</a:t>
             </a:r>
           </a:p>
         </p:txBody>
@@ -25421,7 +25569,7 @@
                 </a:solidFill>
                 <a:latin typeface="Calibri"/>
               </a:rPr>
-              <a:t>banks create money by lending</a:t>
+              <a:t>bank credit vs. interest-free WIR clearing (Stodder)</a:t>
             </a:r>
           </a:p>
         </p:txBody>
@@ -25506,7 +25654,7 @@
                 </a:solidFill>
                 <a:latin typeface="Cambria"/>
               </a:rPr>
-              <a:t>Labour accounting</a:t>
+              <a:t>Labour &amp; rent accounting</a:t>
             </a:r>
           </a:p>
         </p:txBody>
@@ -25545,7 +25693,7 @@
                 </a:solidFill>
                 <a:latin typeface="Calibri"/>
               </a:rPr>
-              <a:t>embodied labour can be computed</a:t>
+              <a:t>input–output, depreciation &amp; differential rent (Ricardo)</a:t>
             </a:r>
           </a:p>
         </p:txBody>
@@ -25754,7 +25902,7 @@
                 </a:solidFill>
                 <a:latin typeface="Calibri"/>
               </a:rPr>
-              <a:t>Hayek 1945  ·  Leontief 1936  ·  Ostrom 2010  ·  Max-Neef et al. 1989  ·  BoE 2014  ·  Cockshott and Cottrell 1993  ·  AnalyticMadhyasthDarshan.org  ·  25 / 31</a:t>
+              <a:t>Ricardo 1817  ·  Leontief 1936  ·  Polanyi 1944  ·  Hayek 1945  ·  Sen 1999  ·  Stodder 2009  ·  Ostrom 2010  ·  25 / 33</a:t>
             </a:r>
           </a:p>
         </p:txBody>
@@ -26416,7 +26564,7 @@
                 </a:solidFill>
                 <a:latin typeface="Calibri"/>
               </a:rPr>
-              <a:t>MVD p. 173  ·  AA pp. 18, 117, 122–125, 132, 138  ·  KD p. 139  ·  SB p. 267  ·  AnalyticMadhyasthDarshan.org  ·  26 / 31</a:t>
+              <a:t>MVD p. 173  ·  AA pp. 18, 117  ·  KD p. 139  ·  SB p. 267  ·  AI Study §§1.2–1.5  ·  AnalyticMadhyasthDarshan.org  ·  26 / 33</a:t>
             </a:r>
           </a:p>
         </p:txBody>
@@ -26613,7 +26761,7 @@
                 </a:solidFill>
                 <a:latin typeface="Calibri"/>
               </a:rPr>
-              <a:t>V  ·  FAILURE POINTS  ·  §8.2</a:t>
+              <a:t>V  ·  FAILURE POINTS  ·  §8.4</a:t>
             </a:r>
           </a:p>
         </p:txBody>
@@ -28074,7 +28222,7 @@
                 </a:solidFill>
                 <a:latin typeface="Calibri"/>
               </a:rPr>
-              <a:t>Study §8.2  ·  AA pp. 26, 49, 106, 119, 127, 142–146  ·  MVD pp. 263–268  ·  AnalyticMadhyasthDarshan.org  ·  27 / 31</a:t>
+              <a:t>Study §8.4  ·  AA pp. 26, 49, 106, 119, 127, 142–146  ·  MVD pp. 263–268  ·  AnalyticMadhyasthDarshan.org  ·  29 / 33</a:t>
             </a:r>
           </a:p>
         </p:txBody>
@@ -28271,7 +28419,7 @@
                 </a:solidFill>
                 <a:latin typeface="Calibri"/>
               </a:rPr>
-              <a:t>V  ·  VALUING LABOUR  ·  §8.3</a:t>
+              <a:t>V  ·  VALUING LABOUR  ·  §8.5</a:t>
             </a:r>
           </a:p>
         </p:txBody>
@@ -28310,7 +28458,7 @@
                 </a:solidFill>
                 <a:latin typeface="Cambria"/>
               </a:rPr>
-              <a:t>AI to Give Labour Its Value</a:t>
+              <a:t>AI Agents to Give Labour Its Value</a:t>
             </a:r>
           </a:p>
         </p:txBody>
@@ -28691,7 +28839,7 @@
                 </a:solidFill>
                 <a:latin typeface="Calibri"/>
               </a:rPr>
-              <a:t>input–output tracing</a:t>
+              <a:t>I–O, depreciation, rent</a:t>
             </a:r>
           </a:p>
         </p:txBody>
@@ -29141,7 +29289,7 @@
                 </a:solidFill>
                 <a:latin typeface="Cambria"/>
               </a:rPr>
-              <a:t>What the instrument carries</a:t>
+              <a:t>What the agent network computes</a:t>
             </a:r>
           </a:p>
         </p:txBody>
@@ -29180,7 +29328,7 @@
                 </a:solidFill>
                 <a:latin typeface="Calibri"/>
               </a:rPr>
-              <a:t>Records, computation, and the figures the second and third stages of the transition need; matching skills to the work a village needs.</a:t>
+              <a:t>Multi-village midpoint values, Leontief input–output chains, tool depreciation without interest, Ricardian soil adjustments, and 3-stage dual ledgers.</a:t>
             </a:r>
           </a:p>
         </p:txBody>
@@ -29382,7 +29530,7 @@
                 </a:solidFill>
                 <a:latin typeface="Calibri"/>
               </a:rPr>
-              <a:t>Study §§4.10, 8.3  ·  AA pp. 66–67, 119–120, 131, 142–145  ·  Leontief 1936  ·  AnalyticMadhyasthDarshan.org  ·  28 / 31</a:t>
+              <a:t>Study §§4.2, 4.10, 8.5  ·  AA pp. 66–67, 118–120, 131, 142–145  ·  Ricardo 1817  ·  Leontief 1936  ·  30 / 33</a:t>
             </a:r>
           </a:p>
         </p:txBody>
@@ -29579,7 +29727,7 @@
                 </a:solidFill>
                 <a:latin typeface="Calibri"/>
               </a:rPr>
-              <a:t>V  ·  BALANCE AND PARTICIPATION  ·  §§8.4–8.6</a:t>
+              <a:t>V  ·  BALANCE AND SAFEGUARDS  ·  §§8.6–8.8</a:t>
             </a:r>
           </a:p>
         </p:txBody>
@@ -29618,7 +29766,7 @@
                 </a:solidFill>
                 <a:latin typeface="Cambria"/>
               </a:rPr>
-              <a:t>AI to Keep the Cycle in Balance</a:t>
+              <a:t>Keeping the Cycle Balanced and Governed</a:t>
             </a:r>
           </a:p>
         </p:txBody>
@@ -29788,7 +29936,7 @@
                 </a:solidFill>
                 <a:latin typeface="Cambria"/>
               </a:rPr>
-              <a:t>Keep it visible</a:t>
+              <a:t>Accelerate transition</a:t>
             </a:r>
           </a:p>
         </p:txBody>
@@ -29827,7 +29975,7 @@
                 </a:solidFill>
                 <a:latin typeface="Calibri"/>
               </a:rPr>
-              <a:t>A living village survey; stock and its age; extraction against regeneration; how many families the land supports.</a:t>
+              <a:t>Living surveys, inter-tier surplus routing at labour value, and pre-configured agents that onboard new villages into the 3 stages.</a:t>
             </a:r>
           </a:p>
         </p:txBody>
@@ -29912,7 +30060,7 @@
                 </a:solidFill>
                 <a:latin typeface="Cambria"/>
               </a:rPr>
-              <a:t>Keep everyone producing</a:t>
+              <a:t>Participation &amp; commons</a:t>
             </a:r>
           </a:p>
         </p:txBody>
@@ -29951,7 +30099,7 @@
                 </a:solidFill>
                 <a:latin typeface="Calibri"/>
               </a:rPr>
-              <a:t>Reduce drudgery and time; never displace producers or concentrate the means.</a:t>
+              <a:t>Reduce drudgery without displacing producers; keep all models, weights and protocols open as shared generational means.</a:t>
             </a:r>
           </a:p>
         </p:txBody>
@@ -30036,7 +30184,7 @@
                 </a:solidFill>
                 <a:latin typeface="Cambria"/>
               </a:rPr>
-              <a:t>Keep knowledge common</a:t>
+              <a:t>Subsidiarity &amp; boundaries</a:t>
             </a:r>
           </a:p>
         </p:txBody>
@@ -30075,7 +30223,7 @@
                 </a:solidFill>
                 <a:latin typeface="Calibri"/>
               </a:rPr>
-              <a:t>Models and records shared as means handed down, never enclosed for profit.</a:t>
+              <a:t>Data stays with person, family and village; never optimise for profit or rule; return justice, dharma and truth to people.</a:t>
             </a:r>
           </a:p>
         </p:txBody>
@@ -30284,7 +30432,7 @@
                 </a:solidFill>
                 <a:latin typeface="Calibri"/>
               </a:rPr>
-              <a:t>Study §§8.4–8.7  ·  AA pp. 29, 56–58, 72, 92, 107, 118, 132  ·  MVD pp. 265, 268  ·  JVD p. 35  ·  AnalyticMadhyasthDarshan.org  ·  29 / 31</a:t>
+              <a:t>Study §§8.6–8.8  ·  AA pp. 29, 56–58, 72, 82, 92, 107, 118, 128, 132  ·  MVD pp. 265, 268  ·  JVD p. 35  ·  31 / 33</a:t>
             </a:r>
           </a:p>
         </p:txBody>
@@ -31028,7 +31176,7 @@
                 </a:solidFill>
                 <a:latin typeface="Cambria"/>
               </a:rPr>
-              <a:t>Instruments help</a:t>
+              <a:t>AI agents help</a:t>
             </a:r>
           </a:p>
           <a:p>
@@ -31044,7 +31192,7 @@
                 </a:solidFill>
                 <a:latin typeface="Calibri"/>
               </a:rPr>
-              <a:t>balance and value
+              <a:t>transition &amp; balance
 §8</a:t>
             </a:r>
           </a:p>
@@ -31665,7 +31813,7 @@
                 </a:solidFill>
                 <a:latin typeface="Calibri"/>
               </a:rPr>
-              <a:t>Study, opening and §§1–3, 8  ·  AnalyticMadhyasthDarshan.org  ·  3 / 31</a:t>
+              <a:t>Study, opening and §§1–3, 8  ·  AnalyticMadhyasthDarshan.org  ·  3 / 33</a:t>
             </a:r>
           </a:p>
         </p:txBody>
@@ -32235,7 +32383,7 @@
                 </a:solidFill>
                 <a:latin typeface="Calibri"/>
               </a:rPr>
-              <a:t>Closes need, use and regeneration together</a:t>
+              <a:t>Pairs family need-sharing with labour-value exchange</a:t>
             </a:r>
           </a:p>
         </p:txBody>
@@ -32652,7 +32800,7 @@
                 </a:solidFill>
                 <a:latin typeface="Calibri"/>
               </a:rPr>
-              <a:t>Labour values for complex goods</a:t>
+              <a:t>Embodied labour, depreciation &amp; Ricardian rent</a:t>
             </a:r>
           </a:p>
         </p:txBody>
@@ -32735,7 +32883,7 @@
                 </a:solidFill>
                 <a:latin typeface="Calibri"/>
               </a:rPr>
-              <a:t>Coordination without prices</a:t>
+              <a:t>10-tier coordination via AI agents without bureaucracy</a:t>
             </a:r>
           </a:p>
         </p:txBody>
@@ -32901,7 +33049,7 @@
                 </a:solidFill>
                 <a:latin typeface="Calibri"/>
               </a:rPr>
-              <a:t>Evidence from practising communities</a:t>
+              <a:t>Governing multi-level agents without ceding judgement</a:t>
             </a:r>
           </a:p>
         </p:txBody>
@@ -32979,7 +33127,7 @@
                 </a:solidFill>
                 <a:latin typeface="Calibri"/>
               </a:rPr>
-              <a:t>Study §§9.1, 9.7  ·  AnalyticMadhyasthDarshan.org  ·  30 / 31</a:t>
+              <a:t>Study §§9.1–9.7  ·  AnalyticMadhyasthDarshan.org  ·  32 / 33</a:t>
             </a:r>
           </a:p>
         </p:txBody>
@@ -33635,7 +33783,7 @@
                 </a:solidFill>
                 <a:latin typeface="Calibri"/>
               </a:rPr>
-              <a:t>Instruments can show quickly where understanding is missing; they cannot supply it.</a:t>
+              <a:t>Multi-level AI agents can accelerate the transition and make balance visible; understanding and judgement belong to people.</a:t>
             </a:r>
           </a:p>
         </p:txBody>
@@ -33713,7 +33861,2544 @@
                 </a:solidFill>
                 <a:latin typeface="Calibri"/>
               </a:rPr>
-              <a:t>AnalyticMadhyasthDarshan.org  ·  31 / 31</a:t>
+              <a:t>AnalyticMadhyasthDarshan.org  ·  33 / 33</a:t>
+            </a:r>
+          </a:p>
+        </p:txBody>
+      </p:sp>
+    </p:spTree>
+  </p:cSld>
+  <p:clrMapOvr>
+    <a:masterClrMapping/>
+  </p:clrMapOvr>
+</p:sld>
+</file>
+
+<file path=ppt/slides/slide32.xml><?xml version="1.0" encoding="utf-8"?>
+<p:sld xmlns:a="http://schemas.openxmlformats.org/drawingml/2006/main" xmlns:p="http://schemas.openxmlformats.org/presentationml/2006/main" xmlns:r="http://schemas.openxmlformats.org/officeDocument/2006/relationships">
+  <p:cSld>
+    <p:spTree>
+      <p:nvGrpSpPr>
+        <p:cNvPr id="1" name=""/>
+        <p:cNvGrpSpPr/>
+        <p:nvPr/>
+      </p:nvGrpSpPr>
+      <p:grpSpPr/>
+      <p:sp>
+        <p:nvSpPr>
+          <p:cNvPr id="2" name="Oval 1"/>
+          <p:cNvSpPr/>
+          <p:nvPr/>
+        </p:nvSpPr>
+        <p:spPr>
+          <a:xfrm>
+            <a:off x="457200" y="384048"/>
+            <a:ext cx="365760" cy="365760"/>
+          </a:xfrm>
+          <a:prstGeom prst="ellipse">
+            <a:avLst/>
+          </a:prstGeom>
+          <a:noFill/>
+          <a:ln w="12700">
+            <a:solidFill>
+              <a:srgbClr val="3B4A7A"/>
+            </a:solidFill>
+          </a:ln>
+          <a:effectLst/>
+        </p:spPr>
+        <p:style>
+          <a:lnRef idx="1">
+            <a:schemeClr val="accent1"/>
+          </a:lnRef>
+          <a:fillRef idx="3">
+            <a:schemeClr val="accent1"/>
+          </a:fillRef>
+          <a:effectRef idx="2">
+            <a:schemeClr val="accent1"/>
+          </a:effectRef>
+          <a:fontRef idx="minor">
+            <a:schemeClr val="lt1"/>
+          </a:fontRef>
+        </p:style>
+        <p:txBody>
+          <a:bodyPr rtlCol="0" anchor="ctr"/>
+          <a:lstStyle/>
+          <a:p>
+            <a:pPr algn="ctr"/>
+          </a:p>
+        </p:txBody>
+      </p:sp>
+      <p:sp>
+        <p:nvSpPr>
+          <p:cNvPr id="3" name="Oval 2"/>
+          <p:cNvSpPr/>
+          <p:nvPr/>
+        </p:nvSpPr>
+        <p:spPr>
+          <a:xfrm>
+            <a:off x="530352" y="457200"/>
+            <a:ext cx="219456" cy="219456"/>
+          </a:xfrm>
+          <a:prstGeom prst="ellipse">
+            <a:avLst/>
+          </a:prstGeom>
+          <a:noFill/>
+          <a:ln w="12700">
+            <a:solidFill>
+              <a:srgbClr val="3B4A7A"/>
+            </a:solidFill>
+          </a:ln>
+          <a:effectLst/>
+        </p:spPr>
+        <p:style>
+          <a:lnRef idx="1">
+            <a:schemeClr val="accent1"/>
+          </a:lnRef>
+          <a:fillRef idx="3">
+            <a:schemeClr val="accent1"/>
+          </a:fillRef>
+          <a:effectRef idx="2">
+            <a:schemeClr val="accent1"/>
+          </a:effectRef>
+          <a:fontRef idx="minor">
+            <a:schemeClr val="lt1"/>
+          </a:fontRef>
+        </p:style>
+        <p:txBody>
+          <a:bodyPr rtlCol="0" anchor="ctr"/>
+          <a:lstStyle/>
+          <a:p>
+            <a:pPr algn="ctr"/>
+          </a:p>
+        </p:txBody>
+      </p:sp>
+      <p:sp>
+        <p:nvSpPr>
+          <p:cNvPr id="4" name="Oval 3"/>
+          <p:cNvSpPr/>
+          <p:nvPr/>
+        </p:nvSpPr>
+        <p:spPr>
+          <a:xfrm>
+            <a:off x="594360" y="521207"/>
+            <a:ext cx="91440" cy="91440"/>
+          </a:xfrm>
+          <a:prstGeom prst="ellipse">
+            <a:avLst/>
+          </a:prstGeom>
+          <a:solidFill>
+            <a:srgbClr val="C9821E"/>
+          </a:solidFill>
+          <a:ln>
+            <a:noFill/>
+          </a:ln>
+          <a:effectLst/>
+        </p:spPr>
+        <p:style>
+          <a:lnRef idx="1">
+            <a:schemeClr val="accent1"/>
+          </a:lnRef>
+          <a:fillRef idx="3">
+            <a:schemeClr val="accent1"/>
+          </a:fillRef>
+          <a:effectRef idx="2">
+            <a:schemeClr val="accent1"/>
+          </a:effectRef>
+          <a:fontRef idx="minor">
+            <a:schemeClr val="lt1"/>
+          </a:fontRef>
+        </p:style>
+        <p:txBody>
+          <a:bodyPr rtlCol="0" anchor="ctr"/>
+          <a:lstStyle/>
+          <a:p>
+            <a:pPr algn="ctr"/>
+          </a:p>
+        </p:txBody>
+      </p:sp>
+      <p:sp>
+        <p:nvSpPr>
+          <p:cNvPr id="5" name="TextBox 4"/>
+          <p:cNvSpPr txBox="1"/>
+          <p:nvPr/>
+        </p:nvSpPr>
+        <p:spPr>
+          <a:xfrm>
+            <a:off x="960120" y="256032"/>
+            <a:ext cx="7680960" cy="237744"/>
+          </a:xfrm>
+          <a:prstGeom prst="rect">
+            <a:avLst/>
+          </a:prstGeom>
+          <a:noFill/>
+        </p:spPr>
+        <p:txBody>
+          <a:bodyPr wrap="square" lIns="0" rIns="0" tIns="0" bIns="0" anchor="ctr">
+            <a:spAutoFit/>
+          </a:bodyPr>
+          <a:lstStyle/>
+          <a:p>
+            <a:pPr>
+              <a:spcAft>
+                <a:spcPts val="0"/>
+              </a:spcAft>
+            </a:pPr>
+            <a:r>
+              <a:rPr sz="1050" b="1" i="0">
+                <a:solidFill>
+                  <a:srgbClr val="9A6414"/>
+                </a:solidFill>
+                <a:latin typeface="Calibri"/>
+              </a:rPr>
+              <a:t>V  ·  BEYOND DATABASES  ·  §8.2</a:t>
+            </a:r>
+          </a:p>
+        </p:txBody>
+      </p:sp>
+      <p:sp>
+        <p:nvSpPr>
+          <p:cNvPr id="6" name="TextBox 5"/>
+          <p:cNvSpPr txBox="1"/>
+          <p:nvPr/>
+        </p:nvSpPr>
+        <p:spPr>
+          <a:xfrm>
+            <a:off x="960120" y="457200"/>
+            <a:ext cx="7726679" cy="566928"/>
+          </a:xfrm>
+          <a:prstGeom prst="rect">
+            <a:avLst/>
+          </a:prstGeom>
+          <a:noFill/>
+        </p:spPr>
+        <p:txBody>
+          <a:bodyPr wrap="square" lIns="0" rIns="0" tIns="0" bIns="0" anchor="ctr">
+            <a:spAutoFit/>
+          </a:bodyPr>
+          <a:lstStyle/>
+          <a:p>
+            <a:pPr>
+              <a:spcAft>
+                <a:spcPts val="0"/>
+              </a:spcAft>
+            </a:pPr>
+            <a:r>
+              <a:rPr sz="3000" b="1" i="0">
+                <a:solidFill>
+                  <a:srgbClr val="1E2447"/>
+                </a:solidFill>
+                <a:latin typeface="Cambria"/>
+              </a:rPr>
+              <a:t>Why Databases Alone Are Not Enough</a:t>
+            </a:r>
+          </a:p>
+        </p:txBody>
+      </p:sp>
+      <p:sp>
+        <p:nvSpPr>
+          <p:cNvPr id="7" name="Rounded Rectangle 6"/>
+          <p:cNvSpPr/>
+          <p:nvPr/>
+        </p:nvSpPr>
+        <p:spPr>
+          <a:xfrm>
+            <a:off x="640080" y="1280160"/>
+            <a:ext cx="3840480" cy="1417320"/>
+          </a:xfrm>
+          <a:prstGeom prst="roundRect">
+            <a:avLst>
+              <a:gd name="adj" fmla="val 7000"/>
+            </a:avLst>
+          </a:prstGeom>
+          <a:solidFill>
+            <a:srgbClr val="EEF1F8"/>
+          </a:solidFill>
+          <a:ln>
+            <a:noFill/>
+          </a:ln>
+          <a:effectLst/>
+        </p:spPr>
+        <p:style>
+          <a:lnRef idx="1">
+            <a:schemeClr val="accent1"/>
+          </a:lnRef>
+          <a:fillRef idx="3">
+            <a:schemeClr val="accent1"/>
+          </a:fillRef>
+          <a:effectRef idx="2">
+            <a:schemeClr val="accent1"/>
+          </a:effectRef>
+          <a:fontRef idx="minor">
+            <a:schemeClr val="lt1"/>
+          </a:fontRef>
+        </p:style>
+        <p:txBody>
+          <a:bodyPr rtlCol="0" anchor="ctr"/>
+          <a:lstStyle/>
+          <a:p>
+            <a:pPr algn="ctr"/>
+          </a:p>
+        </p:txBody>
+      </p:sp>
+      <p:sp>
+        <p:nvSpPr>
+          <p:cNvPr id="8" name="TextBox 7"/>
+          <p:cNvSpPr txBox="1"/>
+          <p:nvPr/>
+        </p:nvSpPr>
+        <p:spPr>
+          <a:xfrm>
+            <a:off x="822959" y="1399031"/>
+            <a:ext cx="3474720" cy="274320"/>
+          </a:xfrm>
+          <a:prstGeom prst="rect">
+            <a:avLst/>
+          </a:prstGeom>
+          <a:noFill/>
+        </p:spPr>
+        <p:txBody>
+          <a:bodyPr wrap="square" lIns="0" rIns="0" tIns="0" bIns="0" anchor="ctr">
+            <a:spAutoFit/>
+          </a:bodyPr>
+          <a:lstStyle/>
+          <a:p>
+            <a:pPr>
+              <a:spcAft>
+                <a:spcPts val="0"/>
+              </a:spcAft>
+            </a:pPr>
+            <a:r>
+              <a:rPr sz="1300" b="1" i="0">
+                <a:solidFill>
+                  <a:srgbClr val="1E2447"/>
+                </a:solidFill>
+                <a:latin typeface="Cambria"/>
+              </a:rPr>
+              <a:t>Part-time governance constraint</a:t>
+            </a:r>
+          </a:p>
+        </p:txBody>
+      </p:sp>
+      <p:sp>
+        <p:nvSpPr>
+          <p:cNvPr id="9" name="TextBox 8"/>
+          <p:cNvSpPr txBox="1"/>
+          <p:nvPr/>
+        </p:nvSpPr>
+        <p:spPr>
+          <a:xfrm>
+            <a:off x="822959" y="1719072"/>
+            <a:ext cx="3474720" cy="868680"/>
+          </a:xfrm>
+          <a:prstGeom prst="rect">
+            <a:avLst/>
+          </a:prstGeom>
+          <a:noFill/>
+        </p:spPr>
+        <p:txBody>
+          <a:bodyPr wrap="square" lIns="0" rIns="0" tIns="0" bIns="0" anchor="t">
+            <a:spAutoFit/>
+          </a:bodyPr>
+          <a:lstStyle/>
+          <a:p>
+            <a:pPr>
+              <a:spcAft>
+                <a:spcPts val="0"/>
+              </a:spcAft>
+            </a:pPr>
+            <a:r>
+              <a:rPr sz="1150" b="0" i="0">
+                <a:solidFill>
+                  <a:srgbClr val="5A6377"/>
+                </a:solidFill>
+                <a:latin typeface="Calibri"/>
+              </a:rPr>
+              <a:t>Councils serve part-time while producing (AA p. 127) and the exchange-reserve has 3 staff (p. 138); manual databases would force a bureaucracy.</a:t>
+            </a:r>
+          </a:p>
+        </p:txBody>
+      </p:sp>
+      <p:sp>
+        <p:nvSpPr>
+          <p:cNvPr id="10" name="Rounded Rectangle 9"/>
+          <p:cNvSpPr/>
+          <p:nvPr/>
+        </p:nvSpPr>
+        <p:spPr>
+          <a:xfrm>
+            <a:off x="4663440" y="1280160"/>
+            <a:ext cx="3840480" cy="1417320"/>
+          </a:xfrm>
+          <a:prstGeom prst="roundRect">
+            <a:avLst>
+              <a:gd name="adj" fmla="val 7000"/>
+            </a:avLst>
+          </a:prstGeom>
+          <a:solidFill>
+            <a:srgbClr val="EEF1F8"/>
+          </a:solidFill>
+          <a:ln>
+            <a:noFill/>
+          </a:ln>
+          <a:effectLst/>
+        </p:spPr>
+        <p:style>
+          <a:lnRef idx="1">
+            <a:schemeClr val="accent1"/>
+          </a:lnRef>
+          <a:fillRef idx="3">
+            <a:schemeClr val="accent1"/>
+          </a:fillRef>
+          <a:effectRef idx="2">
+            <a:schemeClr val="accent1"/>
+          </a:effectRef>
+          <a:fontRef idx="minor">
+            <a:schemeClr val="lt1"/>
+          </a:fontRef>
+        </p:style>
+        <p:txBody>
+          <a:bodyPr rtlCol="0" anchor="ctr"/>
+          <a:lstStyle/>
+          <a:p>
+            <a:pPr algn="ctr"/>
+          </a:p>
+        </p:txBody>
+      </p:sp>
+      <p:sp>
+        <p:nvSpPr>
+          <p:cNvPr id="11" name="TextBox 10"/>
+          <p:cNvSpPr txBox="1"/>
+          <p:nvPr/>
+        </p:nvSpPr>
+        <p:spPr>
+          <a:xfrm>
+            <a:off x="4846320" y="1399031"/>
+            <a:ext cx="3474720" cy="274320"/>
+          </a:xfrm>
+          <a:prstGeom prst="rect">
+            <a:avLst/>
+          </a:prstGeom>
+          <a:noFill/>
+        </p:spPr>
+        <p:txBody>
+          <a:bodyPr wrap="square" lIns="0" rIns="0" tIns="0" bIns="0" anchor="ctr">
+            <a:spAutoFit/>
+          </a:bodyPr>
+          <a:lstStyle/>
+          <a:p>
+            <a:pPr>
+              <a:spcAft>
+                <a:spcPts val="0"/>
+              </a:spcAft>
+            </a:pPr>
+            <a:r>
+              <a:rPr sz="1300" b="1" i="0">
+                <a:solidFill>
+                  <a:srgbClr val="1E2447"/>
+                </a:solidFill>
+                <a:latin typeface="Cambria"/>
+              </a:rPr>
+              <a:t>Non-price calculation at scale</a:t>
+            </a:r>
+          </a:p>
+        </p:txBody>
+      </p:sp>
+      <p:sp>
+        <p:nvSpPr>
+          <p:cNvPr id="12" name="TextBox 11"/>
+          <p:cNvSpPr txBox="1"/>
+          <p:nvPr/>
+        </p:nvSpPr>
+        <p:spPr>
+          <a:xfrm>
+            <a:off x="4846320" y="1719072"/>
+            <a:ext cx="3474720" cy="868680"/>
+          </a:xfrm>
+          <a:prstGeom prst="rect">
+            <a:avLst/>
+          </a:prstGeom>
+          <a:noFill/>
+        </p:spPr>
+        <p:txBody>
+          <a:bodyPr wrap="square" lIns="0" rIns="0" tIns="0" bIns="0" anchor="t">
+            <a:spAutoFit/>
+          </a:bodyPr>
+          <a:lstStyle/>
+          <a:p>
+            <a:pPr>
+              <a:spcAft>
+                <a:spcPts val="0"/>
+              </a:spcAft>
+            </a:pPr>
+            <a:r>
+              <a:rPr sz="1150" b="0" i="0">
+                <a:solidFill>
+                  <a:srgbClr val="5A6377"/>
+                </a:solidFill>
+                <a:latin typeface="Calibri"/>
+              </a:rPr>
+              <a:t>Replacing prices across millions of inputs, tool depreciation and Ricardian soil differences needs active input–output and constraint solving.</a:t>
+            </a:r>
+          </a:p>
+        </p:txBody>
+      </p:sp>
+      <p:sp>
+        <p:nvSpPr>
+          <p:cNvPr id="13" name="Rounded Rectangle 12"/>
+          <p:cNvSpPr/>
+          <p:nvPr/>
+        </p:nvSpPr>
+        <p:spPr>
+          <a:xfrm>
+            <a:off x="640080" y="2880360"/>
+            <a:ext cx="3840480" cy="1280160"/>
+          </a:xfrm>
+          <a:prstGeom prst="roundRect">
+            <a:avLst>
+              <a:gd name="adj" fmla="val 7000"/>
+            </a:avLst>
+          </a:prstGeom>
+          <a:solidFill>
+            <a:srgbClr val="FAF1DF"/>
+          </a:solidFill>
+          <a:ln>
+            <a:noFill/>
+          </a:ln>
+          <a:effectLst/>
+        </p:spPr>
+        <p:style>
+          <a:lnRef idx="1">
+            <a:schemeClr val="accent1"/>
+          </a:lnRef>
+          <a:fillRef idx="3">
+            <a:schemeClr val="accent1"/>
+          </a:fillRef>
+          <a:effectRef idx="2">
+            <a:schemeClr val="accent1"/>
+          </a:effectRef>
+          <a:fontRef idx="minor">
+            <a:schemeClr val="lt1"/>
+          </a:fontRef>
+        </p:style>
+        <p:txBody>
+          <a:bodyPr rtlCol="0" anchor="ctr"/>
+          <a:lstStyle/>
+          <a:p>
+            <a:pPr algn="ctr"/>
+          </a:p>
+        </p:txBody>
+      </p:sp>
+      <p:sp>
+        <p:nvSpPr>
+          <p:cNvPr id="14" name="TextBox 13"/>
+          <p:cNvSpPr txBox="1"/>
+          <p:nvPr/>
+        </p:nvSpPr>
+        <p:spPr>
+          <a:xfrm>
+            <a:off x="822959" y="2999232"/>
+            <a:ext cx="3474720" cy="274320"/>
+          </a:xfrm>
+          <a:prstGeom prst="rect">
+            <a:avLst/>
+          </a:prstGeom>
+          <a:noFill/>
+        </p:spPr>
+        <p:txBody>
+          <a:bodyPr wrap="square" lIns="0" rIns="0" tIns="0" bIns="0" anchor="ctr">
+            <a:spAutoFit/>
+          </a:bodyPr>
+          <a:lstStyle/>
+          <a:p>
+            <a:pPr>
+              <a:spcAft>
+                <a:spcPts val="0"/>
+              </a:spcAft>
+            </a:pPr>
+            <a:r>
+              <a:rPr sz="1300" b="1" i="0">
+                <a:solidFill>
+                  <a:srgbClr val="9A6414"/>
+                </a:solidFill>
+                <a:latin typeface="Cambria"/>
+              </a:rPr>
+              <a:t>Qualitative to quantitative</a:t>
+            </a:r>
+          </a:p>
+        </p:txBody>
+      </p:sp>
+      <p:sp>
+        <p:nvSpPr>
+          <p:cNvPr id="15" name="TextBox 14"/>
+          <p:cNvSpPr txBox="1"/>
+          <p:nvPr/>
+        </p:nvSpPr>
+        <p:spPr>
+          <a:xfrm>
+            <a:off x="822959" y="3319271"/>
+            <a:ext cx="3474720" cy="731519"/>
+          </a:xfrm>
+          <a:prstGeom prst="rect">
+            <a:avLst/>
+          </a:prstGeom>
+          <a:noFill/>
+        </p:spPr>
+        <p:txBody>
+          <a:bodyPr wrap="square" lIns="0" rIns="0" tIns="0" bIns="0" anchor="t">
+            <a:spAutoFit/>
+          </a:bodyPr>
+          <a:lstStyle/>
+          <a:p>
+            <a:pPr>
+              <a:spcAft>
+                <a:spcPts val="0"/>
+              </a:spcAft>
+            </a:pPr>
+            <a:r>
+              <a:rPr sz="1150" b="0" i="0">
+                <a:solidFill>
+                  <a:srgbClr val="5A6377"/>
+                </a:solidFill>
+                <a:latin typeface="Calibri"/>
+              </a:rPr>
+              <a:t>Village surveys, family needs and skill plans combine numbers with local language; intelligent agents keep producers from becoming clerks.</a:t>
+            </a:r>
+          </a:p>
+        </p:txBody>
+      </p:sp>
+      <p:sp>
+        <p:nvSpPr>
+          <p:cNvPr id="16" name="Rounded Rectangle 15"/>
+          <p:cNvSpPr/>
+          <p:nvPr/>
+        </p:nvSpPr>
+        <p:spPr>
+          <a:xfrm>
+            <a:off x="4663440" y="2880360"/>
+            <a:ext cx="3840480" cy="1280160"/>
+          </a:xfrm>
+          <a:prstGeom prst="roundRect">
+            <a:avLst>
+              <a:gd name="adj" fmla="val 7000"/>
+            </a:avLst>
+          </a:prstGeom>
+          <a:solidFill>
+            <a:srgbClr val="FAF1DF"/>
+          </a:solidFill>
+          <a:ln>
+            <a:noFill/>
+          </a:ln>
+          <a:effectLst/>
+        </p:spPr>
+        <p:style>
+          <a:lnRef idx="1">
+            <a:schemeClr val="accent1"/>
+          </a:lnRef>
+          <a:fillRef idx="3">
+            <a:schemeClr val="accent1"/>
+          </a:fillRef>
+          <a:effectRef idx="2">
+            <a:schemeClr val="accent1"/>
+          </a:effectRef>
+          <a:fontRef idx="minor">
+            <a:schemeClr val="lt1"/>
+          </a:fontRef>
+        </p:style>
+        <p:txBody>
+          <a:bodyPr rtlCol="0" anchor="ctr"/>
+          <a:lstStyle/>
+          <a:p>
+            <a:pPr algn="ctr"/>
+          </a:p>
+        </p:txBody>
+      </p:sp>
+      <p:sp>
+        <p:nvSpPr>
+          <p:cNvPr id="17" name="TextBox 16"/>
+          <p:cNvSpPr txBox="1"/>
+          <p:nvPr/>
+        </p:nvSpPr>
+        <p:spPr>
+          <a:xfrm>
+            <a:off x="4846320" y="2999232"/>
+            <a:ext cx="3474720" cy="274320"/>
+          </a:xfrm>
+          <a:prstGeom prst="rect">
+            <a:avLst/>
+          </a:prstGeom>
+          <a:noFill/>
+        </p:spPr>
+        <p:txBody>
+          <a:bodyPr wrap="square" lIns="0" rIns="0" tIns="0" bIns="0" anchor="ctr">
+            <a:spAutoFit/>
+          </a:bodyPr>
+          <a:lstStyle/>
+          <a:p>
+            <a:pPr>
+              <a:spcAft>
+                <a:spcPts val="0"/>
+              </a:spcAft>
+            </a:pPr>
+            <a:r>
+              <a:rPr sz="1300" b="1" i="0">
+                <a:solidFill>
+                  <a:srgbClr val="9A6414"/>
+                </a:solidFill>
+                <a:latin typeface="Cambria"/>
+              </a:rPr>
+              <a:t>Transition before full awakening</a:t>
+            </a:r>
+          </a:p>
+        </p:txBody>
+      </p:sp>
+      <p:sp>
+        <p:nvSpPr>
+          <p:cNvPr id="18" name="TextBox 17"/>
+          <p:cNvSpPr txBox="1"/>
+          <p:nvPr/>
+        </p:nvSpPr>
+        <p:spPr>
+          <a:xfrm>
+            <a:off x="4846320" y="3319271"/>
+            <a:ext cx="3474720" cy="731519"/>
+          </a:xfrm>
+          <a:prstGeom prst="rect">
+            <a:avLst/>
+          </a:prstGeom>
+          <a:noFill/>
+        </p:spPr>
+        <p:txBody>
+          <a:bodyPr wrap="square" lIns="0" rIns="0" tIns="0" bIns="0" anchor="t">
+            <a:spAutoFit/>
+          </a:bodyPr>
+          <a:lstStyle/>
+          <a:p>
+            <a:pPr>
+              <a:spcAft>
+                <a:spcPts val="0"/>
+              </a:spcAft>
+            </a:pPr>
+            <a:r>
+              <a:rPr sz="1150" b="0" i="0">
+                <a:solidFill>
+                  <a:srgbClr val="5A6377"/>
+                </a:solidFill>
+                <a:latin typeface="Calibri"/>
+              </a:rPr>
+              <a:t>Anubhav-gami people and villages need real-time mirrors and dual currency/labour ledgers across the 3 stages (AA pp. 142–143).</a:t>
+            </a:r>
+          </a:p>
+        </p:txBody>
+      </p:sp>
+      <p:sp>
+        <p:nvSpPr>
+          <p:cNvPr id="19" name="TextBox 18"/>
+          <p:cNvSpPr txBox="1"/>
+          <p:nvPr/>
+        </p:nvSpPr>
+        <p:spPr>
+          <a:xfrm>
+            <a:off x="640080" y="4279392"/>
+            <a:ext cx="7863840" cy="329184"/>
+          </a:xfrm>
+          <a:prstGeom prst="rect">
+            <a:avLst/>
+          </a:prstGeom>
+          <a:noFill/>
+        </p:spPr>
+        <p:txBody>
+          <a:bodyPr wrap="square" lIns="0" rIns="0" tIns="0" bIns="0" anchor="ctr">
+            <a:spAutoFit/>
+          </a:bodyPr>
+          <a:lstStyle/>
+          <a:p>
+            <a:pPr>
+              <a:spcAft>
+                <a:spcPts val="0"/>
+              </a:spcAft>
+            </a:pPr>
+            <a:r>
+              <a:rPr sz="1150" b="0" i="1">
+                <a:solidFill>
+                  <a:srgbClr val="1E2447"/>
+                </a:solidFill>
+                <a:latin typeface="Calibri"/>
+              </a:rPr>
+              <a:t>Passive databases only store records after the fact; intelligent agents are needed as core transition infrastructure.</a:t>
+            </a:r>
+          </a:p>
+        </p:txBody>
+      </p:sp>
+      <p:sp>
+        <p:nvSpPr>
+          <p:cNvPr id="20" name="TextBox 19"/>
+          <p:cNvSpPr txBox="1"/>
+          <p:nvPr/>
+        </p:nvSpPr>
+        <p:spPr>
+          <a:xfrm>
+            <a:off x="502920" y="4828032"/>
+            <a:ext cx="8138160" cy="256032"/>
+          </a:xfrm>
+          <a:prstGeom prst="rect">
+            <a:avLst/>
+          </a:prstGeom>
+          <a:noFill/>
+        </p:spPr>
+        <p:txBody>
+          <a:bodyPr wrap="square" lIns="0" rIns="0" tIns="0" bIns="0" anchor="ctr">
+            <a:spAutoFit/>
+          </a:bodyPr>
+          <a:lstStyle/>
+          <a:p>
+            <a:pPr>
+              <a:spcAft>
+                <a:spcPts val="0"/>
+              </a:spcAft>
+            </a:pPr>
+            <a:r>
+              <a:rPr sz="950" b="0" i="1">
+                <a:solidFill>
+                  <a:srgbClr val="5A6377"/>
+                </a:solidFill>
+                <a:latin typeface="Calibri"/>
+              </a:rPr>
+              <a:t>Study §8.2  ·  AA pp. 72, 107, 122–127, 131–132, 136–138, 142–149  ·  MVD p. 259  ·  JVD p. 35  ·  27 / 33</a:t>
+            </a:r>
+          </a:p>
+        </p:txBody>
+      </p:sp>
+      <p:sp>
+        <p:nvSpPr>
+          <p:cNvPr id="7" name="Rounded Rectangle 6"/>
+          <p:cNvSpPr/>
+          <p:nvPr/>
+        </p:nvSpPr>
+        <p:spPr>
+          <a:xfrm>
+            <a:off x="7031736" y="1042415"/>
+            <a:ext cx="1463040" cy="182880"/>
+          </a:xfrm>
+          <a:prstGeom prst="roundRect">
+            <a:avLst>
+              <a:gd name="adj" fmla="val 7000"/>
+            </a:avLst>
+          </a:prstGeom>
+          <a:solidFill>
+            <a:srgbClr val="C9821E"/>
+          </a:solidFill>
+          <a:ln>
+            <a:noFill/>
+          </a:ln>
+          <a:effectLst/>
+        </p:spPr>
+        <p:style>
+          <a:lnRef idx="1">
+            <a:schemeClr val="accent1"/>
+          </a:lnRef>
+          <a:fillRef idx="3">
+            <a:schemeClr val="accent1"/>
+          </a:fillRef>
+          <a:effectRef idx="2">
+            <a:schemeClr val="accent1"/>
+          </a:effectRef>
+          <a:fontRef idx="minor">
+            <a:schemeClr val="lt1"/>
+          </a:fontRef>
+        </p:style>
+        <p:txBody>
+          <a:bodyPr rtlCol="0" anchor="ctr"/>
+          <a:lstStyle/>
+          <a:p>
+            <a:pPr algn="ctr"/>
+          </a:p>
+        </p:txBody>
+      </p:sp>
+      <p:sp>
+        <p:nvSpPr>
+          <p:cNvPr id="8" name="TextBox 7"/>
+          <p:cNvSpPr txBox="1"/>
+          <p:nvPr/>
+        </p:nvSpPr>
+        <p:spPr>
+          <a:xfrm>
+            <a:off x="7031736" y="1042415"/>
+            <a:ext cx="1463040" cy="182880"/>
+          </a:xfrm>
+          <a:prstGeom prst="rect">
+            <a:avLst/>
+          </a:prstGeom>
+          <a:noFill/>
+        </p:spPr>
+        <p:txBody>
+          <a:bodyPr wrap="square" lIns="0" rIns="0" tIns="0" bIns="0" anchor="ctr">
+            <a:spAutoFit/>
+          </a:bodyPr>
+          <a:lstStyle/>
+          <a:p>
+            <a:pPr algn="ctr">
+              <a:spcAft>
+                <a:spcPts val="0"/>
+              </a:spcAft>
+            </a:pPr>
+            <a:r>
+              <a:rPr sz="750" b="1" i="0">
+                <a:solidFill>
+                  <a:srgbClr val="FFFFFF"/>
+                </a:solidFill>
+                <a:latin typeface="Calibri"/>
+              </a:rPr>
+              <a:t>THIS STUDY'S PROPOSAL</a:t>
+            </a:r>
+          </a:p>
+        </p:txBody>
+      </p:sp>
+    </p:spTree>
+  </p:cSld>
+  <p:clrMapOvr>
+    <a:masterClrMapping/>
+  </p:clrMapOvr>
+</p:sld>
+</file>
+
+<file path=ppt/slides/slide33.xml><?xml version="1.0" encoding="utf-8"?>
+<p:sld xmlns:a="http://schemas.openxmlformats.org/drawingml/2006/main" xmlns:p="http://schemas.openxmlformats.org/presentationml/2006/main" xmlns:r="http://schemas.openxmlformats.org/officeDocument/2006/relationships">
+  <p:cSld>
+    <p:spTree>
+      <p:nvGrpSpPr>
+        <p:cNvPr id="1" name=""/>
+        <p:cNvGrpSpPr/>
+        <p:nvPr/>
+      </p:nvGrpSpPr>
+      <p:grpSpPr/>
+      <p:sp>
+        <p:nvSpPr>
+          <p:cNvPr id="2" name="Oval 1"/>
+          <p:cNvSpPr/>
+          <p:nvPr/>
+        </p:nvSpPr>
+        <p:spPr>
+          <a:xfrm>
+            <a:off x="457200" y="384048"/>
+            <a:ext cx="365760" cy="365760"/>
+          </a:xfrm>
+          <a:prstGeom prst="ellipse">
+            <a:avLst/>
+          </a:prstGeom>
+          <a:noFill/>
+          <a:ln w="12700">
+            <a:solidFill>
+              <a:srgbClr val="3B4A7A"/>
+            </a:solidFill>
+          </a:ln>
+          <a:effectLst/>
+        </p:spPr>
+        <p:style>
+          <a:lnRef idx="1">
+            <a:schemeClr val="accent1"/>
+          </a:lnRef>
+          <a:fillRef idx="3">
+            <a:schemeClr val="accent1"/>
+          </a:fillRef>
+          <a:effectRef idx="2">
+            <a:schemeClr val="accent1"/>
+          </a:effectRef>
+          <a:fontRef idx="minor">
+            <a:schemeClr val="lt1"/>
+          </a:fontRef>
+        </p:style>
+        <p:txBody>
+          <a:bodyPr rtlCol="0" anchor="ctr"/>
+          <a:lstStyle/>
+          <a:p>
+            <a:pPr algn="ctr"/>
+          </a:p>
+        </p:txBody>
+      </p:sp>
+      <p:sp>
+        <p:nvSpPr>
+          <p:cNvPr id="3" name="Oval 2"/>
+          <p:cNvSpPr/>
+          <p:nvPr/>
+        </p:nvSpPr>
+        <p:spPr>
+          <a:xfrm>
+            <a:off x="530352" y="457200"/>
+            <a:ext cx="219456" cy="219456"/>
+          </a:xfrm>
+          <a:prstGeom prst="ellipse">
+            <a:avLst/>
+          </a:prstGeom>
+          <a:noFill/>
+          <a:ln w="12700">
+            <a:solidFill>
+              <a:srgbClr val="3B4A7A"/>
+            </a:solidFill>
+          </a:ln>
+          <a:effectLst/>
+        </p:spPr>
+        <p:style>
+          <a:lnRef idx="1">
+            <a:schemeClr val="accent1"/>
+          </a:lnRef>
+          <a:fillRef idx="3">
+            <a:schemeClr val="accent1"/>
+          </a:fillRef>
+          <a:effectRef idx="2">
+            <a:schemeClr val="accent1"/>
+          </a:effectRef>
+          <a:fontRef idx="minor">
+            <a:schemeClr val="lt1"/>
+          </a:fontRef>
+        </p:style>
+        <p:txBody>
+          <a:bodyPr rtlCol="0" anchor="ctr"/>
+          <a:lstStyle/>
+          <a:p>
+            <a:pPr algn="ctr"/>
+          </a:p>
+        </p:txBody>
+      </p:sp>
+      <p:sp>
+        <p:nvSpPr>
+          <p:cNvPr id="4" name="Oval 3"/>
+          <p:cNvSpPr/>
+          <p:nvPr/>
+        </p:nvSpPr>
+        <p:spPr>
+          <a:xfrm>
+            <a:off x="594360" y="521207"/>
+            <a:ext cx="91440" cy="91440"/>
+          </a:xfrm>
+          <a:prstGeom prst="ellipse">
+            <a:avLst/>
+          </a:prstGeom>
+          <a:solidFill>
+            <a:srgbClr val="C9821E"/>
+          </a:solidFill>
+          <a:ln>
+            <a:noFill/>
+          </a:ln>
+          <a:effectLst/>
+        </p:spPr>
+        <p:style>
+          <a:lnRef idx="1">
+            <a:schemeClr val="accent1"/>
+          </a:lnRef>
+          <a:fillRef idx="3">
+            <a:schemeClr val="accent1"/>
+          </a:fillRef>
+          <a:effectRef idx="2">
+            <a:schemeClr val="accent1"/>
+          </a:effectRef>
+          <a:fontRef idx="minor">
+            <a:schemeClr val="lt1"/>
+          </a:fontRef>
+        </p:style>
+        <p:txBody>
+          <a:bodyPr rtlCol="0" anchor="ctr"/>
+          <a:lstStyle/>
+          <a:p>
+            <a:pPr algn="ctr"/>
+          </a:p>
+        </p:txBody>
+      </p:sp>
+      <p:sp>
+        <p:nvSpPr>
+          <p:cNvPr id="5" name="TextBox 4"/>
+          <p:cNvSpPr txBox="1"/>
+          <p:nvPr/>
+        </p:nvSpPr>
+        <p:spPr>
+          <a:xfrm>
+            <a:off x="960120" y="256032"/>
+            <a:ext cx="7680960" cy="237744"/>
+          </a:xfrm>
+          <a:prstGeom prst="rect">
+            <a:avLst/>
+          </a:prstGeom>
+          <a:noFill/>
+        </p:spPr>
+        <p:txBody>
+          <a:bodyPr wrap="square" lIns="0" rIns="0" tIns="0" bIns="0" anchor="ctr">
+            <a:spAutoFit/>
+          </a:bodyPr>
+          <a:lstStyle/>
+          <a:p>
+            <a:pPr>
+              <a:spcAft>
+                <a:spcPts val="0"/>
+              </a:spcAft>
+            </a:pPr>
+            <a:r>
+              <a:rPr sz="1050" b="1" i="0">
+                <a:solidFill>
+                  <a:srgbClr val="9A6414"/>
+                </a:solidFill>
+                <a:latin typeface="Calibri"/>
+              </a:rPr>
+              <a:t>V  ·  MULTI-LEVEL AGENTS  ·  §8.3</a:t>
+            </a:r>
+          </a:p>
+        </p:txBody>
+      </p:sp>
+      <p:sp>
+        <p:nvSpPr>
+          <p:cNvPr id="6" name="TextBox 5"/>
+          <p:cNvSpPr txBox="1"/>
+          <p:nvPr/>
+        </p:nvSpPr>
+        <p:spPr>
+          <a:xfrm>
+            <a:off x="960120" y="457200"/>
+            <a:ext cx="7726679" cy="566928"/>
+          </a:xfrm>
+          <a:prstGeom prst="rect">
+            <a:avLst/>
+          </a:prstGeom>
+          <a:noFill/>
+        </p:spPr>
+        <p:txBody>
+          <a:bodyPr wrap="square" lIns="0" rIns="0" tIns="0" bIns="0" anchor="ctr">
+            <a:spAutoFit/>
+          </a:bodyPr>
+          <a:lstStyle/>
+          <a:p>
+            <a:pPr>
+              <a:spcAft>
+                <a:spcPts val="0"/>
+              </a:spcAft>
+            </a:pPr>
+            <a:r>
+              <a:rPr sz="3000" b="1" i="0">
+                <a:solidFill>
+                  <a:srgbClr val="1E2447"/>
+                </a:solidFill>
+                <a:latin typeface="Cambria"/>
+              </a:rPr>
+              <a:t>AI Agents Across the Ten-Tier Order</a:t>
+            </a:r>
+          </a:p>
+        </p:txBody>
+      </p:sp>
+      <p:sp>
+        <p:nvSpPr>
+          <p:cNvPr id="7" name="Rounded Rectangle 6"/>
+          <p:cNvSpPr/>
+          <p:nvPr/>
+        </p:nvSpPr>
+        <p:spPr>
+          <a:xfrm>
+            <a:off x="7031736" y="1042415"/>
+            <a:ext cx="1463040" cy="182880"/>
+          </a:xfrm>
+          <a:prstGeom prst="roundRect">
+            <a:avLst>
+              <a:gd name="adj" fmla="val 7000"/>
+            </a:avLst>
+          </a:prstGeom>
+          <a:solidFill>
+            <a:srgbClr val="C9821E"/>
+          </a:solidFill>
+          <a:ln>
+            <a:noFill/>
+          </a:ln>
+          <a:effectLst/>
+        </p:spPr>
+        <p:style>
+          <a:lnRef idx="1">
+            <a:schemeClr val="accent1"/>
+          </a:lnRef>
+          <a:fillRef idx="3">
+            <a:schemeClr val="accent1"/>
+          </a:fillRef>
+          <a:effectRef idx="2">
+            <a:schemeClr val="accent1"/>
+          </a:effectRef>
+          <a:fontRef idx="minor">
+            <a:schemeClr val="lt1"/>
+          </a:fontRef>
+        </p:style>
+        <p:txBody>
+          <a:bodyPr rtlCol="0" anchor="ctr"/>
+          <a:lstStyle/>
+          <a:p>
+            <a:pPr algn="ctr"/>
+          </a:p>
+        </p:txBody>
+      </p:sp>
+      <p:sp>
+        <p:nvSpPr>
+          <p:cNvPr id="8" name="TextBox 7"/>
+          <p:cNvSpPr txBox="1"/>
+          <p:nvPr/>
+        </p:nvSpPr>
+        <p:spPr>
+          <a:xfrm>
+            <a:off x="7031736" y="1042415"/>
+            <a:ext cx="1463040" cy="182880"/>
+          </a:xfrm>
+          <a:prstGeom prst="rect">
+            <a:avLst/>
+          </a:prstGeom>
+          <a:noFill/>
+        </p:spPr>
+        <p:txBody>
+          <a:bodyPr wrap="square" lIns="0" rIns="0" tIns="0" bIns="0" anchor="ctr">
+            <a:spAutoFit/>
+          </a:bodyPr>
+          <a:lstStyle/>
+          <a:p>
+            <a:pPr algn="ctr">
+              <a:spcAft>
+                <a:spcPts val="0"/>
+              </a:spcAft>
+            </a:pPr>
+            <a:r>
+              <a:rPr sz="750" b="1" i="0">
+                <a:solidFill>
+                  <a:srgbClr val="FFFFFF"/>
+                </a:solidFill>
+                <a:latin typeface="Calibri"/>
+              </a:rPr>
+              <a:t>THIS STUDY'S PROPOSAL</a:t>
+            </a:r>
+          </a:p>
+        </p:txBody>
+      </p:sp>
+      <p:sp>
+        <p:nvSpPr>
+          <p:cNvPr id="9" name="Rectangle 8"/>
+          <p:cNvSpPr/>
+          <p:nvPr/>
+        </p:nvSpPr>
+        <p:spPr>
+          <a:xfrm>
+            <a:off x="640080" y="1280160"/>
+            <a:ext cx="7863840" cy="292608"/>
+          </a:xfrm>
+          <a:prstGeom prst="rect">
+            <a:avLst/>
+          </a:prstGeom>
+          <a:solidFill>
+            <a:srgbClr val="1E2447"/>
+          </a:solidFill>
+          <a:ln>
+            <a:noFill/>
+          </a:ln>
+          <a:effectLst/>
+        </p:spPr>
+        <p:style>
+          <a:lnRef idx="1">
+            <a:schemeClr val="accent1"/>
+          </a:lnRef>
+          <a:fillRef idx="3">
+            <a:schemeClr val="accent1"/>
+          </a:fillRef>
+          <a:effectRef idx="2">
+            <a:schemeClr val="accent1"/>
+          </a:effectRef>
+          <a:fontRef idx="minor">
+            <a:schemeClr val="lt1"/>
+          </a:fontRef>
+        </p:style>
+        <p:txBody>
+          <a:bodyPr rtlCol="0" anchor="ctr"/>
+          <a:lstStyle/>
+          <a:p>
+            <a:pPr algn="ctr"/>
+          </a:p>
+        </p:txBody>
+      </p:sp>
+      <p:sp>
+        <p:nvSpPr>
+          <p:cNvPr id="10" name="TextBox 9"/>
+          <p:cNvSpPr txBox="1"/>
+          <p:nvPr/>
+        </p:nvSpPr>
+        <p:spPr>
+          <a:xfrm>
+            <a:off x="731519" y="1280160"/>
+            <a:ext cx="2103120" cy="292608"/>
+          </a:xfrm>
+          <a:prstGeom prst="rect">
+            <a:avLst/>
+          </a:prstGeom>
+          <a:noFill/>
+        </p:spPr>
+        <p:txBody>
+          <a:bodyPr wrap="square" lIns="0" rIns="0" tIns="0" bIns="0" anchor="ctr">
+            <a:spAutoFit/>
+          </a:bodyPr>
+          <a:lstStyle/>
+          <a:p>
+            <a:pPr>
+              <a:spcAft>
+                <a:spcPts val="0"/>
+              </a:spcAft>
+            </a:pPr>
+            <a:r>
+              <a:rPr sz="1050" b="1" i="0">
+                <a:solidFill>
+                  <a:srgbClr val="FFFFFF"/>
+                </a:solidFill>
+                <a:latin typeface="Calibri"/>
+              </a:rPr>
+              <a:t>Human unit</a:t>
+            </a:r>
+          </a:p>
+        </p:txBody>
+      </p:sp>
+      <p:sp>
+        <p:nvSpPr>
+          <p:cNvPr id="11" name="TextBox 10"/>
+          <p:cNvSpPr txBox="1"/>
+          <p:nvPr/>
+        </p:nvSpPr>
+        <p:spPr>
+          <a:xfrm>
+            <a:off x="2971800" y="1280160"/>
+            <a:ext cx="2651760" cy="292608"/>
+          </a:xfrm>
+          <a:prstGeom prst="rect">
+            <a:avLst/>
+          </a:prstGeom>
+          <a:noFill/>
+        </p:spPr>
+        <p:txBody>
+          <a:bodyPr wrap="square" lIns="0" rIns="0" tIns="0" bIns="0" anchor="ctr">
+            <a:spAutoFit/>
+          </a:bodyPr>
+          <a:lstStyle/>
+          <a:p>
+            <a:pPr>
+              <a:spcAft>
+                <a:spcPts val="0"/>
+              </a:spcAft>
+            </a:pPr>
+            <a:r>
+              <a:rPr sz="1050" b="1" i="0">
+                <a:solidFill>
+                  <a:srgbClr val="FFFFFF"/>
+                </a:solidFill>
+                <a:latin typeface="Calibri"/>
+              </a:rPr>
+              <a:t>Paired AI agent &amp; role in the cycle</a:t>
+            </a:r>
+          </a:p>
+        </p:txBody>
+      </p:sp>
+      <p:sp>
+        <p:nvSpPr>
+          <p:cNvPr id="12" name="TextBox 11"/>
+          <p:cNvSpPr txBox="1"/>
+          <p:nvPr/>
+        </p:nvSpPr>
+        <p:spPr>
+          <a:xfrm>
+            <a:off x="5760720" y="1280160"/>
+            <a:ext cx="2697480" cy="292608"/>
+          </a:xfrm>
+          <a:prstGeom prst="rect">
+            <a:avLst/>
+          </a:prstGeom>
+          <a:noFill/>
+        </p:spPr>
+        <p:txBody>
+          <a:bodyPr wrap="square" lIns="0" rIns="0" tIns="0" bIns="0" anchor="ctr">
+            <a:spAutoFit/>
+          </a:bodyPr>
+          <a:lstStyle/>
+          <a:p>
+            <a:pPr>
+              <a:spcAft>
+                <a:spcPts val="0"/>
+              </a:spcAft>
+            </a:pPr>
+            <a:r>
+              <a:rPr sz="1050" b="1" i="0">
+                <a:solidFill>
+                  <a:srgbClr val="FFFFFF"/>
+                </a:solidFill>
+                <a:latin typeface="Calibri"/>
+              </a:rPr>
+              <a:t>Judgement kept by people</a:t>
+            </a:r>
+          </a:p>
+        </p:txBody>
+      </p:sp>
+      <p:sp>
+        <p:nvSpPr>
+          <p:cNvPr id="13" name="Rectangle 12"/>
+          <p:cNvSpPr/>
+          <p:nvPr/>
+        </p:nvSpPr>
+        <p:spPr>
+          <a:xfrm>
+            <a:off x="640080" y="1572768"/>
+            <a:ext cx="7863840" cy="402336"/>
+          </a:xfrm>
+          <a:prstGeom prst="rect">
+            <a:avLst/>
+          </a:prstGeom>
+          <a:solidFill>
+            <a:srgbClr val="EEF1F8"/>
+          </a:solidFill>
+          <a:ln>
+            <a:noFill/>
+          </a:ln>
+          <a:effectLst/>
+        </p:spPr>
+        <p:style>
+          <a:lnRef idx="1">
+            <a:schemeClr val="accent1"/>
+          </a:lnRef>
+          <a:fillRef idx="3">
+            <a:schemeClr val="accent1"/>
+          </a:fillRef>
+          <a:effectRef idx="2">
+            <a:schemeClr val="accent1"/>
+          </a:effectRef>
+          <a:fontRef idx="minor">
+            <a:schemeClr val="lt1"/>
+          </a:fontRef>
+        </p:style>
+        <p:txBody>
+          <a:bodyPr rtlCol="0" anchor="ctr"/>
+          <a:lstStyle/>
+          <a:p>
+            <a:pPr algn="ctr"/>
+          </a:p>
+        </p:txBody>
+      </p:sp>
+      <p:sp>
+        <p:nvSpPr>
+          <p:cNvPr id="14" name="Rectangle 13"/>
+          <p:cNvSpPr/>
+          <p:nvPr/>
+        </p:nvSpPr>
+        <p:spPr>
+          <a:xfrm>
+            <a:off x="640080" y="1965960"/>
+            <a:ext cx="7863840" cy="9144"/>
+          </a:xfrm>
+          <a:prstGeom prst="rect">
+            <a:avLst/>
+          </a:prstGeom>
+          <a:solidFill>
+            <a:srgbClr val="D5DBEA"/>
+          </a:solidFill>
+          <a:ln>
+            <a:noFill/>
+          </a:ln>
+          <a:effectLst/>
+        </p:spPr>
+        <p:style>
+          <a:lnRef idx="1">
+            <a:schemeClr val="accent1"/>
+          </a:lnRef>
+          <a:fillRef idx="3">
+            <a:schemeClr val="accent1"/>
+          </a:fillRef>
+          <a:effectRef idx="2">
+            <a:schemeClr val="accent1"/>
+          </a:effectRef>
+          <a:fontRef idx="minor">
+            <a:schemeClr val="lt1"/>
+          </a:fontRef>
+        </p:style>
+        <p:txBody>
+          <a:bodyPr rtlCol="0" anchor="ctr"/>
+          <a:lstStyle/>
+          <a:p>
+            <a:pPr algn="ctr"/>
+          </a:p>
+        </p:txBody>
+      </p:sp>
+      <p:sp>
+        <p:nvSpPr>
+          <p:cNvPr id="15" name="TextBox 14"/>
+          <p:cNvSpPr txBox="1"/>
+          <p:nvPr/>
+        </p:nvSpPr>
+        <p:spPr>
+          <a:xfrm>
+            <a:off x="731519" y="1600200"/>
+            <a:ext cx="2075688" cy="347472"/>
+          </a:xfrm>
+          <a:prstGeom prst="rect">
+            <a:avLst/>
+          </a:prstGeom>
+          <a:noFill/>
+        </p:spPr>
+        <p:txBody>
+          <a:bodyPr wrap="square" lIns="0" rIns="0" tIns="0" bIns="0" anchor="ctr">
+            <a:spAutoFit/>
+          </a:bodyPr>
+          <a:lstStyle/>
+          <a:p>
+            <a:pPr>
+              <a:spcAft>
+                <a:spcPts val="0"/>
+              </a:spcAft>
+            </a:pPr>
+            <a:r>
+              <a:rPr sz="1050" b="1" i="0">
+                <a:solidFill>
+                  <a:srgbClr val="1E2447"/>
+                </a:solidFill>
+                <a:latin typeface="Calibri"/>
+              </a:rPr>
+              <a:t>Individual (anubhav-gami)</a:t>
+            </a:r>
+          </a:p>
+        </p:txBody>
+      </p:sp>
+      <p:sp>
+        <p:nvSpPr>
+          <p:cNvPr id="16" name="TextBox 15"/>
+          <p:cNvSpPr txBox="1"/>
+          <p:nvPr/>
+        </p:nvSpPr>
+        <p:spPr>
+          <a:xfrm>
+            <a:off x="2971800" y="1600200"/>
+            <a:ext cx="2624327" cy="347472"/>
+          </a:xfrm>
+          <a:prstGeom prst="rect">
+            <a:avLst/>
+          </a:prstGeom>
+          <a:noFill/>
+        </p:spPr>
+        <p:txBody>
+          <a:bodyPr wrap="square" lIns="0" rIns="0" tIns="0" bIns="0" anchor="ctr">
+            <a:spAutoFit/>
+          </a:bodyPr>
+          <a:lstStyle/>
+          <a:p>
+            <a:pPr>
+              <a:spcAft>
+                <a:spcPts val="0"/>
+              </a:spcAft>
+            </a:pPr>
+            <a:r>
+              <a:rPr sz="1000" b="0" i="0">
+                <a:solidFill>
+                  <a:srgbClr val="5A6377"/>
+                </a:solidFill>
+                <a:latin typeface="Calibri"/>
+              </a:rPr>
+              <a:t>Personal Assistant: mirror &amp; study</a:t>
+            </a:r>
+          </a:p>
+        </p:txBody>
+      </p:sp>
+      <p:sp>
+        <p:nvSpPr>
+          <p:cNvPr id="17" name="TextBox 16"/>
+          <p:cNvSpPr txBox="1"/>
+          <p:nvPr/>
+        </p:nvSpPr>
+        <p:spPr>
+          <a:xfrm>
+            <a:off x="5760720" y="1600200"/>
+            <a:ext cx="2670048" cy="347472"/>
+          </a:xfrm>
+          <a:prstGeom prst="rect">
+            <a:avLst/>
+          </a:prstGeom>
+          <a:noFill/>
+        </p:spPr>
+        <p:txBody>
+          <a:bodyPr wrap="square" lIns="0" rIns="0" tIns="0" bIns="0" anchor="ctr">
+            <a:spAutoFit/>
+          </a:bodyPr>
+          <a:lstStyle/>
+          <a:p>
+            <a:pPr>
+              <a:spcAft>
+                <a:spcPts val="0"/>
+              </a:spcAft>
+            </a:pPr>
+            <a:r>
+              <a:rPr sz="1000" b="0" i="0">
+                <a:solidFill>
+                  <a:srgbClr val="5A6377"/>
+                </a:solidFill>
+                <a:latin typeface="Calibri"/>
+              </a:rPr>
+              <a:t>Self-examination, sanskar, work</a:t>
+            </a:r>
+          </a:p>
+        </p:txBody>
+      </p:sp>
+      <p:sp>
+        <p:nvSpPr>
+          <p:cNvPr id="18" name="Rectangle 17"/>
+          <p:cNvSpPr/>
+          <p:nvPr/>
+        </p:nvSpPr>
+        <p:spPr>
+          <a:xfrm>
+            <a:off x="640080" y="2368296"/>
+            <a:ext cx="7863840" cy="9144"/>
+          </a:xfrm>
+          <a:prstGeom prst="rect">
+            <a:avLst/>
+          </a:prstGeom>
+          <a:solidFill>
+            <a:srgbClr val="D5DBEA"/>
+          </a:solidFill>
+          <a:ln>
+            <a:noFill/>
+          </a:ln>
+          <a:effectLst/>
+        </p:spPr>
+        <p:style>
+          <a:lnRef idx="1">
+            <a:schemeClr val="accent1"/>
+          </a:lnRef>
+          <a:fillRef idx="3">
+            <a:schemeClr val="accent1"/>
+          </a:fillRef>
+          <a:effectRef idx="2">
+            <a:schemeClr val="accent1"/>
+          </a:effectRef>
+          <a:fontRef idx="minor">
+            <a:schemeClr val="lt1"/>
+          </a:fontRef>
+        </p:style>
+        <p:txBody>
+          <a:bodyPr rtlCol="0" anchor="ctr"/>
+          <a:lstStyle/>
+          <a:p>
+            <a:pPr algn="ctr"/>
+          </a:p>
+        </p:txBody>
+      </p:sp>
+      <p:sp>
+        <p:nvSpPr>
+          <p:cNvPr id="19" name="TextBox 18"/>
+          <p:cNvSpPr txBox="1"/>
+          <p:nvPr/>
+        </p:nvSpPr>
+        <p:spPr>
+          <a:xfrm>
+            <a:off x="731519" y="2002536"/>
+            <a:ext cx="2075688" cy="347472"/>
+          </a:xfrm>
+          <a:prstGeom prst="rect">
+            <a:avLst/>
+          </a:prstGeom>
+          <a:noFill/>
+        </p:spPr>
+        <p:txBody>
+          <a:bodyPr wrap="square" lIns="0" rIns="0" tIns="0" bIns="0" anchor="ctr">
+            <a:spAutoFit/>
+          </a:bodyPr>
+          <a:lstStyle/>
+          <a:p>
+            <a:pPr>
+              <a:spcAft>
+                <a:spcPts val="0"/>
+              </a:spcAft>
+            </a:pPr>
+            <a:r>
+              <a:rPr sz="1050" b="1" i="0">
+                <a:solidFill>
+                  <a:srgbClr val="1E2447"/>
+                </a:solidFill>
+                <a:latin typeface="Calibri"/>
+              </a:rPr>
+              <a:t>Family (10–12 members)</a:t>
+            </a:r>
+          </a:p>
+        </p:txBody>
+      </p:sp>
+      <p:sp>
+        <p:nvSpPr>
+          <p:cNvPr id="20" name="TextBox 19"/>
+          <p:cNvSpPr txBox="1"/>
+          <p:nvPr/>
+        </p:nvSpPr>
+        <p:spPr>
+          <a:xfrm>
+            <a:off x="2971800" y="2002536"/>
+            <a:ext cx="2624327" cy="347472"/>
+          </a:xfrm>
+          <a:prstGeom prst="rect">
+            <a:avLst/>
+          </a:prstGeom>
+          <a:noFill/>
+        </p:spPr>
+        <p:txBody>
+          <a:bodyPr wrap="square" lIns="0" rIns="0" tIns="0" bIns="0" anchor="ctr">
+            <a:spAutoFit/>
+          </a:bodyPr>
+          <a:lstStyle/>
+          <a:p>
+            <a:pPr>
+              <a:spcAft>
+                <a:spcPts val="0"/>
+              </a:spcAft>
+            </a:pPr>
+            <a:r>
+              <a:rPr sz="1000" b="0" i="0">
+                <a:solidFill>
+                  <a:srgbClr val="5A6377"/>
+                </a:solidFill>
+                <a:latin typeface="Calibri"/>
+              </a:rPr>
+              <a:t>Family Agent: need &amp; restful work</a:t>
+            </a:r>
+          </a:p>
+        </p:txBody>
+      </p:sp>
+      <p:sp>
+        <p:nvSpPr>
+          <p:cNvPr id="21" name="TextBox 20"/>
+          <p:cNvSpPr txBox="1"/>
+          <p:nvPr/>
+        </p:nvSpPr>
+        <p:spPr>
+          <a:xfrm>
+            <a:off x="5760720" y="2002536"/>
+            <a:ext cx="2670048" cy="347472"/>
+          </a:xfrm>
+          <a:prstGeom prst="rect">
+            <a:avLst/>
+          </a:prstGeom>
+          <a:noFill/>
+        </p:spPr>
+        <p:txBody>
+          <a:bodyPr wrap="square" lIns="0" rIns="0" tIns="0" bIns="0" anchor="ctr">
+            <a:spAutoFit/>
+          </a:bodyPr>
+          <a:lstStyle/>
+          <a:p>
+            <a:pPr>
+              <a:spcAft>
+                <a:spcPts val="0"/>
+              </a:spcAft>
+            </a:pPr>
+            <a:r>
+              <a:rPr sz="1000" b="0" i="0">
+                <a:solidFill>
+                  <a:srgbClr val="5A6377"/>
+                </a:solidFill>
+                <a:latin typeface="Calibri"/>
+              </a:rPr>
+              <a:t>True family need, care, sharing</a:t>
+            </a:r>
+          </a:p>
+        </p:txBody>
+      </p:sp>
+      <p:sp>
+        <p:nvSpPr>
+          <p:cNvPr id="22" name="Rectangle 21"/>
+          <p:cNvSpPr/>
+          <p:nvPr/>
+        </p:nvSpPr>
+        <p:spPr>
+          <a:xfrm>
+            <a:off x="640080" y="2377440"/>
+            <a:ext cx="7863840" cy="402336"/>
+          </a:xfrm>
+          <a:prstGeom prst="rect">
+            <a:avLst/>
+          </a:prstGeom>
+          <a:solidFill>
+            <a:srgbClr val="EEF1F8"/>
+          </a:solidFill>
+          <a:ln>
+            <a:noFill/>
+          </a:ln>
+          <a:effectLst/>
+        </p:spPr>
+        <p:style>
+          <a:lnRef idx="1">
+            <a:schemeClr val="accent1"/>
+          </a:lnRef>
+          <a:fillRef idx="3">
+            <a:schemeClr val="accent1"/>
+          </a:fillRef>
+          <a:effectRef idx="2">
+            <a:schemeClr val="accent1"/>
+          </a:effectRef>
+          <a:fontRef idx="minor">
+            <a:schemeClr val="lt1"/>
+          </a:fontRef>
+        </p:style>
+        <p:txBody>
+          <a:bodyPr rtlCol="0" anchor="ctr"/>
+          <a:lstStyle/>
+          <a:p>
+            <a:pPr algn="ctr"/>
+          </a:p>
+        </p:txBody>
+      </p:sp>
+      <p:sp>
+        <p:nvSpPr>
+          <p:cNvPr id="23" name="Rectangle 22"/>
+          <p:cNvSpPr/>
+          <p:nvPr/>
+        </p:nvSpPr>
+        <p:spPr>
+          <a:xfrm>
+            <a:off x="640080" y="2770632"/>
+            <a:ext cx="7863840" cy="9144"/>
+          </a:xfrm>
+          <a:prstGeom prst="rect">
+            <a:avLst/>
+          </a:prstGeom>
+          <a:solidFill>
+            <a:srgbClr val="D5DBEA"/>
+          </a:solidFill>
+          <a:ln>
+            <a:noFill/>
+          </a:ln>
+          <a:effectLst/>
+        </p:spPr>
+        <p:style>
+          <a:lnRef idx="1">
+            <a:schemeClr val="accent1"/>
+          </a:lnRef>
+          <a:fillRef idx="3">
+            <a:schemeClr val="accent1"/>
+          </a:fillRef>
+          <a:effectRef idx="2">
+            <a:schemeClr val="accent1"/>
+          </a:effectRef>
+          <a:fontRef idx="minor">
+            <a:schemeClr val="lt1"/>
+          </a:fontRef>
+        </p:style>
+        <p:txBody>
+          <a:bodyPr rtlCol="0" anchor="ctr"/>
+          <a:lstStyle/>
+          <a:p>
+            <a:pPr algn="ctr"/>
+          </a:p>
+        </p:txBody>
+      </p:sp>
+      <p:sp>
+        <p:nvSpPr>
+          <p:cNvPr id="24" name="TextBox 23"/>
+          <p:cNvSpPr txBox="1"/>
+          <p:nvPr/>
+        </p:nvSpPr>
+        <p:spPr>
+          <a:xfrm>
+            <a:off x="731519" y="2404872"/>
+            <a:ext cx="2075688" cy="347472"/>
+          </a:xfrm>
+          <a:prstGeom prst="rect">
+            <a:avLst/>
+          </a:prstGeom>
+          <a:noFill/>
+        </p:spPr>
+        <p:txBody>
+          <a:bodyPr wrap="square" lIns="0" rIns="0" tIns="0" bIns="0" anchor="ctr">
+            <a:spAutoFit/>
+          </a:bodyPr>
+          <a:lstStyle/>
+          <a:p>
+            <a:pPr>
+              <a:spcAft>
+                <a:spcPts val="0"/>
+              </a:spcAft>
+            </a:pPr>
+            <a:r>
+              <a:rPr sz="1050" b="1" i="0">
+                <a:solidFill>
+                  <a:srgbClr val="1E2447"/>
+                </a:solidFill>
+                <a:latin typeface="Calibri"/>
+              </a:rPr>
+              <a:t>Family cluster (Tier 1)</a:t>
+            </a:r>
+          </a:p>
+        </p:txBody>
+      </p:sp>
+      <p:sp>
+        <p:nvSpPr>
+          <p:cNvPr id="25" name="TextBox 24"/>
+          <p:cNvSpPr txBox="1"/>
+          <p:nvPr/>
+        </p:nvSpPr>
+        <p:spPr>
+          <a:xfrm>
+            <a:off x="2971800" y="2404872"/>
+            <a:ext cx="2624327" cy="347472"/>
+          </a:xfrm>
+          <a:prstGeom prst="rect">
+            <a:avLst/>
+          </a:prstGeom>
+          <a:noFill/>
+        </p:spPr>
+        <p:txBody>
+          <a:bodyPr wrap="square" lIns="0" rIns="0" tIns="0" bIns="0" anchor="ctr">
+            <a:spAutoFit/>
+          </a:bodyPr>
+          <a:lstStyle/>
+          <a:p>
+            <a:pPr>
+              <a:spcAft>
+                <a:spcPts val="0"/>
+              </a:spcAft>
+            </a:pPr>
+            <a:r>
+              <a:rPr sz="1000" b="0" i="0">
+                <a:solidFill>
+                  <a:srgbClr val="5A6377"/>
+                </a:solidFill>
+                <a:latin typeface="Calibri"/>
+              </a:rPr>
+              <a:t>Cluster Agent: 10-family synthesis</a:t>
+            </a:r>
+          </a:p>
+        </p:txBody>
+      </p:sp>
+      <p:sp>
+        <p:nvSpPr>
+          <p:cNvPr id="26" name="TextBox 25"/>
+          <p:cNvSpPr txBox="1"/>
+          <p:nvPr/>
+        </p:nvSpPr>
+        <p:spPr>
+          <a:xfrm>
+            <a:off x="5760720" y="2404872"/>
+            <a:ext cx="2670048" cy="347472"/>
+          </a:xfrm>
+          <a:prstGeom prst="rect">
+            <a:avLst/>
+          </a:prstGeom>
+          <a:noFill/>
+        </p:spPr>
+        <p:txBody>
+          <a:bodyPr wrap="square" lIns="0" rIns="0" tIns="0" bIns="0" anchor="ctr">
+            <a:spAutoFit/>
+          </a:bodyPr>
+          <a:lstStyle/>
+          <a:p>
+            <a:pPr>
+              <a:spcAft>
+                <a:spcPts val="0"/>
+              </a:spcAft>
+            </a:pPr>
+            <a:r>
+              <a:rPr sz="1000" b="0" i="0">
+                <a:solidFill>
+                  <a:srgbClr val="5A6377"/>
+                </a:solidFill>
+                <a:latin typeface="Calibri"/>
+              </a:rPr>
+              <a:t>Evaluating representatives, aid</a:t>
+            </a:r>
+          </a:p>
+        </p:txBody>
+      </p:sp>
+      <p:sp>
+        <p:nvSpPr>
+          <p:cNvPr id="27" name="Rectangle 26"/>
+          <p:cNvSpPr/>
+          <p:nvPr/>
+        </p:nvSpPr>
+        <p:spPr>
+          <a:xfrm>
+            <a:off x="640080" y="3172968"/>
+            <a:ext cx="7863840" cy="9144"/>
+          </a:xfrm>
+          <a:prstGeom prst="rect">
+            <a:avLst/>
+          </a:prstGeom>
+          <a:solidFill>
+            <a:srgbClr val="D5DBEA"/>
+          </a:solidFill>
+          <a:ln>
+            <a:noFill/>
+          </a:ln>
+          <a:effectLst/>
+        </p:spPr>
+        <p:style>
+          <a:lnRef idx="1">
+            <a:schemeClr val="accent1"/>
+          </a:lnRef>
+          <a:fillRef idx="3">
+            <a:schemeClr val="accent1"/>
+          </a:fillRef>
+          <a:effectRef idx="2">
+            <a:schemeClr val="accent1"/>
+          </a:effectRef>
+          <a:fontRef idx="minor">
+            <a:schemeClr val="lt1"/>
+          </a:fontRef>
+        </p:style>
+        <p:txBody>
+          <a:bodyPr rtlCol="0" anchor="ctr"/>
+          <a:lstStyle/>
+          <a:p>
+            <a:pPr algn="ctr"/>
+          </a:p>
+        </p:txBody>
+      </p:sp>
+      <p:sp>
+        <p:nvSpPr>
+          <p:cNvPr id="28" name="TextBox 27"/>
+          <p:cNvSpPr txBox="1"/>
+          <p:nvPr/>
+        </p:nvSpPr>
+        <p:spPr>
+          <a:xfrm>
+            <a:off x="731519" y="2807208"/>
+            <a:ext cx="2075688" cy="347472"/>
+          </a:xfrm>
+          <a:prstGeom prst="rect">
+            <a:avLst/>
+          </a:prstGeom>
+          <a:noFill/>
+        </p:spPr>
+        <p:txBody>
+          <a:bodyPr wrap="square" lIns="0" rIns="0" tIns="0" bIns="0" anchor="ctr">
+            <a:spAutoFit/>
+          </a:bodyPr>
+          <a:lstStyle/>
+          <a:p>
+            <a:pPr>
+              <a:spcAft>
+                <a:spcPts val="0"/>
+              </a:spcAft>
+            </a:pPr>
+            <a:r>
+              <a:rPr sz="1050" b="1" i="0">
+                <a:solidFill>
+                  <a:srgbClr val="1E2447"/>
+                </a:solidFill>
+                <a:latin typeface="Calibri"/>
+              </a:rPr>
+              <a:t>Village &amp; 5 committees</a:t>
+            </a:r>
+          </a:p>
+        </p:txBody>
+      </p:sp>
+      <p:sp>
+        <p:nvSpPr>
+          <p:cNvPr id="29" name="TextBox 28"/>
+          <p:cNvSpPr txBox="1"/>
+          <p:nvPr/>
+        </p:nvSpPr>
+        <p:spPr>
+          <a:xfrm>
+            <a:off x="2971800" y="2807208"/>
+            <a:ext cx="2624327" cy="347472"/>
+          </a:xfrm>
+          <a:prstGeom prst="rect">
+            <a:avLst/>
+          </a:prstGeom>
+          <a:noFill/>
+        </p:spPr>
+        <p:txBody>
+          <a:bodyPr wrap="square" lIns="0" rIns="0" tIns="0" bIns="0" anchor="ctr">
+            <a:spAutoFit/>
+          </a:bodyPr>
+          <a:lstStyle/>
+          <a:p>
+            <a:pPr>
+              <a:spcAft>
+                <a:spcPts val="0"/>
+              </a:spcAft>
+            </a:pPr>
+            <a:r>
+              <a:rPr sz="1000" b="0" i="0">
+                <a:solidFill>
+                  <a:srgbClr val="5A6377"/>
+                </a:solidFill>
+                <a:latin typeface="Calibri"/>
+              </a:rPr>
+              <a:t>Village Agents: survey &amp; 3-stage</a:t>
+            </a:r>
+          </a:p>
+        </p:txBody>
+      </p:sp>
+      <p:sp>
+        <p:nvSpPr>
+          <p:cNvPr id="30" name="TextBox 29"/>
+          <p:cNvSpPr txBox="1"/>
+          <p:nvPr/>
+        </p:nvSpPr>
+        <p:spPr>
+          <a:xfrm>
+            <a:off x="5760720" y="2807208"/>
+            <a:ext cx="2670048" cy="347472"/>
+          </a:xfrm>
+          <a:prstGeom prst="rect">
+            <a:avLst/>
+          </a:prstGeom>
+          <a:noFill/>
+        </p:spPr>
+        <p:txBody>
+          <a:bodyPr wrap="square" lIns="0" rIns="0" tIns="0" bIns="0" anchor="ctr">
+            <a:spAutoFit/>
+          </a:bodyPr>
+          <a:lstStyle/>
+          <a:p>
+            <a:pPr>
+              <a:spcAft>
+                <a:spcPts val="0"/>
+              </a:spcAft>
+            </a:pPr>
+            <a:r>
+              <a:rPr sz="1000" b="0" i="0">
+                <a:solidFill>
+                  <a:srgbClr val="5A6377"/>
+                </a:solidFill>
+                <a:latin typeface="Calibri"/>
+              </a:rPr>
+              <a:t>Labour values, training, justice</a:t>
+            </a:r>
+          </a:p>
+        </p:txBody>
+      </p:sp>
+      <p:sp>
+        <p:nvSpPr>
+          <p:cNvPr id="31" name="Rectangle 30"/>
+          <p:cNvSpPr/>
+          <p:nvPr/>
+        </p:nvSpPr>
+        <p:spPr>
+          <a:xfrm>
+            <a:off x="640080" y="3182112"/>
+            <a:ext cx="7863840" cy="402336"/>
+          </a:xfrm>
+          <a:prstGeom prst="rect">
+            <a:avLst/>
+          </a:prstGeom>
+          <a:solidFill>
+            <a:srgbClr val="EEF1F8"/>
+          </a:solidFill>
+          <a:ln>
+            <a:noFill/>
+          </a:ln>
+          <a:effectLst/>
+        </p:spPr>
+        <p:style>
+          <a:lnRef idx="1">
+            <a:schemeClr val="accent1"/>
+          </a:lnRef>
+          <a:fillRef idx="3">
+            <a:schemeClr val="accent1"/>
+          </a:fillRef>
+          <a:effectRef idx="2">
+            <a:schemeClr val="accent1"/>
+          </a:effectRef>
+          <a:fontRef idx="minor">
+            <a:schemeClr val="lt1"/>
+          </a:fontRef>
+        </p:style>
+        <p:txBody>
+          <a:bodyPr rtlCol="0" anchor="ctr"/>
+          <a:lstStyle/>
+          <a:p>
+            <a:pPr algn="ctr"/>
+          </a:p>
+        </p:txBody>
+      </p:sp>
+      <p:sp>
+        <p:nvSpPr>
+          <p:cNvPr id="32" name="Rectangle 31"/>
+          <p:cNvSpPr/>
+          <p:nvPr/>
+        </p:nvSpPr>
+        <p:spPr>
+          <a:xfrm>
+            <a:off x="640080" y="3575304"/>
+            <a:ext cx="7863840" cy="9144"/>
+          </a:xfrm>
+          <a:prstGeom prst="rect">
+            <a:avLst/>
+          </a:prstGeom>
+          <a:solidFill>
+            <a:srgbClr val="D5DBEA"/>
+          </a:solidFill>
+          <a:ln>
+            <a:noFill/>
+          </a:ln>
+          <a:effectLst/>
+        </p:spPr>
+        <p:style>
+          <a:lnRef idx="1">
+            <a:schemeClr val="accent1"/>
+          </a:lnRef>
+          <a:fillRef idx="3">
+            <a:schemeClr val="accent1"/>
+          </a:fillRef>
+          <a:effectRef idx="2">
+            <a:schemeClr val="accent1"/>
+          </a:effectRef>
+          <a:fontRef idx="minor">
+            <a:schemeClr val="lt1"/>
+          </a:fontRef>
+        </p:style>
+        <p:txBody>
+          <a:bodyPr rtlCol="0" anchor="ctr"/>
+          <a:lstStyle/>
+          <a:p>
+            <a:pPr algn="ctr"/>
+          </a:p>
+        </p:txBody>
+      </p:sp>
+      <p:sp>
+        <p:nvSpPr>
+          <p:cNvPr id="33" name="TextBox 32"/>
+          <p:cNvSpPr txBox="1"/>
+          <p:nvPr/>
+        </p:nvSpPr>
+        <p:spPr>
+          <a:xfrm>
+            <a:off x="731519" y="3209544"/>
+            <a:ext cx="2075688" cy="347472"/>
+          </a:xfrm>
+          <a:prstGeom prst="rect">
+            <a:avLst/>
+          </a:prstGeom>
+          <a:noFill/>
+        </p:spPr>
+        <p:txBody>
+          <a:bodyPr wrap="square" lIns="0" rIns="0" tIns="0" bIns="0" anchor="ctr">
+            <a:spAutoFit/>
+          </a:bodyPr>
+          <a:lstStyle/>
+          <a:p>
+            <a:pPr>
+              <a:spcAft>
+                <a:spcPts val="0"/>
+              </a:spcAft>
+            </a:pPr>
+            <a:r>
+              <a:rPr sz="1050" b="1" i="0">
+                <a:solidFill>
+                  <a:srgbClr val="1E2447"/>
+                </a:solidFill>
+                <a:latin typeface="Calibri"/>
+              </a:rPr>
+              <a:t>Regional tiers (3–9)</a:t>
+            </a:r>
+          </a:p>
+        </p:txBody>
+      </p:sp>
+      <p:sp>
+        <p:nvSpPr>
+          <p:cNvPr id="34" name="TextBox 33"/>
+          <p:cNvSpPr txBox="1"/>
+          <p:nvPr/>
+        </p:nvSpPr>
+        <p:spPr>
+          <a:xfrm>
+            <a:off x="2971800" y="3209544"/>
+            <a:ext cx="2624327" cy="347472"/>
+          </a:xfrm>
+          <a:prstGeom prst="rect">
+            <a:avLst/>
+          </a:prstGeom>
+          <a:noFill/>
+        </p:spPr>
+        <p:txBody>
+          <a:bodyPr wrap="square" lIns="0" rIns="0" tIns="0" bIns="0" anchor="ctr">
+            <a:spAutoFit/>
+          </a:bodyPr>
+          <a:lstStyle/>
+          <a:p>
+            <a:pPr>
+              <a:spcAft>
+                <a:spcPts val="0"/>
+              </a:spcAft>
+            </a:pPr>
+            <a:r>
+              <a:rPr sz="1000" b="0" i="0">
+                <a:solidFill>
+                  <a:srgbClr val="5A6377"/>
+                </a:solidFill>
+                <a:latin typeface="Calibri"/>
+              </a:rPr>
+              <a:t>Regional Agents: I–O &amp; rent match</a:t>
+            </a:r>
+          </a:p>
+        </p:txBody>
+      </p:sp>
+      <p:sp>
+        <p:nvSpPr>
+          <p:cNvPr id="35" name="TextBox 34"/>
+          <p:cNvSpPr txBox="1"/>
+          <p:nvPr/>
+        </p:nvSpPr>
+        <p:spPr>
+          <a:xfrm>
+            <a:off x="5760720" y="3209544"/>
+            <a:ext cx="2670048" cy="347472"/>
+          </a:xfrm>
+          <a:prstGeom prst="rect">
+            <a:avLst/>
+          </a:prstGeom>
+          <a:noFill/>
+        </p:spPr>
+        <p:txBody>
+          <a:bodyPr wrap="square" lIns="0" rIns="0" tIns="0" bIns="0" anchor="ctr">
+            <a:spAutoFit/>
+          </a:bodyPr>
+          <a:lstStyle/>
+          <a:p>
+            <a:pPr>
+              <a:spcAft>
+                <a:spcPts val="0"/>
+              </a:spcAft>
+            </a:pPr>
+            <a:r>
+              <a:rPr sz="1000" b="0" i="0">
+                <a:solidFill>
+                  <a:srgbClr val="5A6377"/>
+                </a:solidFill>
+                <a:latin typeface="Calibri"/>
+              </a:rPr>
+              <a:t>Exchange rules &amp; infrastructure</a:t>
+            </a:r>
+          </a:p>
+        </p:txBody>
+      </p:sp>
+      <p:sp>
+        <p:nvSpPr>
+          <p:cNvPr id="36" name="Rectangle 35"/>
+          <p:cNvSpPr/>
+          <p:nvPr/>
+        </p:nvSpPr>
+        <p:spPr>
+          <a:xfrm>
+            <a:off x="640080" y="3977640"/>
+            <a:ext cx="7863840" cy="9144"/>
+          </a:xfrm>
+          <a:prstGeom prst="rect">
+            <a:avLst/>
+          </a:prstGeom>
+          <a:solidFill>
+            <a:srgbClr val="D5DBEA"/>
+          </a:solidFill>
+          <a:ln>
+            <a:noFill/>
+          </a:ln>
+          <a:effectLst/>
+        </p:spPr>
+        <p:style>
+          <a:lnRef idx="1">
+            <a:schemeClr val="accent1"/>
+          </a:lnRef>
+          <a:fillRef idx="3">
+            <a:schemeClr val="accent1"/>
+          </a:fillRef>
+          <a:effectRef idx="2">
+            <a:schemeClr val="accent1"/>
+          </a:effectRef>
+          <a:fontRef idx="minor">
+            <a:schemeClr val="lt1"/>
+          </a:fontRef>
+        </p:style>
+        <p:txBody>
+          <a:bodyPr rtlCol="0" anchor="ctr"/>
+          <a:lstStyle/>
+          <a:p>
+            <a:pPr algn="ctr"/>
+          </a:p>
+        </p:txBody>
+      </p:sp>
+      <p:sp>
+        <p:nvSpPr>
+          <p:cNvPr id="37" name="TextBox 36"/>
+          <p:cNvSpPr txBox="1"/>
+          <p:nvPr/>
+        </p:nvSpPr>
+        <p:spPr>
+          <a:xfrm>
+            <a:off x="731519" y="3611879"/>
+            <a:ext cx="2075688" cy="347472"/>
+          </a:xfrm>
+          <a:prstGeom prst="rect">
+            <a:avLst/>
+          </a:prstGeom>
+          <a:noFill/>
+        </p:spPr>
+        <p:txBody>
+          <a:bodyPr wrap="square" lIns="0" rIns="0" tIns="0" bIns="0" anchor="ctr">
+            <a:spAutoFit/>
+          </a:bodyPr>
+          <a:lstStyle/>
+          <a:p>
+            <a:pPr>
+              <a:spcAft>
+                <a:spcPts val="0"/>
+              </a:spcAft>
+            </a:pPr>
+            <a:r>
+              <a:rPr sz="1050" b="1" i="0">
+                <a:solidFill>
+                  <a:srgbClr val="1E2447"/>
+                </a:solidFill>
+                <a:latin typeface="Calibri"/>
+              </a:rPr>
+              <a:t>World council (Tier 10)</a:t>
+            </a:r>
+          </a:p>
+        </p:txBody>
+      </p:sp>
+      <p:sp>
+        <p:nvSpPr>
+          <p:cNvPr id="38" name="TextBox 37"/>
+          <p:cNvSpPr txBox="1"/>
+          <p:nvPr/>
+        </p:nvSpPr>
+        <p:spPr>
+          <a:xfrm>
+            <a:off x="2971800" y="3611879"/>
+            <a:ext cx="2624327" cy="347472"/>
+          </a:xfrm>
+          <a:prstGeom prst="rect">
+            <a:avLst/>
+          </a:prstGeom>
+          <a:noFill/>
+        </p:spPr>
+        <p:txBody>
+          <a:bodyPr wrap="square" lIns="0" rIns="0" tIns="0" bIns="0" anchor="ctr">
+            <a:spAutoFit/>
+          </a:bodyPr>
+          <a:lstStyle/>
+          <a:p>
+            <a:pPr>
+              <a:spcAft>
+                <a:spcPts val="0"/>
+              </a:spcAft>
+            </a:pPr>
+            <a:r>
+              <a:rPr sz="1000" b="0" i="0">
+                <a:solidFill>
+                  <a:srgbClr val="5A6377"/>
+                </a:solidFill>
+                <a:latin typeface="Calibri"/>
+              </a:rPr>
+              <a:t>Global Agents: planetary bounds</a:t>
+            </a:r>
+          </a:p>
+        </p:txBody>
+      </p:sp>
+      <p:sp>
+        <p:nvSpPr>
+          <p:cNvPr id="39" name="TextBox 38"/>
+          <p:cNvSpPr txBox="1"/>
+          <p:nvPr/>
+        </p:nvSpPr>
+        <p:spPr>
+          <a:xfrm>
+            <a:off x="5760720" y="3611879"/>
+            <a:ext cx="2670048" cy="347472"/>
+          </a:xfrm>
+          <a:prstGeom prst="rect">
+            <a:avLst/>
+          </a:prstGeom>
+          <a:noFill/>
+        </p:spPr>
+        <p:txBody>
+          <a:bodyPr wrap="square" lIns="0" rIns="0" tIns="0" bIns="0" anchor="ctr">
+            <a:spAutoFit/>
+          </a:bodyPr>
+          <a:lstStyle/>
+          <a:p>
+            <a:pPr>
+              <a:spcAft>
+                <a:spcPts val="0"/>
+              </a:spcAft>
+            </a:pPr>
+            <a:r>
+              <a:rPr sz="1000" b="0" i="0">
+                <a:solidFill>
+                  <a:srgbClr val="5A6377"/>
+                </a:solidFill>
+                <a:latin typeface="Calibri"/>
+              </a:rPr>
+              <a:t>Global covenants on coexistence</a:t>
+            </a:r>
+          </a:p>
+        </p:txBody>
+      </p:sp>
+      <p:sp>
+        <p:nvSpPr>
+          <p:cNvPr id="40" name="TextBox 39"/>
+          <p:cNvSpPr txBox="1"/>
+          <p:nvPr/>
+        </p:nvSpPr>
+        <p:spPr>
+          <a:xfrm>
+            <a:off x="640080" y="4343400"/>
+            <a:ext cx="7863840" cy="329184"/>
+          </a:xfrm>
+          <a:prstGeom prst="rect">
+            <a:avLst/>
+          </a:prstGeom>
+          <a:noFill/>
+        </p:spPr>
+        <p:txBody>
+          <a:bodyPr wrap="square" lIns="0" rIns="0" tIns="0" bIns="0" anchor="ctr">
+            <a:spAutoFit/>
+          </a:bodyPr>
+          <a:lstStyle/>
+          <a:p>
+            <a:pPr>
+              <a:spcAft>
+                <a:spcPts val="0"/>
+              </a:spcAft>
+            </a:pPr>
+            <a:r>
+              <a:rPr sz="1150" b="0" i="1">
+                <a:solidFill>
+                  <a:srgbClr val="1E2447"/>
+                </a:solidFill>
+                <a:latin typeface="Calibri"/>
+              </a:rPr>
+              <a:t>Every human unit from the person and family to the ten tiers works with a paired agent; authority stays with people.</a:t>
+            </a:r>
+          </a:p>
+        </p:txBody>
+      </p:sp>
+      <p:sp>
+        <p:nvSpPr>
+          <p:cNvPr id="41" name="TextBox 40"/>
+          <p:cNvSpPr txBox="1"/>
+          <p:nvPr/>
+        </p:nvSpPr>
+        <p:spPr>
+          <a:xfrm>
+            <a:off x="502920" y="4828032"/>
+            <a:ext cx="8138160" cy="256032"/>
+          </a:xfrm>
+          <a:prstGeom prst="rect">
+            <a:avLst/>
+          </a:prstGeom>
+          <a:noFill/>
+        </p:spPr>
+        <p:txBody>
+          <a:bodyPr wrap="square" lIns="0" rIns="0" tIns="0" bIns="0" anchor="ctr">
+            <a:spAutoFit/>
+          </a:bodyPr>
+          <a:lstStyle/>
+          <a:p>
+            <a:pPr>
+              <a:spcAft>
+                <a:spcPts val="0"/>
+              </a:spcAft>
+            </a:pPr>
+            <a:r>
+              <a:rPr sz="950" b="0" i="1">
+                <a:solidFill>
+                  <a:srgbClr val="5A6377"/>
+                </a:solidFill>
+                <a:latin typeface="Calibri"/>
+              </a:rPr>
+              <a:t>Study §8.3  ·  Technical Note  ·  AA pp. 14–15, 27–30, 65–67, 112–145  ·  MVD p. 268  ·  AnalyticMadhyasthDarshan.org  ·  28 / 33</a:t>
             </a:r>
           </a:p>
         </p:txBody>
@@ -35005,7 +37690,7 @@
                 </a:solidFill>
                 <a:latin typeface="Calibri"/>
               </a:rPr>
-              <a:t>JV pp. 47–48  ·  MVD p. 105  ·  AA pp. 41, 54–55, 77–78, 117  ·  AnalyticMadhyasthDarshan.org  ·  4 / 31</a:t>
+              <a:t>JV pp. 47–48  ·  MVD p. 105  ·  AA pp. 41, 54–55, 77–78, 117  ·  AnalyticMadhyasthDarshan.org  ·  4 / 33</a:t>
             </a:r>
           </a:p>
         </p:txBody>
@@ -36271,7 +38956,7 @@
                 </a:solidFill>
                 <a:latin typeface="Calibri"/>
               </a:rPr>
-              <a:t>AA pp. 26, 73, 93  ·  JV p. 152  ·  MVD pp. 96, 183, 282  ·  KD p. 114  ·  AnalyticMadhyasthDarshan.org  ·  5 / 31</a:t>
+              <a:t>AA pp. 26, 73, 93  ·  JV p. 152  ·  MVD pp. 96, 183, 282  ·  KD p. 114  ·  AnalyticMadhyasthDarshan.org  ·  5 / 33</a:t>
             </a:r>
           </a:p>
         </p:txBody>
@@ -37678,7 +40363,7 @@
                 </a:solidFill>
                 <a:latin typeface="Calibri"/>
               </a:rPr>
-              <a:t>AA pp. 13, 20–21, 48, 50, 92  ·  JV pp. 72–73, 137  ·  AnalyticMadhyasthDarshan.org  ·  6 / 31</a:t>
+              <a:t>AA pp. 13, 20–21, 48, 50, 92  ·  JV pp. 72–73, 137  ·  AnalyticMadhyasthDarshan.org  ·  6 / 33</a:t>
             </a:r>
           </a:p>
         </p:txBody>
@@ -38697,7 +41382,7 @@
                 </a:solidFill>
                 <a:latin typeface="Calibri"/>
               </a:rPr>
-              <a:t>JV pp. 72–73  ·  AA pp. 17–18  ·  AnalyticMadhyasthDarshan.org  ·  7 / 31</a:t>
+              <a:t>JV pp. 72–73  ·  AA pp. 17–18  ·  AnalyticMadhyasthDarshan.org  ·  7 / 33</a:t>
             </a:r>
           </a:p>
         </p:txBody>
@@ -40168,7 +42853,7 @@
                 </a:solidFill>
                 <a:latin typeface="Calibri"/>
               </a:rPr>
-              <a:t>AA p. 95  ·  Study §2.2  ·  AnalyticMadhyasthDarshan.org  ·  8 / 31</a:t>
+              <a:t>AA p. 95  ·  Study §2.2  ·  AnalyticMadhyasthDarshan.org  ·  8 / 33</a:t>
             </a:r>
           </a:p>
         </p:txBody>
@@ -41577,7 +44262,7 @@
                 </a:solidFill>
                 <a:latin typeface="Calibri"/>
               </a:rPr>
-              <a:t>JV pp. 162–163  ·  AA pp. 33, 48, 58–59, 78  ·  MVD p. 128  ·  AnalyticMadhyasthDarshan.org  ·  9 / 31</a:t>
+              <a:t>JV pp. 162–163  ·  AA pp. 33, 48, 58–59, 78  ·  MVD p. 128  ·  AnalyticMadhyasthDarshan.org  ·  9 / 33</a:t>
             </a:r>
           </a:p>
         </p:txBody>

</xml_diff>

<commit_message>
Update Slides 19 and 22 in Prosperity-Economics-And-Right-Use presentation on service remuneration
</commit_message>
<xml_diff>
--- a/Studies/Prosperity-Economics-And-Right-Use/Prosperity-Economics-And-Right-Use-Madhyasth-Darshan.pptx
+++ b/Studies/Prosperity-Economics-And-Right-Use/Prosperity-Economics-And-Right-Use-Madhyasth-Darshan.pptx
@@ -1354,13 +1354,13 @@
           <a:p/>
           <a:p>
             <a:r>
-              <a:t>The darshan distinguishes animal instincts from the three humane motives: progeny (putreshana), wealth (vitteshana), and public welfare or reputation (lokeshana), with public welfare highest (MVD pp. 318, 320). It also contrasts five kinds of human living: servile, voluptuary and glorious humans driven by sensory interest, the virtuous human on the path of awakening, and the capable human living by values (AA pp. 101–102).</a:t>
+              <a:t>The darshan distinguishes animal instincts from the three humane motives: progeny (putreshana), wealth (vitteshana), and public welfare or reputation (lokeshana), with public welfare highest (MVD pp. 318, 320). It also connects economic orientation to five kinds of human living: animalistic and demonic humans prior to awakening, and humane, deific and divine humans who replace interest-based consumption with value-based and goal-based living (AA pp. 101–102, 132).</a:t>
             </a:r>
           </a:p>
           <a:p/>
           <a:p>
             <a:r>
-              <a:t>Within the family goods are shared; between families they are exchanged (AA p. 1). Those who cannot produce are cared for through kindness, and surplus flows into generosity and benevolence (MVD p. 339; KD p. 116).</a:t>
+              <a:t>How do individuals doing service (seva) obtain the objects they need when they do not produce a physical commodity? The texts name agriculture and industry as the two primary forms of production, with all other vocations complementary to them (MVD p. 267), and distinguish benevolence-focused service (upkar-pradhan seva) from remuneration-focused service (pratiphal-pradhan seva, MVD p. 72). Household care, teaching, part-time village committee duties (AA p. 127), and full-time representation in the ten-tier council order (lok-pratinidhi) are sustained directly by the ten-member prosperous family (KD pp. 115–117; AA pp. 1, 119–120). Conversely, dedicated village services (the ninth branch of the village production system on AA pp. 133, 136 — repairing bicycles, radios, TVs and machines, washing, barbering, or staffing the exchange-reserve on AA p. 138) preserve the usefulness of goods; the village family council fixes their remuneration (AA p. 136), which credits their account in the autonomous cooperative exchange-reserve (AA pp. 137–138) so they can draw food, clothing and needed objects at labour value. Those unable to work receive goods through kindness (AA pp. 23–24, 140).</a:t>
             </a:r>
           </a:p>
         </p:txBody>
@@ -1682,7 +1682,7 @@
           <a:p/>
           <a:p>
             <a:r>
-              <a:t>Ten families form a family cluster, ten clusters a hundred-family village with nine branches of production (agriculture, go-shala, forestry, cottage crafts and related work; AA pp. 133–136), and ten tiers reach the world family council. Representatives are selected by mutual recognition with zero election expenditure and serve part-time while continuing production, keeping at least eighty percent of society prosperous in production and twenty percent in coordination (AA pp. 27–30, 110, 127; MVD p. 259).</a:t>
+              <a:t>Ten families form a family cluster, ten clusters a hundred-family village with nine branches of work (agriculture, animal husbandry, forestry, minerals, handicrafts, village crafts, cottage industry, village industry and service; AA pp. 133–136), and ten tiers reach the world family council. Representatives are selected by consensus with zero election expenditure and serve part-time while continuing production, so governance never creates a non-producing class and every family produces more than its needs, while higher tiers coordinate medium and large industry and calamity buffers (AA pp. 27–30, 72, 110, 115, 127; MVD pp. 259, 267).</a:t>
             </a:r>
           </a:p>
           <a:p/>
@@ -17893,7 +17893,7 @@
         </p:spPr>
         <p:txBody>
           <a:bodyPr wrap="square" lIns="0" rIns="0" tIns="0" bIns="0" anchor="ctr">
-            <a:spAutoFit/>
+            <a:noAutofit/>
           </a:bodyPr>
           <a:lstStyle/>
           <a:p>
@@ -17909,7 +17909,7 @@
                 </a:solidFill>
                 <a:latin typeface="Cambria"/>
               </a:rPr>
-              <a:t>Care for those who cannot produce</a:t>
+              <a:t>Service (seva) &amp; care for all</a:t>
             </a:r>
           </a:p>
         </p:txBody>
@@ -17932,7 +17932,7 @@
         </p:spPr>
         <p:txBody>
           <a:bodyPr wrap="square" lIns="0" rIns="0" tIns="0" bIns="0" anchor="t">
-            <a:spAutoFit/>
+            <a:noAutofit/>
           </a:bodyPr>
           <a:lstStyle/>
           <a:p>
@@ -17948,7 +17948,7 @@
                 </a:solidFill>
                 <a:latin typeface="Calibri"/>
               </a:rPr>
-              <a:t>Sharing within the family; kindness that brings an object where there is receptivity but no object.</a:t>
+              <a:t>Family care &amp; council duties are sustained by the 10-member household; village repair/service is paid council-fixed remuneration via the reserve.</a:t>
             </a:r>
           </a:p>
         </p:txBody>
@@ -18010,7 +18010,7 @@
         </p:spPr>
         <p:txBody>
           <a:bodyPr wrap="square" lIns="0" rIns="0" tIns="0" bIns="0" anchor="ctr">
-            <a:spAutoFit/>
+            <a:noAutofit/>
           </a:bodyPr>
           <a:lstStyle/>
           <a:p>
@@ -18026,7 +18026,7 @@
                 </a:solidFill>
                 <a:latin typeface="Calibri"/>
               </a:rPr>
-              <a:t>AA pp. 1, 22–24, 54, 101–102, 140  ·  MVD pp. 59, 211, 263, 318–320, 339  ·  KD pp. 1–2, 116–117  ·  AnalyticMadhyasthDarshan.org  ·  19 / 33</a:t>
+              <a:t>AA pp. 1, 22–24, 54, 101–102, 136–138, 140  ·  MVD pp. 59, 72, 263, 267, 318–320, 339  ·  KD pp. 1–2, 115–117  ·  19 / 33</a:t>
             </a:r>
           </a:p>
         </p:txBody>
@@ -21657,7 +21657,7 @@
         </p:spPr>
         <p:txBody>
           <a:bodyPr wrap="square" lIns="0" rIns="0" tIns="0" bIns="0" anchor="t">
-            <a:spAutoFit/>
+            <a:noAutofit/>
           </a:bodyPr>
           <a:lstStyle/>
           <a:p>
@@ -21673,7 +21673,7 @@
                 </a:solidFill>
                 <a:latin typeface="Calibri"/>
               </a:rPr>
-              <a:t>A 100-family village with nine production branches; ten tiers of part-time councils (zero election cost); 80% in production, 20% in service.</a:t>
+              <a:t>A 100-family village with nine branches (agriculture, crafts, industry, service); ten tiers of part-time councils with zero election cost.</a:t>
             </a:r>
           </a:p>
         </p:txBody>

</xml_diff>

<commit_message>
Integrate benevolence from family abundance and upkar vs. pratiphal service taxonomy
</commit_message>
<xml_diff>
--- a/Studies/Prosperity-Economics-And-Right-Use/Prosperity-Economics-And-Right-Use-Madhyasth-Darshan.pptx
+++ b/Studies/Prosperity-Economics-And-Right-Use/Prosperity-Economics-And-Right-Use-Madhyasth-Darshan.pptx
@@ -1354,13 +1354,13 @@
           <a:p/>
           <a:p>
             <a:r>
-              <a:t>The darshan distinguishes animal instincts from the three humane motives: progeny (putreshana), wealth (vitteshana), and public welfare or reputation (lokeshana), with public welfare highest (MVD pp. 318, 320). It also connects economic orientation to five kinds of human living: animalistic and demonic humans prior to awakening, and humane, deific and divine humans who replace interest-based consumption with value-based and goal-based living (AA pp. 101–102, 132).</a:t>
+              <a:t>The darshan distinguishes animal instincts from the three humane motives: progeny (putreshana), wealth (vitteshana), and public welfare or reputation (lokeshana), with public welfare highest (MVD pp. 318, 320). Upon awakening, once a ten-member family (where two to four members already produce beyond the household's limited physical needs) achieves resolution and prosperity, the propensity of benevolence (upkar — help and inspiration for awakening and prosperity, MVD p. 72; AA pp. 23–24, 101) naturally arises (KD pp. 115–116). Instead of diverting surplus into limitless accumulation (sangrah), household abundance is channelled into use within the family, right use (sadupyog) in society, and purposeful use in the universal order (KD pp. 116–117; AA p. 116; MVD p. 150). That is also why the higher societal services that sustain awakening and orderliness — education, medical care, justice, and governance — must be performed with benevolence rather than sold as commercial trades (AA pp. 45–46; JV pp. 166–168).</a:t>
             </a:r>
           </a:p>
           <a:p/>
           <a:p>
             <a:r>
-              <a:t>How do individuals doing service (seva) obtain the objects they need when they do not produce a physical commodity? The texts name agriculture and industry as the two primary forms of production, with all other vocations complementary to them (MVD p. 267), and distinguish benevolence-focused service (upkar-pradhan seva) from remuneration-focused service (pratiphal-pradhan seva, MVD p. 72). Household care, teaching, part-time village committee duties (AA p. 127), and full-time representation in the ten-tier council order (lok-pratinidhi) are sustained directly by the ten-member prosperous family (KD pp. 115–117; AA pp. 1, 119–120). Conversely, dedicated village services (the ninth branch of the village production system on AA pp. 133, 136 — repairing bicycles, radios, TVs and machines, washing, barbering, or staffing the exchange-reserve on AA p. 138) preserve the usefulness of goods; the village family council fixes their remuneration (AA p. 136), which credits their account in the autonomous cooperative exchange-reserve (AA pp. 137–138) so they can draw food, clothing and needed objects at labour value. Those unable to work receive goods through kindness (AA pp. 23–24, 140).</a:t>
+              <a:t>How are services (seva) organised, which vocations fall where, and how do practitioners obtain the physical objects they need? The texts name agriculture and industry as the two primary forms of production, with all other vocations complementary to them (MVD p. 267), and distinguish two forms of service (MVD p. 72). First, benevolence-focused service (upkar-pradhan seva) covers household care, child and elder support, teaching under the education-sanskar committee (AA pp. 24, 29, 130–132, 140), medical care and healing by doctors under the health-restraint committee at village and regional medical centres (AA pp. 139–140; JV pp. 166–168), part-time committee duties (AA p. 127), and full-time council representation (lok-pratinidhi, KD pp. 116–117); because these practitioners belong to a self-reliant ten-member family producing in excess of need, their household's abundance provides all objects needed for their bodily nourishment, protection, and societal motion without salaried jobs (KD pp. 115–117; AA pp. 119–120, 137). Second, remuneration-focused service (pratiphal-pradhan seva) covers the ninth branch of the village production system (AA pp. 133, 136) and exchange-reserve staffing (AA p. 138) — repairing bicycles, radios, TVs and machines, washing clothes, barbering, and running the exchange-reserve — whose council-fixed remuneration (parishramik as svadhan, AA pp. 136, 140) credits their account in the cooperative exchange-reserve (AA pp. 137–138) so they draw needed objects at labour value.</a:t>
             </a:r>
           </a:p>
         </p:txBody>
@@ -17785,7 +17785,7 @@
                 </a:solidFill>
                 <a:latin typeface="Cambria"/>
               </a:rPr>
-              <a:t>Generosity</a:t>
+              <a:t>Generosity &amp; benevolence (upkar)</a:t>
             </a:r>
           </a:p>
         </p:txBody>
@@ -17824,7 +17824,7 @@
                 </a:solidFill>
                 <a:latin typeface="Calibri"/>
               </a:rPr>
-              <a:t>Offering body, mind and wealth, as needed, for others' awakening, health and prosperity; wealth is satisfied through it.</a:t>
+              <a:t>From family abundance arises benevolence (upkar), directing surplus into right use in society rather than accumulation.</a:t>
             </a:r>
           </a:p>
         </p:txBody>
@@ -17909,7 +17909,7 @@
                 </a:solidFill>
                 <a:latin typeface="Cambria"/>
               </a:rPr>
-              <a:t>Service (seva) &amp; care for all</a:t>
+              <a:t>Two forms of service (seva)</a:t>
             </a:r>
           </a:p>
         </p:txBody>
@@ -17948,7 +17948,7 @@
                 </a:solidFill>
                 <a:latin typeface="Calibri"/>
               </a:rPr>
-              <a:t>Family care &amp; council duties are sustained by the 10-member household; village repair/service is paid council-fixed remuneration via the reserve.</a:t>
+              <a:t>Upkar-pradhan (teaching, healing, councils) is sustained by the prosperous family; pratiphal-pradhan (repair, upkeep) earns reserve credit.</a:t>
             </a:r>
           </a:p>
         </p:txBody>
@@ -17987,7 +17987,7 @@
                 </a:solidFill>
                 <a:latin typeface="Calibri"/>
               </a:rPr>
-              <a:t>Once a family is resolved and prosperous, the propensity of benevolence answers where its surplus goes.</a:t>
+              <a:t>Once a family is prosperous, benevolence directs its surplus into right use rather than accumulation.</a:t>
             </a:r>
           </a:p>
         </p:txBody>

</xml_diff>

<commit_message>
Add Ten-Tier Agentic Infrastructure technical note and resolve Prosperity Economics review
</commit_message>
<xml_diff>
--- a/Studies/Prosperity-Economics-And-Right-Use/Prosperity-Economics-And-Right-Use-Madhyasth-Darshan.pptx
+++ b/Studies/Prosperity-Economics-And-Right-Use/Prosperity-Economics-And-Right-Use-Madhyasth-Darshan.pptx
@@ -1356,13 +1356,13 @@
           <a:p/>
           <a:p>
             <a:r>
-              <a:t>The darshan distinguishes animal instincts from the three humane motives: progeny (putreshana), wealth (vitteshana), and public welfare or reputation (lokeshana), with public welfare highest (MVD pp. 318, 320). Upon awakening, once a ten-member family (where two to four members already produce beyond the household's limited physical needs) achieves resolution and prosperity, the propensity of benevolence (upkar — help and inspiration for awakening and prosperity, MVD p. 72; AA pp. 23–24, 101) naturally arises (KD pp. 115–116). Instead of diverting surplus into limitless accumulation (sangrah), household abundance is channelled into use within the family, right use (sadupyog) in society, and purposeful use in the universal order (KD pp. 116–117; AA p. 116; MVD p. 150). That is also why the higher societal services that sustain awakening and orderliness — education, medical care, justice, and governance — must be performed with benevolence rather than sold as commercial trades (AA pp. 45–46; JV pp. 166–168).</a:t>
+              <a:t>The darshan distinguishes animal instincts from the three humane motives: progeny (putreshana), wealth (vitteshana), and public welfare or reputation (lokeshana), with public welfare highest (MVD pp. 318, 320). Upon awakening, once a ten-member family (where two to four members already produce beyond the household's limited physical needs) achieves resolution and prosperity, the propensity of benevolence (upkar — help and inspiration for awakening and prosperity, MVD p. 72; AA pp. 23–24, 101) naturally arises (KD pp. 115–116). Instead of diverting surplus into limitless accumulation (sangrah), household abundance is channelled into use within the family, right use (sadupyog) in society, and purposeful use in the universal order rather than hoarded (KD pp. 116–117; AA p. 116; MVD p. 150).</a:t>
             </a:r>
           </a:p>
           <a:p/>
           <a:p>
             <a:r>
-              <a:t>How are services (seva) organised, which vocations fall where, and how do practitioners obtain the physical objects they need? The texts name agriculture and industry as the two primary forms of production, with all other vocations complementary to them (MVD p. 267), and distinguish two forms of service (MVD p. 72). First, benevolence-focused service (upkar-pradhan seva) covers household care, child and elder support, teaching under the education-sanskar committee (AA pp. 24, 29, 130–132, 140), medical care and healing by doctors under the health-restraint committee at village and regional medical centres (AA pp. 139–140; JV pp. 166–168), part-time committee duties (AA p. 127), and full-time council representation (lok-pratinidhi, KD pp. 116–117); because these practitioners belong to a self-reliant ten-member family producing in excess of need, their household's abundance provides all objects needed for their bodily nourishment, protection, and societal motion without salaried jobs (KD pp. 115–117; AA pp. 119–120, 137). Second, remuneration-focused service (pratiphal-pradhan seva) covers the ninth branch of the village production system (AA pp. 133, 136) and exchange-reserve staffing (AA p. 138) — repairing bicycles, radios, TVs and machines, washing clothes, barbering, and running the exchange-reserve — whose council-fixed remuneration (parishramik as svadhan, AA pp. 136, 140) credits their account in the cooperative exchange-reserve (AA pp. 137–138) so they draw needed objects at labour value. Healing the body falls on the unpaid side of this line because restoring a person in disease is a direct work of kindness and generosity in human relationship that fees corrupt into a trade in suffering (AA pp. 22–24, 45–46, 140; JV pp. 166–168), whereas repair, laundry, barbering, and reserve staffing maintain produced objects and village operations.</a:t>
+              <a:t>The texts treat agriculture and industry as the two primary forms of production, with all other vocations complementary to them (MVD p. 267), and distinguish two forms of service (seva, MVD p. 72). First, benevolence-focused service (upkar-pradhan seva) covers household care, child and elder support, teaching under the education-sanskar committee (AA pp. 24, 29, 130–132, 140), medical care and healing by doctors under the health-restraint committee at village and regional medical centres (AA pp. 139–140; JV pp. 166–168), service on the five committees (AA p. 127), and representation in the ten-tier council order (lok-pratinidhi, KD pp. 116–117); because these practitioners belong to a self-reliant ten-member family producing in excess of need, their household's abundance provides all objects needed for their bodily nourishment, protection, and societal motion without salaried employment (KD pp. 115–117; AA pp. 119–120, 137). Second, remuneration-focused service (pratiphal-pradhan seva) covers the village service branch (AA pp. 133, 136) and exchange-reserve staffing (AA p. 138) — repairing bicycles, radios, TVs and machines, washing clothes, barbering, and staffing the exchange-reserve — whose council-fixed remuneration (parishramik as svadhan, AA pp. 136, 140) credits their account in the cooperative exchange-reserve (AA pp. 137–138) so they draw needed objects at labour value. Healing falls on the unpaid side because restoring a person in distress or disease is a direct work of kindness (daya) in human relationship, and selling it for gain turns it into trade (vyapar) and distorts its purpose (AA pp. 22–24, 45–46, 140; JV pp. 166–168). Repair, laundry, barbering, and reserve staffing fall on the paid side because they maintain produced objects and village operations and so extend material production.</a:t>
             </a:r>
           </a:p>
         </p:txBody>

</xml_diff>

<commit_message>
Align Prosperity Economics presentation decks with updated study and 10-tier structure
</commit_message>
<xml_diff>
--- a/Studies/Prosperity-Economics-And-Right-Use/Prosperity-Economics-And-Right-Use-Madhyasth-Darshan.pptx
+++ b/Studies/Prosperity-Economics-And-Right-Use/Prosperity-Economics-And-Right-Use-Madhyasth-Darshan.pptx
@@ -1596,7 +1596,7 @@
           <a:lstStyle/>
           <a:p>
             <a:r>
-              <a:t>In the cyclical economy, every villager is trained across multiple occupations, planned jointly by the education, production and exchange-reserve committees, so that no one suffers occupational fear (AA pp. 64–65, 131). Under “Security of production” (AA p. 144), when a producer or researcher develops an original tool, procedure, method or formula (maulikta) not previously in the tradition, four village committees record its drawings and formulas in writing and honour the inventor with prizes and awards (puraskar), which count as righteous wealth (svadhan, AA p. 140). Research and dissemination remain inseparable: just as one grain multiplies into hundreds only when sown in the field, knowledge and skill reach fruition through open dissemination, not through patent monopolies that sell research while concealing the method (AA pp. 56–58; JV pp. 88–89).</a:t>
+              <a:t>In the cyclical economy, every villager is trained across multiple occupations, planned jointly by the education-sanskar, production, and exchange-reserve committees, so that no one suffers occupational fear (AA pp. 64–65, 131). Under “Security of production” (AA p. 144), when a producer or researcher develops an original tool, procedure, method or formula (maulikta) not previously in the tradition, four village committees record its drawings and formulas in writing and honour the inventor with prizes and awards (puraskar), which count as righteous wealth (svadhan, AA p. 140). Research and dissemination remain inseparable: just as one grain multiplies into hundreds only when sown in the field, knowledge and skill reach fruition through open dissemination, not through patent monopolies that sell research while concealing the method (AA pp. 56–58; JV pp. 88–89).</a:t>
             </a:r>
           </a:p>
           <a:p/>
@@ -1684,7 +1684,7 @@
           <a:p/>
           <a:p>
             <a:r>
-              <a:t>This institutional architecture scales resolved, prosperous, fearless living to the entire Earth and into universal orderliness. Ten families form a family cluster, ten clusters a hundred-family village with nine branches of work (AA pp. 133–136), and ten tiers reach the World Family Council (vishva parivar sabha). Representatives are selected by consensus with zero election expenditure and serve part-time while continuing production, so governance never creates a non-producing ruling class and every family produces more than its needs, while higher tiers coordinate medium and large industry, planetary regeneration, and inter-nation labour-value exchange free of profit and loss (AA pp. 27–30, 63, 72, 110, 115, 127; MVD pp. 259, 264–271; KD p. 67).</a:t>
+              <a:t>This institutional architecture scales resolved, prosperous, fearless living to the entire Earth and into universal orderliness. From the Tier-1 family council (parivar sabha, at least ten members) and Tier-2 family cluster (parivar samuh sabha, ten families) to the Tier-3 village family council (gram parivar sabha, a hundred families nominating the five committees and coordinating nine branches of work; AA pp. 67, 127, 133–136), Tiers 4–8 scale by factors of ten up to ten million families, while Tiers 9 and 10 span the continent councils (pradhan rajya sabha) and the World Family Council (vishva parivar sabha; AA pp. 27–30, 125–127). Representatives are selected by consensus with zero election expenditure and serve part-time while continuing production, so governance never creates a non-producing ruling class and every family produces more than its needs, while higher tiers coordinate medium and large industry, planetary regeneration, and inter-nation labour-value exchange free of profit and loss (AA pp. 27–30, 63, 72, 110, 115, 127; MVD pp. 259, 264–271; KD p. 67).</a:t>
             </a:r>
           </a:p>
         </p:txBody>
@@ -2000,7 +2000,7 @@
           <a:p/>
           <a:p>
             <a:r>
-              <a:t>Why does a group of people still in the process of realisation (anubhav-gami) self-correct when an individual errs? Because priya–hita–labha biases are private to each body and cannot command shared endorsement once objective facts and checkable causal logic are placed in common view before a council of peers who all innately seek contentment and justice (AA pp. 18–20, 48, 58–60; MVD p. 203).</a:t>
+              <a:t>That collective self-correction rests on two things: the treatise grounds universal agreement (sarvasammati) in realisation and evaluation by justice, dharma, and truth (§2.1; AA pp. 18–20, 58–60; MVD p. 203), and for councils whose members are still in the process of realisation (anubhav-gami) and may slip into a priya–hit–labh impulse, this study argues as a working institutional hypothesis that placing objective facts and checkable causal logic continuously in common view makes it far harder for a group of peers to quietly endorse injustice or ecological waste.</a:t>
             </a:r>
           </a:p>
         </p:txBody>
@@ -2082,7 +2082,7 @@
           <a:p/>
           <a:p>
             <a:r>
-              <a:t>Because these facts and checkable derivations are visible to the whole council at once, no single member's blind spot or mistake can quietly persist: the collective is compelled to deliberate and restore balance.</a:t>
+              <a:t>Because these facts and checkable derivations are visible to the whole council at once, no single member's blind spot or mistake can quietly persist: the visible discrepancy prompts the collective to examine the facts and restore balance.</a:t>
             </a:r>
           </a:p>
         </p:txBody>
@@ -2234,7 +2234,7 @@
           <a:lstStyle/>
           <a:p>
             <a:r>
-              <a:t>Across the ten tiers, the agentic backbone keeps the cycle in balance, enables collective self-correction, and lowers the barrier to transition. When a new cluster of families or villages begins transitioning inside today's market economy, pre-configured agents immediately connect its exchange-reserve to regional labour-value benchmarks and mutual-credit clearing, while placing verified discrepancies and checkable causal traces before the whole council simultaneously so they cannot be ignored (AA pp. 72, 115, 118, 139, 142–143; MVD p. 268).</a:t>
+              <a:t>Across the ten tiers, the agentic backbone keeps the cycle in balance, enables collective self-correction, and lowers the barrier to transition. When a new cluster of families or villages begins transitioning inside today's market economy, pre-configured agents immediately connect its exchange-reserve to regional labour-value benchmarks and mutual-credit clearing, while placing verified discrepancies and checkable causal traces before the whole council simultaneously making them far harder to ignore (AA pp. 72, 115, 118, 139, 142–143; MVD p. 268).</a:t>
             </a:r>
           </a:p>
           <a:p/>
@@ -2246,7 +2246,7 @@
           <a:p/>
           <a:p>
             <a:r>
-              <a:t>Five safeguards keep the agentic backbone subordinate to people (§8.8): no optimisation for profit or attention capture; strict data subsidiarity (AA p. 128); inspectable rules that prevent technocratic rulership (AA p. 82); counting AI's own energy and mineral footprint within regenerative limits; and shared council visibility with cross-agent auditability so no single representative or single agent can hide an inconsistency from the group.</a:t>
+              <a:t>Five safeguards keep the agentic backbone subordinate to people (§8.8): no optimisation for profit or attention capture; strict data subsidiarity (AA p. 128); inspectable rules that prevent technocratic rulership (AA p. 82); counting AI's own energy and mineral footprint within regenerative limits; and shared council visibility with cross-agent auditability making it far harder for any single representative to quietly dismiss an inconsistency.</a:t>
             </a:r>
           </a:p>
         </p:txBody>
@@ -2404,13 +2404,13 @@
           <a:p/>
           <a:p>
             <a:r>
-              <a:t>Its strengths: it sets out the complete vision of resolved, prosperous, fearless humans coexisting with nature across the Earth; explains insatiability through the joint form of jeevan and body; resolves the six structural deadlocks that body-centric economics cannot solve without jeevan and realisation (rebound against caps, Arrow's impossibility of social agreement, the work-disutility trilemma, non-kin family sharing, strategic ledger gaming, and intergenerational discounting); pairs family need-sharing with inter-family labour-value exchange; and specifies the three-stage transition path together with the required ten-tier AI agentic backbone.</a:t>
+              <a:t>On the darshan's account, its strengths are that it sets out the complete vision of resolved, prosperous, fearless humans coexisting with nature across the Earth; explains insatiability through the joint form of jeevan and body; resolves at a common root the six structural deadlocks that body-centric economics cannot solve without jeevan and realisation (rebound against caps, Arrow's impossibility of social agreement, the work-disutility trilemma, non-kin family sharing, strategic ledger gaming, and intergenerational discounting); pairs family need-sharing with inter-family fivefold labour-value exchange (skill, proficiency, pace, time, and means); and specifies the three-stage transition path, which this study joins to the federated ten-tier AI agentic backbone.</a:t>
             </a:r>
           </a:p>
           <a:p/>
           <a:p>
             <a:r>
-              <a:t>Its open problems: how family need assessments aggregate at planetary scale; how common labour values compute multi-stage inputs, capital depreciation without interest, and Ricardian differential fertility across regions; how the federated ten-tier AI agentic backbone replaces price and interest signals without creating a technocratic bottleneck; how automation reduces drudgery without displacing producers; and how communities govern Personal, Family and Committee AI Agents so that shared visibility strengthens human deliberation without ceding justice, dharma and truth.</a:t>
+              <a:t>Its open problems: how family need assessments aggregate at planetary scale; how fivefold labour valuation computes multi-stage inputs, capital depreciation without interest, and Ricardian differential fertility across regions; how the federated ten-tier AI agentic backbone replaces price and interest signals without creating a technocratic bottleneck; how automation reduces drudgery without displacing producers; how teachers, doctors, and council representatives are supported in unpaid benevolent service (upkar-pradhan seva) during the transition before their households reach ten-member prosperity; and how communities govern Personal, Family and Committee AI Agents without ceding justice, dharma and truth.</a:t>
             </a:r>
           </a:p>
         </p:txBody>
@@ -2562,13 +2562,13 @@
           <a:lstStyle/>
           <a:p>
             <a:r>
-              <a:t>Writing in the 1990s, Shri A. Nagraj anticipated computers in the village exchange-reserve (AA p. 138) and a computer network linking committees from the village to the world (AA p. 132). When this vision is examined at the scale of the whole Earth — rather than a single small family or isolated hamlet — and under the realistic condition that citizens are in the process of realisation (anubhav-gami), a strong, federated ten-tier AI agentic backbone emerges as a structural requirement rather than an optional convenience, for four interconnected reasons.</a:t>
+              <a:t>Writing in the 1990s, Shri A. Nagraj anticipated computers in the village exchange-reserve (AA p. 138) and a computer network linking committees from the village to the world (AA p. 132). Extending that institutional design to contemporary computing, this study argues that at the scale of the whole Earth — and while citizens are in the process of realisation (anubhav-gami) — a federated ten-tier AI agentic backbone is a structural requirement rather than an optional convenience, for four interconnected reasons.</a:t>
             </a:r>
           </a:p>
           <a:p/>
           <a:p>
             <a:r>
-              <a:t>First, planetary-scale visibility for collective self-correction: in a single household, stock, effort and soil are visible to the naked eye; across ten tiers of villages, bioregions and continents, no council can see distant ecological drawdown or exchange drift without active agents that continuously cross-check flows and place checkable causal traces in common view so councils cannot ignore them. Second, fault-tolerant collective correction while individuals are anubhav-gami: even when an individual errs or slips into priya–hita–labha bias (AA p. 139), simultaneous visibility of facts and checkable logic before the whole committee or council enables the group to correct the error cleanly. Third, part-time governance: representatives continue physical production (AA p. 127; MVD p. 259) and the village exchange-reserve has only three staff (AA p. 138); manual databases would force a full-time managerial bureaucracy (JVD p. 35). Fourth, non-price input–output calculation, Ricardian soil adjustment, natural-language village surveys, and dual currency/labour ledgers across Stages 1–3 (AA pp. 122–125, 142–143) require active agentic computation.</a:t>
+              <a:t>First, planetary-scale visibility across ten tiers: in a single household, stock, effort and soil are visible to the naked eye; across ten tiers of villages, regions and continents, no council can see distant ecological drawdown or exchange drift without active agents that continuously cross-check flows and place checkable causal traces in common view. Second, fault-tolerance while individuals are anubhav-gami: even when an individual errs or slips into priya–hit–labh bias (AA p. 139), simultaneous visibility of verified discrepancies and their step-by-step logic before the relevant committee or council brings private drift into common view for reformative deliberation (AA pp. 129–130, 139–140). Third, part-time governance and lean staffing: representatives continue physical production (AA p. 127; MVD p. 259) and the village exchange-reserve is staffed on average by three people (AA p. 138); manual databases would force a full-time managerial bureaucracy (JVD p. 35). Fourth, non-price input–output calculation, Ricardian soil adjustment, natural-language village surveys, and dual currency/labour ledgers across Stages 1–3 (AA pp. 122–125, 142–143) require active agentic computation.</a:t>
             </a:r>
           </a:p>
         </p:txBody>
@@ -2638,19 +2638,19 @@
           <a:lstStyle/>
           <a:p>
             <a:r>
-              <a:t>To operate at the scale of the Earth while citizens are in the process of realisation (anubhav-gami), every human unit from the person and ten-member family to the Tier-10 World Family Council is paired with a dedicated AI agent. Across all ten tiers, these agents act not as rulers or passive ledgers, but as collective consistency mirrors: they place verified facts, discrepancies, and checkable causal logic in common view before all members of the family, cluster, committee, or council simultaneously, so that no single person's error can hide and the collective can self-correct.</a:t>
+              <a:t>To operate at the scale of the Earth while citizens are in the process of realisation (anubhav-gami), every human unit from the person and the Tier-1 family council to the Tier-10 World Family Council is paired with a dedicated AI agent. Across all ten tiers, these agents act both as operational coordinators and as collective consistency mirrors: they place verified facts, discrepancies, and checkable causal logic in common view before all members of the family, cluster, committee, or council simultaneously.</a:t>
             </a:r>
           </a:p>
           <a:p/>
           <a:p>
             <a:r>
-              <a:t>At the individual and family level (10–12 members; AA pp. 14, 26, 65), the Personal Assistant and Family AI Agent help reflect on priya–hita–labha impulses, assess common and special aspirations (AA p. 112), track stock age against hoarding, and coordinate complementary household production without weighing individual labour shares (AA pp. 119–120). At Tiers 1 and 2, Cluster, Village Council, and five Committee Agents maintain the living village survey, link the five dimensions horizontally, and run the three-stage transition ledgers alongside the three-person exchange-reserve staff (AA pp. 125–145).</a:t>
+              <a:t>At the individual and Tier-1 family council level (parivar sabha, at least ten members; AA pp. 14, 26–28, 65, 125), the Personal Assistant and Family AI Agent help reflect on priya–hit–labh impulses, assess common and special aspirations (AA p. 112), track stock age against hoarding, and coordinate complementary household production without weighing individual labour shares (AA pp. 119–120). At Tier 2 (the ten-family cluster council, parivar samuh sabha; AA pp. 27, 125) and Tier 3 (the hundred-family village council, gram parivar sabha, which is the first tier to nominate the five committees; AA pp. 67, 125–145), the Cluster, Village Council, and five Committee Agents maintain the living village survey, link the five committees horizontally, monitor the four dimensions of justice (in character, behaviour, production, and exchange; AA pp. 140–143), and run the three-stage transition ledgers alongside the exchange-reserve's three-person staff (AA p. 138).</a:t>
             </a:r>
           </a:p>
           <a:p/>
           <a:p>
             <a:r>
-              <a:t>Across Tiers 3 to 10, federated Council and Committee Agents compute Leontief input–output chains and Ricardian fertility adjustments, match inter-regional surpluses and deficits at labour value (AA p. 72), coordinate small, medium and large industry (AA p. 115), and monitor planetary regeneration boundaries (MVD p. 268). At every tier, normative authority stays with the human council.</a:t>
+              <a:t>Across Tiers 4 to 10 (from the ten-village cluster to the continent and World Family Councils; AA pp. 27–30, 115, 126–127), federated Council and Committee Agents compute Leontief input–output chains and Ricardian fertility adjustments, match inter-regional surpluses and deficits at labour value (AA p. 72), coordinate small, medium and large industry (AA p. 115), and monitor planetary regeneration boundaries (MVD p. 268). This study's companion Technical Note on the Ten-Tier Agentic Infrastructure specifies the eight-block architecture, eighteen use cases, and four-phase Indian transition blueprint.</a:t>
             </a:r>
           </a:p>
         </p:txBody>
@@ -29036,7 +29036,7 @@
                 </a:solidFill>
                 <a:latin typeface="Calibri"/>
               </a:rPr>
-              <a:t>Fulfilment of relationships and accord with coexistence. Even if one person errs, a council cannot ignore facts and checkable logic visible in common view.</a:t>
+              <a:t>Fulfilment of relationships and accord with coexistence. When facts and checkable logic are visible in common view, peers can spot and correct individual errors.</a:t>
             </a:r>
           </a:p>
           <a:p>
@@ -29795,7 +29795,7 @@
                 </a:solidFill>
                 <a:latin typeface="Calibri"/>
               </a:rPr>
-              <a:t>Councils serve part-time while producing (AA p. 127) and reserves have 3 staff (p. 138); without agents, coordination forces a bureaucracy.</a:t>
+              <a:t>Councils serve part-time while producing (AA p. 127) and reserves average 3 staff (p. 138); without agents, coordination forces a bureaucracy.</a:t>
             </a:r>
           </a:p>
         </p:txBody>
@@ -32225,7 +32225,7 @@
                 </a:solidFill>
                 <a:latin typeface="Calibri"/>
               </a:rPr>
-              <a:t>Family (10–12 members)</a:t>
+              <a:t>Family (Tier 1, ≥10)</a:t>
             </a:r>
           </a:p>
         </p:txBody>
@@ -32430,7 +32430,7 @@
                 </a:solidFill>
                 <a:latin typeface="Calibri"/>
               </a:rPr>
-              <a:t>Family cluster (Tier 1)</a:t>
+              <a:t>Family cluster (Tier 2)</a:t>
             </a:r>
           </a:p>
         </p:txBody>
@@ -32591,7 +32591,7 @@
                 </a:solidFill>
                 <a:latin typeface="Calibri"/>
               </a:rPr>
-              <a:t>Village &amp; 5 committees</a:t>
+              <a:t>Village council (Tier 3)</a:t>
             </a:r>
           </a:p>
         </p:txBody>
@@ -32796,7 +32796,7 @@
                 </a:solidFill>
                 <a:latin typeface="Calibri"/>
               </a:rPr>
-              <a:t>Regional tiers (3–9)</a:t>
+              <a:t>Regional tiers (4–9)</a:t>
             </a:r>
           </a:p>
         </p:txBody>
@@ -36524,7 +36524,7 @@
                 </a:solidFill>
                 <a:latin typeface="Calibri"/>
               </a:rPr>
-              <a:t>Shared council views make drift, causal logic, and 3-stage ledgers visible to all peers at once, compelling collective self-correction across 10 tiers.</a:t>
+              <a:t>Shared council views make drift, causal logic, and 3-stage ledgers visible to all peers at once, supporting collective self-correction across 10 tiers.</a:t>
             </a:r>
           </a:p>
         </p:txBody>

</xml_diff>